<commit_message>
Add DKW decomposition slide and update deck
Add a slide decomposing the 10y move with DKW (expected real short
rate, real TP, expected inflation, inflation risk premium), show the
three-model TP comparison on the decomposition slide, and update the
summary, indicator, limitation and appendix slides accordingly.

Co-Authored-By: Claude Opus 5.5 <noreply@anthropic.com>
Claude-Session: https://claude.ai/code/session_01TCy2oBSRDZdisvwwxxfgzX
</commit_message>
<xml_diff>
--- a/slides/2026-10-03_us-treasury-vol-regime-change.pptx
+++ b/slides/2026-10-03_us-treasury-vol-regime-change.pptx
@@ -20,6 +20,7 @@
     <p:sldId id="886" r:id="rId20"/>
     <p:sldId id="887" r:id="rId21"/>
     <p:sldId id="888" r:id="rId22"/>
+    <p:sldId id="889" r:id="rId23"/>
     <p:sldId id="877" r:id="rId10"/>
   </p:sldIdLst>
   <p:sldSz cx="12192000" cy="6858000"/>
@@ -429,6 +430,269 @@
 </file>
 
 <file path=ppt/charts/chart2.xml><?xml version="1.0" encoding="utf-8"?>
+<c:chartSpace xmlns:c="http://schemas.openxmlformats.org/drawingml/2006/chart" xmlns:a="http://schemas.openxmlformats.org/drawingml/2006/main" xmlns:r="http://schemas.openxmlformats.org/officeDocument/2006/relationships">
+  <c:date1904 val="0"/>
+  <c:chart>
+    <c:title>
+      <c:tx>
+        <c:rich>
+          <a:bodyPr/>
+          <a:lstStyle/>
+          <a:p>
+            <a:r>
+              <a:rPr sz="1300" b="1">
+                <a:solidFill>
+                  <a:srgbClr val="234976"/>
+                </a:solidFill>
+              </a:rPr>
+              <a:t>DKW 10Y 各成分變動（bp）：7 月以來實質 TP 大於預期實質短率</a:t>
+            </a:r>
+          </a:p>
+        </c:rich>
+      </c:tx>
+      <c:layout/>
+      <c:overlay val="0"/>
+    </c:title>
+    <c:autoTitleDeleted val="0"/>
+    <c:plotArea>
+      <c:barChart>
+        <c:barDir val="col"/>
+        <c:grouping val="clustered"/>
+        <c:ser>
+          <c:idx val="0"/>
+          <c:order val="0"/>
+          <c:tx>
+            <c:strRef>
+              <c:f>Sheet1!$B$1</c:f>
+              <c:strCache>
+                <c:ptCount val="1"/>
+                <c:pt idx="0">
+                  <c:v>2025 年底 → 8/31</c:v>
+                </c:pt>
+              </c:strCache>
+            </c:strRef>
+          </c:tx>
+          <c:spPr>
+            <a:solidFill>
+              <a:srgbClr val="234976"/>
+            </a:solidFill>
+          </c:spPr>
+          <c:cat>
+            <c:strRef>
+              <c:f>Sheet1!$A$2:$A$5</c:f>
+              <c:strCache>
+                <c:ptCount val="4"/>
+                <c:pt idx="0">
+                  <c:v>預期實質短率</c:v>
+                </c:pt>
+                <c:pt idx="1">
+                  <c:v>實質 TP</c:v>
+                </c:pt>
+                <c:pt idx="2">
+                  <c:v>預期通膨</c:v>
+                </c:pt>
+                <c:pt idx="3">
+                  <c:v>通膨風險溢酬</c:v>
+                </c:pt>
+              </c:strCache>
+            </c:strRef>
+          </c:cat>
+          <c:val>
+            <c:numRef>
+              <c:f>Sheet1!$B$2:$B$5</c:f>
+              <c:numCache>
+                <c:formatCode>General</c:formatCode>
+                <c:ptCount val="4"/>
+                <c:pt idx="0">
+                  <c:v>25.4</c:v>
+                </c:pt>
+                <c:pt idx="1">
+                  <c:v>16.2</c:v>
+                </c:pt>
+                <c:pt idx="2">
+                  <c:v>12.0</c:v>
+                </c:pt>
+                <c:pt idx="3">
+                  <c:v>3.7</c:v>
+                </c:pt>
+              </c:numCache>
+            </c:numRef>
+          </c:val>
+        </c:ser>
+        <c:ser>
+          <c:idx val="1"/>
+          <c:order val="1"/>
+          <c:tx>
+            <c:strRef>
+              <c:f>Sheet1!$C$1</c:f>
+              <c:strCache>
+                <c:ptCount val="1"/>
+                <c:pt idx="0">
+                  <c:v>6/30 → 8/31</c:v>
+                </c:pt>
+              </c:strCache>
+            </c:strRef>
+          </c:tx>
+          <c:spPr>
+            <a:solidFill>
+              <a:srgbClr val="0065B2"/>
+            </a:solidFill>
+          </c:spPr>
+          <c:cat>
+            <c:strRef>
+              <c:f>Sheet1!$A$2:$A$5</c:f>
+              <c:strCache>
+                <c:ptCount val="4"/>
+                <c:pt idx="0">
+                  <c:v>預期實質短率</c:v>
+                </c:pt>
+                <c:pt idx="1">
+                  <c:v>實質 TP</c:v>
+                </c:pt>
+                <c:pt idx="2">
+                  <c:v>預期通膨</c:v>
+                </c:pt>
+                <c:pt idx="3">
+                  <c:v>通膨風險溢酬</c:v>
+                </c:pt>
+              </c:strCache>
+            </c:strRef>
+          </c:cat>
+          <c:val>
+            <c:numRef>
+              <c:f>Sheet1!$C$2:$C$5</c:f>
+              <c:numCache>
+                <c:formatCode>General</c:formatCode>
+                <c:ptCount val="4"/>
+                <c:pt idx="0">
+                  <c:v>10.4</c:v>
+                </c:pt>
+                <c:pt idx="1">
+                  <c:v>12.6</c:v>
+                </c:pt>
+                <c:pt idx="2">
+                  <c:v>7.9</c:v>
+                </c:pt>
+                <c:pt idx="3">
+                  <c:v>3.0</c:v>
+                </c:pt>
+              </c:numCache>
+            </c:numRef>
+          </c:val>
+        </c:ser>
+        <c:dLbls>
+          <c:numFmt formatCode="+0.0" sourceLinked="0"/>
+          <c:txPr>
+            <a:bodyPr/>
+            <a:lstStyle/>
+            <a:p>
+              <a:pPr>
+                <a:defRPr sz="1200" b="1">
+                  <a:solidFill>
+                    <a:srgbClr val="234976"/>
+                  </a:solidFill>
+                </a:defRPr>
+              </a:pPr>
+            </a:p>
+          </c:txPr>
+          <c:dLblPos val="outEnd"/>
+          <c:showLegendKey val="0"/>
+          <c:showVal val="1"/>
+          <c:showCatName val="0"/>
+          <c:showSerName val="0"/>
+          <c:showPercent val="0"/>
+          <c:showBubbleSize val="0"/>
+          <c:showLeaderLines val="1"/>
+        </c:dLbls>
+        <c:gapWidth val="60"/>
+        <c:overlap val="-10"/>
+        <c:axId val="-2068027336"/>
+        <c:axId val="-2113994440"/>
+      </c:barChart>
+      <c:catAx>
+        <c:axId val="-2068027336"/>
+        <c:scaling>
+          <c:orientation val="minMax"/>
+        </c:scaling>
+        <c:delete val="0"/>
+        <c:axPos val="b"/>
+        <c:majorTickMark val="out"/>
+        <c:minorTickMark val="none"/>
+        <c:tickLblPos val="nextTo"/>
+        <c:spPr>
+          <a:ln>
+            <a:solidFill>
+              <a:srgbClr val="BFBFBF"/>
+            </a:solidFill>
+          </a:ln>
+        </c:spPr>
+        <c:txPr>
+          <a:bodyPr/>
+          <a:lstStyle/>
+          <a:p>
+            <a:pPr>
+              <a:defRPr sz="1200"/>
+            </a:pPr>
+          </a:p>
+        </c:txPr>
+        <c:crossAx val="-2113994440"/>
+        <c:crosses val="autoZero"/>
+        <c:auto val="1"/>
+        <c:lblAlgn val="ctr"/>
+        <c:lblOffset val="100"/>
+        <c:noMultiLvlLbl val="0"/>
+      </c:catAx>
+      <c:valAx>
+        <c:axId val="-2113994440"/>
+        <c:scaling>
+          <c:max val="30.0"/>
+          <c:min val="0.0"/>
+        </c:scaling>
+        <c:delete/>
+        <c:axPos val="l"/>
+        <c:majorTickMark val="out"/>
+        <c:minorTickMark val="none"/>
+        <c:tickLblPos val="nextTo"/>
+        <c:crossAx val="-2068027336"/>
+        <c:crosses val="autoZero"/>
+      </c:valAx>
+    </c:plotArea>
+    <c:legend>
+      <c:legendPos val="b"/>
+      <c:overlay val="0"/>
+      <c:txPr>
+        <a:bodyPr/>
+        <a:lstStyle/>
+        <a:p>
+          <a:pPr>
+            <a:defRPr sz="1200"/>
+          </a:pPr>
+        </a:p>
+      </c:txPr>
+    </c:legend>
+    <c:dispBlanksAs val="gap"/>
+  </c:chart>
+  <c:txPr>
+    <a:bodyPr/>
+    <a:lstStyle/>
+    <a:p>
+      <a:pPr>
+        <a:defRPr sz="1200">
+          <a:solidFill>
+            <a:srgbClr val="595959"/>
+          </a:solidFill>
+        </a:defRPr>
+      </a:pPr>
+      <a:endParaRPr lang="en-US"/>
+    </a:p>
+  </c:txPr>
+  <c:externalData r:id="rId1">
+    <c:autoUpdate val="0"/>
+  </c:externalData>
+</c:chartSpace>
+</file>
+
+<file path=ppt/charts/chart3.xml><?xml version="1.0" encoding="utf-8"?>
 <c:chartSpace xmlns:c="http://schemas.openxmlformats.org/drawingml/2006/chart" xmlns:a="http://schemas.openxmlformats.org/drawingml/2006/main" xmlns:r="http://schemas.openxmlformats.org/officeDocument/2006/relationships">
   <c:date1904 val="0"/>
   <c:chart>
@@ -721,7 +985,7 @@
 </c:chartSpace>
 </file>
 
-<file path=ppt/charts/chart3.xml><?xml version="1.0" encoding="utf-8"?>
+<file path=ppt/charts/chart4.xml><?xml version="1.0" encoding="utf-8"?>
 <c:chartSpace xmlns:c="http://schemas.openxmlformats.org/drawingml/2006/chart" xmlns:a="http://schemas.openxmlformats.org/drawingml/2006/main" xmlns:r="http://schemas.openxmlformats.org/officeDocument/2006/relationships">
   <c:date1904 val="0"/>
   <c:chart>
@@ -1395,6 +1659,76 @@
           <a:p>
             <a:r>
               <a:t>CR 與 Kim-Wright 對 TP 份量差很多；兩者都顯示 7 月起 TP 持續上升。</a:t>
+            </a:r>
+          </a:p>
+        </p:txBody>
+      </p:sp>
+      <p:sp>
+        <p:nvSpPr>
+          <p:cNvPr id="4" name="Slide Number Placeholder 3"/>
+          <p:cNvSpPr>
+            <a:spLocks noGrp="1"/>
+          </p:cNvSpPr>
+          <p:nvPr>
+            <p:ph type="sldNum" idx="5" sz="quarter"/>
+          </p:nvPr>
+        </p:nvSpPr>
+        <p:spPr/>
+      </p:sp>
+    </p:spTree>
+  </p:cSld>
+  <p:clrMapOvr>
+    <a:masterClrMapping/>
+  </p:clrMapOvr>
+</p:notes>
+</file>
+
+<file path=ppt/notesSlides/notesSlide3.xml><?xml version="1.0" encoding="utf-8"?>
+<p:notes xmlns:a="http://schemas.openxmlformats.org/drawingml/2006/main" xmlns:p="http://schemas.openxmlformats.org/presentationml/2006/main" xmlns:r="http://schemas.openxmlformats.org/officeDocument/2006/relationships">
+  <p:cSld>
+    <p:spTree>
+      <p:nvGrpSpPr>
+        <p:cNvPr id="1" name=""/>
+        <p:cNvGrpSpPr/>
+        <p:nvPr/>
+      </p:nvGrpSpPr>
+      <p:grpSpPr>
+        <a:xfrm>
+          <a:off x="0" y="0"/>
+          <a:ext cx="0" cy="0"/>
+          <a:chOff x="0" y="0"/>
+          <a:chExt cx="0" cy="0"/>
+        </a:xfrm>
+      </p:grpSpPr>
+      <p:sp>
+        <p:nvSpPr>
+          <p:cNvPr id="2" name="Slide Image Placeholder 1"/>
+          <p:cNvSpPr>
+            <a:spLocks noGrp="1"/>
+          </p:cNvSpPr>
+          <p:nvPr>
+            <p:ph type="sldImg" idx="2"/>
+          </p:nvPr>
+        </p:nvSpPr>
+        <p:spPr/>
+      </p:sp>
+      <p:sp>
+        <p:nvSpPr>
+          <p:cNvPr id="3" name="Notes Placeholder 2"/>
+          <p:cNvSpPr>
+            <a:spLocks noGrp="1"/>
+          </p:cNvSpPr>
+          <p:nvPr>
+            <p:ph type="body" idx="3" sz="quarter"/>
+          </p:nvPr>
+        </p:nvSpPr>
+        <p:spPr/>
+        <p:txBody>
+          <a:bodyPr/>
+          <a:lstStyle/>
+          <a:p>
+            <a:r>
+              <a:t>DKW 把名目殖利率拆成四塊。實質部分（預期實質短率＋實質 TP）約 +42 bp，其中實質 TP 約 16 bp。原文用實質利率貢獻 120 bp 推論不是 TP，在 DKW 下站不住。</a:t>
             </a:r>
           </a:p>
         </p:txBody>
@@ -45293,6 +45627,532 @@
           <a:lstStyle/>
           <a:p>
             <a:r>
+              <a:t>用 Bloomberg 計算 RV、IV − RV 與事後 VRP，區分「TP 失序」與「單純補漲」</a:t>
+            </a:r>
+          </a:p>
+        </p:txBody>
+      </p:sp>
+      <p:sp>
+        <p:nvSpPr>
+          <p:cNvPr id="4" name="Title 3"/>
+          <p:cNvSpPr>
+            <a:spLocks noGrp="1"/>
+          </p:cNvSpPr>
+          <p:nvPr>
+            <p:ph type="title"/>
+          </p:nvPr>
+        </p:nvSpPr>
+        <p:spPr>
+          <a:xfrm>
+            <a:off x="411480" y="192024"/>
+            <a:ext cx="11329416" cy="548640"/>
+          </a:xfrm>
+        </p:spPr>
+        <p:txBody>
+          <a:bodyPr/>
+          <a:lstStyle/>
+          <a:p>
+            <a:r>
+              <a:t>檢驗與情境：由 IV − RV 決定結論</a:t>
+            </a:r>
+          </a:p>
+        </p:txBody>
+      </p:sp>
+      <p:sp>
+        <p:nvSpPr>
+          <p:cNvPr id="5" name="Rectangle 4"/>
+          <p:cNvSpPr/>
+          <p:nvPr/>
+        </p:nvSpPr>
+        <p:spPr>
+          <a:xfrm>
+            <a:off x="411480" y="1783080"/>
+            <a:ext cx="3931920" cy="2743200"/>
+          </a:xfrm>
+          <a:prstGeom prst="rect">
+            <a:avLst/>
+          </a:prstGeom>
+          <a:solidFill>
+            <a:srgbClr val="EEF3F8"/>
+          </a:solidFill>
+          <a:ln>
+            <a:noFill/>
+          </a:ln>
+          <a:effectLst/>
+        </p:spPr>
+        <p:style>
+          <a:lnRef idx="1">
+            <a:schemeClr val="accent1"/>
+          </a:lnRef>
+          <a:fillRef idx="3">
+            <a:schemeClr val="accent1"/>
+          </a:fillRef>
+          <a:effectRef idx="2">
+            <a:schemeClr val="accent1"/>
+          </a:effectRef>
+          <a:fontRef idx="minor">
+            <a:schemeClr val="lt1"/>
+          </a:fontRef>
+        </p:style>
+        <p:txBody>
+          <a:bodyPr rtlCol="0" anchor="ctr"/>
+          <a:lstStyle/>
+          <a:p>
+            <a:pPr algn="ctr"/>
+          </a:p>
+        </p:txBody>
+      </p:sp>
+      <p:sp>
+        <p:nvSpPr>
+          <p:cNvPr id="6" name="TextBox 5"/>
+          <p:cNvSpPr txBox="1"/>
+          <p:nvPr/>
+        </p:nvSpPr>
+        <p:spPr>
+          <a:xfrm>
+            <a:off x="594360" y="1920240"/>
+            <a:ext cx="3611880" cy="4114800"/>
+          </a:xfrm>
+          <a:prstGeom prst="rect">
+            <a:avLst/>
+          </a:prstGeom>
+          <a:noFill/>
+        </p:spPr>
+        <p:txBody>
+          <a:bodyPr wrap="square" lIns="45720" rIns="45720" anchor="t">
+            <a:spAutoFit/>
+          </a:bodyPr>
+          <a:lstStyle/>
+          <a:p>
+            <a:pPr algn="l"/>
+            <a:r>
+              <a:rPr b="1" sz="1800">
+                <a:solidFill>
+                  <a:srgbClr val="234976"/>
+                </a:solidFill>
+              </a:rPr>
+              <a:t>三個要回答的問題</a:t>
+            </a:r>
+          </a:p>
+          <a:p>
+            <a:pPr algn="l"/>
+            <a:r>
+              <a:rPr sz="1400">
+                <a:solidFill>
+                  <a:srgbClr val="1F1F1F"/>
+                </a:solidFill>
+              </a:rPr>
+              <a:t>1. 5–9 月 RV 到底高不高？IV − RV 是否真的被壓縮？</a:t>
+            </a:r>
+          </a:p>
+          <a:p>
+            <a:pPr algn="l"/>
+            <a:r>
+              <a:rPr sz="600">
+                <a:solidFill>
+                  <a:srgbClr val="1F1F1F"/>
+                </a:solidFill>
+              </a:rPr>
+              <a:t/>
+            </a:r>
+          </a:p>
+          <a:p>
+            <a:pPr algn="l"/>
+            <a:r>
+              <a:rPr sz="1400">
+                <a:solidFill>
+                  <a:srgbClr val="1F1F1F"/>
+                </a:solidFill>
+              </a:rPr>
+              <a:t>2. 9 月底到 10 月，IV 上升是在追 RV，還是明顯脫離 RV？</a:t>
+            </a:r>
+          </a:p>
+          <a:p>
+            <a:pPr algn="l"/>
+            <a:r>
+              <a:rPr sz="600">
+                <a:solidFill>
+                  <a:srgbClr val="1F1F1F"/>
+                </a:solidFill>
+              </a:rPr>
+              <a:t/>
+            </a:r>
+          </a:p>
+          <a:p>
+            <a:pPr algn="l"/>
+            <a:r>
+              <a:rPr sz="1400">
+                <a:solidFill>
+                  <a:srgbClr val="1F1F1F"/>
+                </a:solidFill>
+              </a:rPr>
+              <a:t>3. Payer Skew 是否同步變陡？</a:t>
+            </a:r>
+          </a:p>
+        </p:txBody>
+      </p:sp>
+      <p:graphicFrame>
+        <p:nvGraphicFramePr>
+          <p:cNvPr id="7" name="Table 6"/>
+          <p:cNvGraphicFramePr>
+            <a:graphicFrameLocks noGrp="1"/>
+          </p:cNvGraphicFramePr>
+          <p:nvPr/>
+        </p:nvGraphicFramePr>
+        <p:xfrm>
+          <a:off x="4617720" y="1783080"/>
+          <a:ext cx="7132320" cy="2880360"/>
+        </p:xfrm>
+        <a:graphic>
+          <a:graphicData uri="http://schemas.openxmlformats.org/drawingml/2006/table">
+            <a:tbl>
+              <a:tblPr firstRow="1" bandRow="1">
+                <a:tableStyleId>{5940675A-B579-460E-94D1-54222C63F5DA}</a:tableStyleId>
+              </a:tblPr>
+              <a:tblGrid>
+                <a:gridCol w="1463040"/>
+                <a:gridCol w="2103120"/>
+                <a:gridCol w="1371600"/>
+                <a:gridCol w="2194560"/>
+              </a:tblGrid>
+              <a:tr h="960120">
+                <a:tc>
+                  <a:txBody>
+                    <a:bodyPr wrap="square"/>
+                    <a:lstStyle/>
+                    <a:p>
+                      <a:r>
+                        <a:rPr b="1" sz="1300">
+                          <a:solidFill>
+                            <a:srgbClr val="FFFFFF"/>
+                          </a:solidFill>
+                        </a:rPr>
+                        <a:t>情境</a:t>
+                      </a:r>
+                    </a:p>
+                  </a:txBody>
+                  <a:tcPr marL="73152" marR="73152" marT="27432" marB="27432" anchor="ctr">
+                    <a:solidFill>
+                      <a:srgbClr val="234976"/>
+                    </a:solidFill>
+                  </a:tcPr>
+                </a:tc>
+                <a:tc>
+                  <a:txBody>
+                    <a:bodyPr wrap="square"/>
+                    <a:lstStyle/>
+                    <a:p>
+                      <a:r>
+                        <a:rPr b="1" sz="1300">
+                          <a:solidFill>
+                            <a:srgbClr val="FFFFFF"/>
+                          </a:solidFill>
+                        </a:rPr>
+                        <a:t>數據特徵</a:t>
+                      </a:r>
+                    </a:p>
+                  </a:txBody>
+                  <a:tcPr marL="73152" marR="73152" marT="27432" marB="27432" anchor="ctr">
+                    <a:solidFill>
+                      <a:srgbClr val="234976"/>
+                    </a:solidFill>
+                  </a:tcPr>
+                </a:tc>
+                <a:tc>
+                  <a:txBody>
+                    <a:bodyPr wrap="square"/>
+                    <a:lstStyle/>
+                    <a:p>
+                      <a:r>
+                        <a:rPr b="1" sz="1300">
+                          <a:solidFill>
+                            <a:srgbClr val="FFFFFF"/>
+                          </a:solidFill>
+                        </a:rPr>
+                        <a:t>判斷</a:t>
+                      </a:r>
+                    </a:p>
+                  </a:txBody>
+                  <a:tcPr marL="73152" marR="73152" marT="27432" marB="27432" anchor="ctr">
+                    <a:solidFill>
+                      <a:srgbClr val="234976"/>
+                    </a:solidFill>
+                  </a:tcPr>
+                </a:tc>
+                <a:tc>
+                  <a:txBody>
+                    <a:bodyPr wrap="square"/>
+                    <a:lstStyle/>
+                    <a:p>
+                      <a:r>
+                        <a:rPr b="1" sz="1300">
+                          <a:solidFill>
+                            <a:srgbClr val="FFFFFF"/>
+                          </a:solidFill>
+                        </a:rPr>
+                        <a:t>交易意涵</a:t>
+                      </a:r>
+                    </a:p>
+                  </a:txBody>
+                  <a:tcPr marL="73152" marR="73152" marT="27432" marB="27432" anchor="ctr">
+                    <a:solidFill>
+                      <a:srgbClr val="234976"/>
+                    </a:solidFill>
+                  </a:tcPr>
+                </a:tc>
+              </a:tr>
+              <a:tr h="960120">
+                <a:tc>
+                  <a:txBody>
+                    <a:bodyPr wrap="square"/>
+                    <a:lstStyle/>
+                    <a:p>
+                      <a:r>
+                        <a:rPr b="1" sz="1300">
+                          <a:solidFill>
+                            <a:srgbClr val="1F1F1F"/>
+                          </a:solidFill>
+                        </a:rPr>
+                        <a:t>A：進入 TP 失序期</a:t>
+                      </a:r>
+                    </a:p>
+                  </a:txBody>
+                  <a:tcPr marL="73152" marR="73152" marT="27432" marB="27432" anchor="ctr">
+                    <a:solidFill>
+                      <a:srgbClr val="FFFFFF"/>
+                    </a:solidFill>
+                  </a:tcPr>
+                </a:tc>
+                <a:tc>
+                  <a:txBody>
+                    <a:bodyPr wrap="square"/>
+                    <a:lstStyle/>
+                    <a:p>
+                      <a:r>
+                        <a:rPr sz="1300">
+                          <a:solidFill>
+                            <a:srgbClr val="1F1F1F"/>
+                          </a:solidFill>
+                        </a:rPr>
+                        <a:t>IV − RV 明顯擴大、Payer Skew 變陡、TP 加速</a:t>
+                      </a:r>
+                    </a:p>
+                  </a:txBody>
+                  <a:tcPr marL="73152" marR="73152" marT="27432" marB="27432" anchor="ctr">
+                    <a:solidFill>
+                      <a:srgbClr val="FFFFFF"/>
+                    </a:solidFill>
+                  </a:tcPr>
+                </a:tc>
+                <a:tc>
+                  <a:txBody>
+                    <a:bodyPr wrap="square"/>
+                    <a:lstStyle/>
+                    <a:p>
+                      <a:r>
+                        <a:rPr sz="1300">
+                          <a:solidFill>
+                            <a:srgbClr val="1F1F1F"/>
+                          </a:solidFill>
+                        </a:rPr>
+                        <a:t>Regime Change 已發生</a:t>
+                      </a:r>
+                    </a:p>
+                  </a:txBody>
+                  <a:tcPr marL="73152" marR="73152" marT="27432" marB="27432" anchor="ctr">
+                    <a:solidFill>
+                      <a:srgbClr val="FFFFFF"/>
+                    </a:solidFill>
+                  </a:tcPr>
+                </a:tc>
+                <a:tc>
+                  <a:txBody>
+                    <a:bodyPr wrap="square"/>
+                    <a:lstStyle/>
+                    <a:p>
+                      <a:r>
+                        <a:rPr sz="1300">
+                          <a:solidFill>
+                            <a:srgbClr val="1F1F1F"/>
+                          </a:solidFill>
+                        </a:rPr>
+                        <a:t>IV 易因恐慌避險偏貴；失序緩解後再評估系統性賣 Vol</a:t>
+                      </a:r>
+                    </a:p>
+                  </a:txBody>
+                  <a:tcPr marL="73152" marR="73152" marT="27432" marB="27432" anchor="ctr">
+                    <a:solidFill>
+                      <a:srgbClr val="FFFFFF"/>
+                    </a:solidFill>
+                  </a:tcPr>
+                </a:tc>
+              </a:tr>
+              <a:tr h="960120">
+                <a:tc>
+                  <a:txBody>
+                    <a:bodyPr wrap="square"/>
+                    <a:lstStyle/>
+                    <a:p>
+                      <a:r>
+                        <a:rPr b="1" sz="1300">
+                          <a:solidFill>
+                            <a:srgbClr val="1F1F1F"/>
+                          </a:solidFill>
+                        </a:rPr>
+                        <a:t>B：只是補漲</a:t>
+                      </a:r>
+                    </a:p>
+                  </a:txBody>
+                  <a:tcPr marL="73152" marR="73152" marT="27432" marB="27432" anchor="ctr">
+                    <a:solidFill>
+                      <a:srgbClr val="EEF3F8"/>
+                    </a:solidFill>
+                  </a:tcPr>
+                </a:tc>
+                <a:tc>
+                  <a:txBody>
+                    <a:bodyPr wrap="square"/>
+                    <a:lstStyle/>
+                    <a:p>
+                      <a:r>
+                        <a:rPr sz="1300">
+                          <a:solidFill>
+                            <a:srgbClr val="1F1F1F"/>
+                          </a:solidFill>
+                        </a:rPr>
+                        <a:t>IV 追上 RV、Skew 平穩</a:t>
+                      </a:r>
+                    </a:p>
+                  </a:txBody>
+                  <a:tcPr marL="73152" marR="73152" marT="27432" marB="27432" anchor="ctr">
+                    <a:solidFill>
+                      <a:srgbClr val="EEF3F8"/>
+                    </a:solidFill>
+                  </a:tcPr>
+                </a:tc>
+                <a:tc>
+                  <a:txBody>
+                    <a:bodyPr wrap="square"/>
+                    <a:lstStyle/>
+                    <a:p>
+                      <a:r>
+                        <a:rPr sz="1300">
+                          <a:solidFill>
+                            <a:srgbClr val="1F1F1F"/>
+                          </a:solidFill>
+                        </a:rPr>
+                        <a:t>尚未失序</a:t>
+                      </a:r>
+                    </a:p>
+                  </a:txBody>
+                  <a:tcPr marL="73152" marR="73152" marT="27432" marB="27432" anchor="ctr">
+                    <a:solidFill>
+                      <a:srgbClr val="EEF3F8"/>
+                    </a:solidFill>
+                  </a:tcPr>
+                </a:tc>
+                <a:tc>
+                  <a:txBody>
+                    <a:bodyPr wrap="square"/>
+                    <a:lstStyle/>
+                    <a:p>
+                      <a:r>
+                        <a:rPr sz="1300">
+                          <a:solidFill>
+                            <a:srgbClr val="1F1F1F"/>
+                          </a:solidFill>
+                        </a:rPr>
+                        <a:t>賣 Vol 的機會還沒到；追蹤 TP 上升速度</a:t>
+                      </a:r>
+                    </a:p>
+                  </a:txBody>
+                  <a:tcPr marL="73152" marR="73152" marT="27432" marB="27432" anchor="ctr">
+                    <a:solidFill>
+                      <a:srgbClr val="EEF3F8"/>
+                    </a:solidFill>
+                  </a:tcPr>
+                </a:tc>
+              </a:tr>
+            </a:tbl>
+          </a:graphicData>
+        </a:graphic>
+      </p:graphicFrame>
+      <p:sp>
+        <p:nvSpPr>
+          <p:cNvPr id="8" name="TextBox 7"/>
+          <p:cNvSpPr txBox="1"/>
+          <p:nvPr/>
+        </p:nvSpPr>
+        <p:spPr>
+          <a:xfrm>
+            <a:off x="4617720" y="4892040"/>
+            <a:ext cx="7132320" cy="1188720"/>
+          </a:xfrm>
+          <a:prstGeom prst="rect">
+            <a:avLst/>
+          </a:prstGeom>
+          <a:noFill/>
+        </p:spPr>
+        <p:txBody>
+          <a:bodyPr wrap="square" lIns="45720" rIns="45720" anchor="t">
+            <a:spAutoFit/>
+          </a:bodyPr>
+          <a:lstStyle/>
+          <a:p>
+            <a:pPr algn="l"/>
+            <a:r>
+              <a:rPr b="1" sz="1400">
+                <a:solidFill>
+                  <a:srgbClr val="E83F0A"/>
+                </a:solidFill>
+              </a:rPr>
+              <a:t>兩種情境都要留意：</a:t>
+            </a:r>
+            <a:r>
+              <a:rPr sz="1400">
+                <a:solidFill>
+                  <a:srgbClr val="1F1F1F"/>
+                </a:solidFill>
+              </a:rPr>
+              <a:t>TP 主導期的高 VRP 可能是對肥尾風險的合理補償，而不是「偏貴」；在自我強化的環境系統性賣 Vol，風險不對稱。</a:t>
+            </a:r>
+          </a:p>
+        </p:txBody>
+      </p:sp>
+    </p:spTree>
+  </p:cSld>
+  <p:clrMapOvr>
+    <a:masterClrMapping/>
+  </p:clrMapOvr>
+</p:sld>
+</file>
+
+<file path=ppt/slides/slide11.xml><?xml version="1.0" encoding="utf-8"?>
+<p:sld xmlns:a="http://schemas.openxmlformats.org/drawingml/2006/main" xmlns:p="http://schemas.openxmlformats.org/presentationml/2006/main" xmlns:r="http://schemas.openxmlformats.org/officeDocument/2006/relationships">
+  <p:cSld>
+    <p:spTree>
+      <p:nvGrpSpPr>
+        <p:cNvPr id="1" name=""/>
+        <p:cNvGrpSpPr/>
+        <p:nvPr/>
+      </p:nvGrpSpPr>
+      <p:grpSpPr/>
+      <p:sp>
+        <p:nvSpPr>
+          <p:cNvPr id="3" name="Text Placeholder 2"/>
+          <p:cNvSpPr>
+            <a:spLocks noGrp="1"/>
+          </p:cNvSpPr>
+          <p:nvPr>
+            <p:ph type="body" idx="15" sz="quarter"/>
+          </p:nvPr>
+        </p:nvSpPr>
+        <p:spPr/>
+        <p:txBody>
+          <a:bodyPr/>
+          <a:lstStyle/>
+          <a:p>
+            <a:r>
               <a:t>追蹤 TP 的速度、IV − RV、Payer Skew 與 AI 發行人 CDS，判斷有序是否轉為失序</a:t>
             </a:r>
           </a:p>
@@ -45445,7 +46305,7 @@
                             <a:srgbClr val="1F1F1F"/>
                           </a:solidFill>
                         </a:rPr>
-                        <a:t>Kim-Wright、ACM 10Y TP</a:t>
+                        <a:t>DKW（主）、Kim-Wright、ACM 10Y TP</a:t>
                       </a:r>
                     </a:p>
                   </a:txBody>
@@ -45977,6 +46837,17 @@
                   <a:srgbClr val="1F1F1F"/>
                 </a:solidFill>
               </a:rPr>
+              <a:t>• DKW 每月更新，目前只到 8/31，不含 9 月。</a:t>
+            </a:r>
+          </a:p>
+          <a:p>
+            <a:pPr algn="l"/>
+            <a:r>
+              <a:rPr sz="1300">
+                <a:solidFill>
+                  <a:srgbClr val="1F1F1F"/>
+                </a:solidFill>
+              </a:rPr>
               <a:t>• CDS 表只有單一時點；「債務」可能含租賃。</a:t>
             </a:r>
           </a:p>
@@ -46001,7 +46872,7 @@
 </p:sld>
 </file>
 
-<file path=ppt/slides/slide11.xml><?xml version="1.0" encoding="utf-8"?>
+<file path=ppt/slides/slide12.xml><?xml version="1.0" encoding="utf-8"?>
 <p:sld xmlns:a="http://schemas.openxmlformats.org/drawingml/2006/main" xmlns:p="http://schemas.openxmlformats.org/presentationml/2006/main" xmlns:r="http://schemas.openxmlformats.org/officeDocument/2006/relationships">
   <p:cSld>
     <p:spTree>
@@ -46422,7 +47293,7 @@
 </p:sld>
 </file>
 
-<file path=ppt/slides/slide12.xml><?xml version="1.0" encoding="utf-8"?>
+<file path=ppt/slides/slide13.xml><?xml version="1.0" encoding="utf-8"?>
 <p:sld xmlns:a="http://schemas.openxmlformats.org/drawingml/2006/main" xmlns:p="http://schemas.openxmlformats.org/presentationml/2006/main" xmlns:r="http://schemas.openxmlformats.org/officeDocument/2006/relationships">
   <p:cSld>
     <p:spTree>
@@ -46448,7 +47319,7 @@
           <a:lstStyle/>
           <a:p>
             <a:r>
-              <a:t>原文適合當作值得驗證的假說；部分論點與 Kim-Wright 數據不一致</a:t>
+              <a:t>原文適合當作值得驗證的假說；部分論點與 DKW、Kim-Wright 數據不一致</a:t>
             </a:r>
           </a:p>
         </p:txBody>
@@ -46665,7 +47536,7 @@
                             <a:srgbClr val="1F1F1F"/>
                           </a:solidFill>
                         </a:rPr>
-                        <a:t>存疑</a:t>
+                        <a:t>不成立</a:t>
                       </a:r>
                     </a:p>
                   </a:txBody>
@@ -46686,7 +47557,7 @@
                             <a:srgbClr val="1F1F1F"/>
                           </a:solidFill>
                         </a:rPr>
-                        <a:t>TIPS 實質殖利率含實質 TP；Kim-Wright 顯示 TP 今年以來約 +45 bp</a:t>
+                        <a:t>DKW：實質部分 +42 bp 中實質 TP 約 +16 bp（近四成）；Kim-Wright TP 至 9/25 約 +45 bp</a:t>
                       </a:r>
                     </a:p>
                   </a:txBody>
@@ -46751,7 +47622,7 @@
                             <a:srgbClr val="1F1F1F"/>
                           </a:solidFill>
                         </a:rPr>
-                        <a:t>Kim-Wright 與 CR 都顯示 TP 從 7 月起持續上升</a:t>
+                        <a:t>DKW、Kim-Wright、CR 都顯示 TP 從 7 月起持續上升</a:t>
                       </a:r>
                     </a:p>
                   </a:txBody>
@@ -46969,7 +47840,7 @@
 </p:sld>
 </file>
 
-<file path=ppt/slides/slide13.xml><?xml version="1.0" encoding="utf-8"?>
+<file path=ppt/slides/slide14.xml><?xml version="1.0" encoding="utf-8"?>
 <p:sld xmlns:a="http://schemas.openxmlformats.org/drawingml/2006/main" xmlns:r="http://schemas.openxmlformats.org/officeDocument/2006/relationships" xmlns:p="http://schemas.openxmlformats.org/presentationml/2006/main">
   <p:cSld>
     <p:spTree>
@@ -47039,7 +47910,7 @@
             </a:r>
             <a:r>
               <a:rPr sz="1500"/>
-              <a:t>：依 Kim-Wright，10Y 今年的上升約四成來自 TP；只是過程緩慢、有序，沒有觸發恐慌性凸性避險，IV 因此停在低檔</a:t>
+              <a:t>：依 DKW，10Y 今年到 8 月的上升約三成五來自 TP，「實質利率」上升裡近四成是實質 TP；只是過程有序，沒有觸發恐慌性凸性避險，IV 因此停在低檔</a:t>
             </a:r>
           </a:p>
           <a:p>
@@ -48213,7 +49084,7 @@
         </p:nvGraphicFramePr>
         <p:xfrm>
           <a:off x="7635240" y="1783080"/>
-          <a:ext cx="4114800" cy="2057400"/>
+          <a:ext cx="4114800" cy="1645920"/>
         </p:xfrm>
         <a:graphic>
           <a:graphicData uri="http://schemas.openxmlformats.org/drawingml/2006/table">
@@ -48222,8 +49093,7 @@
                 <a:tableStyleId>{5940675A-B579-460E-94D1-54222C63F5DA}</a:tableStyleId>
               </a:tblPr>
               <a:tblGrid>
-                <a:gridCol w="1371600"/>
-                <a:gridCol w="1371600"/>
+                <a:gridCol w="2743200"/>
                 <a:gridCol w="1371600"/>
               </a:tblGrid>
               <a:tr h="411480">
@@ -48238,7 +49108,7 @@
                             <a:srgbClr val="FFFFFF"/>
                           </a:solidFill>
                         </a:rPr>
-                        <a:t>到 8 月底</a:t>
+                        <a:t>名目 TP（年底→8/31）</a:t>
                       </a:r>
                     </a:p>
                   </a:txBody>
@@ -48259,28 +49129,7 @@
                             <a:srgbClr val="FFFFFF"/>
                           </a:solidFill>
                         </a:rPr>
-                        <a:t>CR 模型</a:t>
-                      </a:r>
-                    </a:p>
-                  </a:txBody>
-                  <a:tcPr marL="73152" marR="73152" marT="27432" marB="27432" anchor="ctr">
-                    <a:solidFill>
-                      <a:srgbClr val="234976"/>
-                    </a:solidFill>
-                  </a:tcPr>
-                </a:tc>
-                <a:tc>
-                  <a:txBody>
-                    <a:bodyPr wrap="square"/>
-                    <a:lstStyle/>
-                    <a:p>
-                      <a:r>
-                        <a:rPr b="1" sz="1300">
-                          <a:solidFill>
-                            <a:srgbClr val="FFFFFF"/>
-                          </a:solidFill>
-                        </a:rPr>
-                        <a:t>Kim-Wright</a:t>
+                        <a:t>bp</a:t>
                       </a:r>
                     </a:p>
                   </a:txBody>
@@ -48303,7 +49152,7 @@
                             <a:srgbClr val="1F1F1F"/>
                           </a:solidFill>
                         </a:rPr>
-                        <a:t>10Y 累計</a:t>
+                        <a:t>CR 模型（目測）</a:t>
                       </a:r>
                     </a:p>
                   </a:txBody>
@@ -48324,28 +49173,7 @@
                             <a:srgbClr val="1F1F1F"/>
                           </a:solidFill>
                         </a:rPr>
-                        <a:t>約 +71 bp</a:t>
-                      </a:r>
-                    </a:p>
-                  </a:txBody>
-                  <a:tcPr marL="73152" marR="73152" marT="27432" marB="27432" anchor="ctr">
-                    <a:solidFill>
-                      <a:srgbClr val="FFFFFF"/>
-                    </a:solidFill>
-                  </a:tcPr>
-                </a:tc>
-                <a:tc>
-                  <a:txBody>
-                    <a:bodyPr wrap="square"/>
-                    <a:lstStyle/>
-                    <a:p>
-                      <a:r>
-                        <a:rPr sz="1300">
-                          <a:solidFill>
-                            <a:srgbClr val="1F1F1F"/>
-                          </a:solidFill>
-                        </a:rPr>
-                        <a:t>—</a:t>
+                        <a:t>約 +18</a:t>
                       </a:r>
                     </a:p>
                   </a:txBody>
@@ -48368,7 +49196,7 @@
                             <a:srgbClr val="1F1F1F"/>
                           </a:solidFill>
                         </a:rPr>
-                        <a:t>預期短率</a:t>
+                        <a:t>DKW（主軸）</a:t>
                       </a:r>
                     </a:p>
                   </a:txBody>
@@ -48386,31 +49214,10 @@
                       <a:r>
                         <a:rPr sz="1300">
                           <a:solidFill>
-                            <a:srgbClr val="1F1F1F"/>
+                            <a:srgbClr val="E83F0A"/>
                           </a:solidFill>
                         </a:rPr>
-                        <a:t>約 +53 bp</a:t>
-                      </a:r>
-                    </a:p>
-                  </a:txBody>
-                  <a:tcPr marL="73152" marR="73152" marT="27432" marB="27432" anchor="ctr">
-                    <a:solidFill>
-                      <a:srgbClr val="EEF3F8"/>
-                    </a:solidFill>
-                  </a:tcPr>
-                </a:tc>
-                <a:tc>
-                  <a:txBody>
-                    <a:bodyPr wrap="square"/>
-                    <a:lstStyle/>
-                    <a:p>
-                      <a:r>
-                        <a:rPr sz="1300">
-                          <a:solidFill>
-                            <a:srgbClr val="1F1F1F"/>
-                          </a:solidFill>
-                        </a:rPr>
-                        <a:t>—</a:t>
+                        <a:t>+20</a:t>
                       </a:r>
                     </a:p>
                   </a:txBody>
@@ -48433,7 +49240,7 @@
                             <a:srgbClr val="1F1F1F"/>
                           </a:solidFill>
                         </a:rPr>
-                        <a:t>TP</a:t>
+                        <a:t>Kim-Wright</a:t>
                       </a:r>
                     </a:p>
                   </a:txBody>
@@ -48451,102 +49258,16 @@
                       <a:r>
                         <a:rPr sz="1300">
                           <a:solidFill>
-                            <a:srgbClr val="E83F0A"/>
+                            <a:srgbClr val="1F1F1F"/>
                           </a:solidFill>
                         </a:rPr>
-                        <a:t>約 +18 bp</a:t>
+                        <a:t>+31</a:t>
                       </a:r>
                     </a:p>
                   </a:txBody>
                   <a:tcPr marL="73152" marR="73152" marT="27432" marB="27432" anchor="ctr">
                     <a:solidFill>
                       <a:srgbClr val="FFFFFF"/>
-                    </a:solidFill>
-                  </a:tcPr>
-                </a:tc>
-                <a:tc>
-                  <a:txBody>
-                    <a:bodyPr wrap="square"/>
-                    <a:lstStyle/>
-                    <a:p>
-                      <a:r>
-                        <a:rPr sz="1300">
-                          <a:solidFill>
-                            <a:srgbClr val="E83F0A"/>
-                          </a:solidFill>
-                        </a:rPr>
-                        <a:t>約 +31 bp</a:t>
-                      </a:r>
-                    </a:p>
-                  </a:txBody>
-                  <a:tcPr marL="73152" marR="73152" marT="27432" marB="27432" anchor="ctr">
-                    <a:solidFill>
-                      <a:srgbClr val="FFFFFF"/>
-                    </a:solidFill>
-                  </a:tcPr>
-                </a:tc>
-              </a:tr>
-              <a:tr h="411480">
-                <a:tc>
-                  <a:txBody>
-                    <a:bodyPr wrap="square"/>
-                    <a:lstStyle/>
-                    <a:p>
-                      <a:r>
-                        <a:rPr b="1" sz="1300">
-                          <a:solidFill>
-                            <a:srgbClr val="1F1F1F"/>
-                          </a:solidFill>
-                        </a:rPr>
-                        <a:t>TP 佔比</a:t>
-                      </a:r>
-                    </a:p>
-                  </a:txBody>
-                  <a:tcPr marL="73152" marR="73152" marT="27432" marB="27432" anchor="ctr">
-                    <a:solidFill>
-                      <a:srgbClr val="EEF3F8"/>
-                    </a:solidFill>
-                  </a:tcPr>
-                </a:tc>
-                <a:tc>
-                  <a:txBody>
-                    <a:bodyPr wrap="square"/>
-                    <a:lstStyle/>
-                    <a:p>
-                      <a:r>
-                        <a:rPr sz="1300">
-                          <a:solidFill>
-                            <a:srgbClr val="E83F0A"/>
-                          </a:solidFill>
-                        </a:rPr>
-                        <a:t>約四分之一</a:t>
-                      </a:r>
-                    </a:p>
-                  </a:txBody>
-                  <a:tcPr marL="73152" marR="73152" marT="27432" marB="27432" anchor="ctr">
-                    <a:solidFill>
-                      <a:srgbClr val="EEF3F8"/>
-                    </a:solidFill>
-                  </a:tcPr>
-                </a:tc>
-                <a:tc>
-                  <a:txBody>
-                    <a:bodyPr wrap="square"/>
-                    <a:lstStyle/>
-                    <a:p>
-                      <a:r>
-                        <a:rPr sz="1300">
-                          <a:solidFill>
-                            <a:srgbClr val="E83F0A"/>
-                          </a:solidFill>
-                        </a:rPr>
-                        <a:t>約四成</a:t>
-                      </a:r>
-                    </a:p>
-                  </a:txBody>
-                  <a:tcPr marL="73152" marR="73152" marT="27432" marB="27432" anchor="ctr">
-                    <a:solidFill>
-                      <a:srgbClr val="EEF3F8"/>
                     </a:solidFill>
                   </a:tcPr>
                 </a:tc>
@@ -48563,8 +49284,8 @@
         </p:nvSpPr>
         <p:spPr>
           <a:xfrm>
-            <a:off x="7635240" y="4069080"/>
-            <a:ext cx="4114800" cy="2103120"/>
+            <a:off x="7635240" y="3611880"/>
+            <a:ext cx="4114800" cy="2560320"/>
           </a:xfrm>
           <a:prstGeom prst="rect">
             <a:avLst/>
@@ -48584,7 +49305,7 @@
                   <a:srgbClr val="1F1F1F"/>
                 </a:solidFill>
               </a:rPr>
-              <a:t>市場說「這輪拋售不是 TP」，依據是實質利率貢獻約 120 bp。</a:t>
+              <a:t>三個模型都同意：預期是主力，TP 是第二大來源，而且 7 月起持續上升。</a:t>
             </a:r>
           </a:p>
           <a:p>
@@ -48595,7 +49316,7 @@
                   <a:srgbClr val="1F1F1F"/>
                 </a:solidFill>
               </a:rPr>
-              <a:t>但 TIPS 實質殖利率本身也含實質期限溢酬，這個拆法無法排除 TP 的角色。</a:t>
+              <a:t>DKW 每月更新、只到 8/31；9 月以後暫用日資料的 Kim-Wright，至 9/25 已 +45 bp。</a:t>
             </a:r>
           </a:p>
           <a:p>
@@ -48620,6 +49341,174 @@
 </file>
 
 <file path=ppt/slides/slide5.xml><?xml version="1.0" encoding="utf-8"?>
+<p:sld xmlns:a="http://schemas.openxmlformats.org/drawingml/2006/main" xmlns:p="http://schemas.openxmlformats.org/presentationml/2006/main" xmlns:r="http://schemas.openxmlformats.org/officeDocument/2006/relationships">
+  <p:cSld>
+    <p:spTree>
+      <p:nvGrpSpPr>
+        <p:cNvPr id="1" name=""/>
+        <p:cNvGrpSpPr/>
+        <p:nvPr/>
+      </p:nvGrpSpPr>
+      <p:grpSpPr/>
+      <p:sp>
+        <p:nvSpPr>
+          <p:cNvPr id="2" name="Content Placeholder 1"/>
+          <p:cNvSpPr>
+            <a:spLocks noGrp="1"/>
+          </p:cNvSpPr>
+          <p:nvPr>
+            <p:ph idx="2" sz="half"/>
+          </p:nvPr>
+        </p:nvSpPr>
+        <p:spPr>
+          <a:xfrm>
+            <a:off x="7635240" y="1783080"/>
+            <a:ext cx="4114800" cy="4389120"/>
+          </a:xfrm>
+        </p:spPr>
+        <p:txBody>
+          <a:bodyPr wrap="square"/>
+          <a:lstStyle/>
+          <a:p>
+            <a:r>
+              <a:rPr b="1" sz="1400"/>
+              <a:t>實質部分 +42 bp 怎麼拆</a:t>
+            </a:r>
+          </a:p>
+          <a:p>
+            <a:pPr>
+              <a:buFont typeface="+mj-lt"/>
+              <a:buAutoNum type="arabicPeriod"/>
+            </a:pPr>
+            <a:r>
+              <a:rPr b="1" sz="1400"/>
+              <a:t>預期實質短率 +25 bp</a:t>
+            </a:r>
+            <a:r>
+              <a:rPr sz="1400"/>
+              <a:t>：政策路徑與 r* 的預期，原文說的主力</a:t>
+            </a:r>
+          </a:p>
+          <a:p>
+            <a:pPr>
+              <a:buFont typeface="+mj-lt"/>
+              <a:buAutoNum type="arabicPeriod"/>
+            </a:pPr>
+            <a:r>
+              <a:rPr b="1" sz="1400"/>
+              <a:t>實質 TP +16 bp</a:t>
+            </a:r>
+            <a:r>
+              <a:rPr sz="1400"/>
+              <a:t>：約佔實質部分的 39%，原文的拆法看不到這一塊</a:t>
+            </a:r>
+          </a:p>
+          <a:p>
+            <a:r>
+              <a:rPr b="1" sz="1400"/>
+              <a:t>7 月以來</a:t>
+            </a:r>
+          </a:p>
+          <a:p>
+            <a:pPr marL="0" indent="0">
+              <a:buNone/>
+            </a:pPr>
+            <a:r>
+              <a:rPr sz="1400"/>
+              <a:t>6/30 → 8/31 名目 TP +15 bp，佔名目上升約四成；實質 TP（+13）大於預期實質短率（+10）。</a:t>
+            </a:r>
+          </a:p>
+          <a:p>
+            <a:r>
+              <a:rPr b="1" sz="1400"/>
+              <a:t>其他</a:t>
+            </a:r>
+          </a:p>
+          <a:p>
+            <a:pPr marL="0" indent="0">
+              <a:buNone/>
+            </a:pPr>
+            <a:r>
+              <a:rPr sz="1400"/>
+              <a:t>預期通膨今年到 8 月 +12 bp；DKW 尚未涵蓋 9 月升息後的變化。</a:t>
+            </a:r>
+          </a:p>
+        </p:txBody>
+      </p:sp>
+      <p:sp>
+        <p:nvSpPr>
+          <p:cNvPr id="3" name="Text Placeholder 2"/>
+          <p:cNvSpPr>
+            <a:spLocks noGrp="1"/>
+          </p:cNvSpPr>
+          <p:nvPr>
+            <p:ph type="body" idx="15" sz="quarter"/>
+          </p:nvPr>
+        </p:nvSpPr>
+        <p:spPr/>
+        <p:txBody>
+          <a:bodyPr/>
+          <a:lstStyle/>
+          <a:p>
+            <a:r>
+              <a:t>10Y 今年到 8 月 +57 bp：預期實質短率 +25、實質 TP +16、預期通膨 +12</a:t>
+            </a:r>
+          </a:p>
+        </p:txBody>
+      </p:sp>
+      <p:sp>
+        <p:nvSpPr>
+          <p:cNvPr id="4" name="Title 3"/>
+          <p:cNvSpPr>
+            <a:spLocks noGrp="1"/>
+          </p:cNvSpPr>
+          <p:nvPr>
+            <p:ph type="title"/>
+          </p:nvPr>
+        </p:nvSpPr>
+        <p:spPr>
+          <a:xfrm>
+            <a:off x="411480" y="192024"/>
+            <a:ext cx="11329416" cy="548640"/>
+          </a:xfrm>
+        </p:spPr>
+        <p:txBody>
+          <a:bodyPr/>
+          <a:lstStyle/>
+          <a:p>
+            <a:r>
+              <a:t>DKW：「實質利率」上升裡，近四成是實質 TP</a:t>
+            </a:r>
+          </a:p>
+        </p:txBody>
+      </p:sp>
+      <p:graphicFrame>
+        <p:nvGraphicFramePr>
+          <p:cNvPr id="5" name="Chart 4"/>
+          <p:cNvGraphicFramePr>
+            <a:graphicFrameLocks noGrp="1"/>
+          </p:cNvGraphicFramePr>
+          <p:nvPr/>
+        </p:nvGraphicFramePr>
+        <p:xfrm>
+          <a:off x="411480" y="1737360"/>
+          <a:ext cx="6949440" cy="4434840"/>
+        </p:xfrm>
+        <a:graphic>
+          <a:graphicData uri="http://schemas.openxmlformats.org/drawingml/2006/chart">
+            <c:chart xmlns:c="http://schemas.openxmlformats.org/drawingml/2006/chart" r:id="rId3"/>
+          </a:graphicData>
+        </a:graphic>
+      </p:graphicFrame>
+    </p:spTree>
+  </p:cSld>
+  <p:clrMapOvr>
+    <a:masterClrMapping/>
+  </p:clrMapOvr>
+</p:sld>
+</file>
+
+<file path=ppt/slides/slide6.xml><?xml version="1.0" encoding="utf-8"?>
 <p:sld xmlns:a="http://schemas.openxmlformats.org/drawingml/2006/main" xmlns:p="http://schemas.openxmlformats.org/presentationml/2006/main" xmlns:r="http://schemas.openxmlformats.org/officeDocument/2006/relationships">
   <p:cSld>
     <p:spTree>
@@ -49288,7 +50177,7 @@
 </p:sld>
 </file>
 
-<file path=ppt/slides/slide6.xml><?xml version="1.0" encoding="utf-8"?>
+<file path=ppt/slides/slide7.xml><?xml version="1.0" encoding="utf-8"?>
 <p:sld xmlns:a="http://schemas.openxmlformats.org/drawingml/2006/main" xmlns:p="http://schemas.openxmlformats.org/presentationml/2006/main" xmlns:r="http://schemas.openxmlformats.org/officeDocument/2006/relationships">
   <p:cSld>
     <p:spTree>
@@ -49441,7 +50330,7 @@
 </p:sld>
 </file>
 
-<file path=ppt/slides/slide7.xml><?xml version="1.0" encoding="utf-8"?>
+<file path=ppt/slides/slide8.xml><?xml version="1.0" encoding="utf-8"?>
 <p:sld xmlns:a="http://schemas.openxmlformats.org/drawingml/2006/main" xmlns:p="http://schemas.openxmlformats.org/presentationml/2006/main" xmlns:r="http://schemas.openxmlformats.org/officeDocument/2006/relationships">
   <p:cSld>
     <p:spTree>
@@ -50575,7 +51464,7 @@
 </p:sld>
 </file>
 
-<file path=ppt/slides/slide8.xml><?xml version="1.0" encoding="utf-8"?>
+<file path=ppt/slides/slide9.xml><?xml version="1.0" encoding="utf-8"?>
 <p:sld xmlns:a="http://schemas.openxmlformats.org/drawingml/2006/main" xmlns:p="http://schemas.openxmlformats.org/presentationml/2006/main" xmlns:r="http://schemas.openxmlformats.org/officeDocument/2006/relationships">
   <p:cSld>
     <p:spTree>
@@ -50749,532 +51638,6 @@
           </a:graphicData>
         </a:graphic>
       </p:graphicFrame>
-    </p:spTree>
-  </p:cSld>
-  <p:clrMapOvr>
-    <a:masterClrMapping/>
-  </p:clrMapOvr>
-</p:sld>
-</file>
-
-<file path=ppt/slides/slide9.xml><?xml version="1.0" encoding="utf-8"?>
-<p:sld xmlns:a="http://schemas.openxmlformats.org/drawingml/2006/main" xmlns:p="http://schemas.openxmlformats.org/presentationml/2006/main" xmlns:r="http://schemas.openxmlformats.org/officeDocument/2006/relationships">
-  <p:cSld>
-    <p:spTree>
-      <p:nvGrpSpPr>
-        <p:cNvPr id="1" name=""/>
-        <p:cNvGrpSpPr/>
-        <p:nvPr/>
-      </p:nvGrpSpPr>
-      <p:grpSpPr/>
-      <p:sp>
-        <p:nvSpPr>
-          <p:cNvPr id="3" name="Text Placeholder 2"/>
-          <p:cNvSpPr>
-            <a:spLocks noGrp="1"/>
-          </p:cNvSpPr>
-          <p:nvPr>
-            <p:ph type="body" idx="15" sz="quarter"/>
-          </p:nvPr>
-        </p:nvSpPr>
-        <p:spPr/>
-        <p:txBody>
-          <a:bodyPr/>
-          <a:lstStyle/>
-          <a:p>
-            <a:r>
-              <a:t>用 Bloomberg 計算 RV、IV − RV 與事後 VRP，區分「TP 失序」與「單純補漲」</a:t>
-            </a:r>
-          </a:p>
-        </p:txBody>
-      </p:sp>
-      <p:sp>
-        <p:nvSpPr>
-          <p:cNvPr id="4" name="Title 3"/>
-          <p:cNvSpPr>
-            <a:spLocks noGrp="1"/>
-          </p:cNvSpPr>
-          <p:nvPr>
-            <p:ph type="title"/>
-          </p:nvPr>
-        </p:nvSpPr>
-        <p:spPr>
-          <a:xfrm>
-            <a:off x="411480" y="192024"/>
-            <a:ext cx="11329416" cy="548640"/>
-          </a:xfrm>
-        </p:spPr>
-        <p:txBody>
-          <a:bodyPr/>
-          <a:lstStyle/>
-          <a:p>
-            <a:r>
-              <a:t>檢驗與情境：由 IV − RV 決定結論</a:t>
-            </a:r>
-          </a:p>
-        </p:txBody>
-      </p:sp>
-      <p:sp>
-        <p:nvSpPr>
-          <p:cNvPr id="5" name="Rectangle 4"/>
-          <p:cNvSpPr/>
-          <p:nvPr/>
-        </p:nvSpPr>
-        <p:spPr>
-          <a:xfrm>
-            <a:off x="411480" y="1783080"/>
-            <a:ext cx="3931920" cy="2743200"/>
-          </a:xfrm>
-          <a:prstGeom prst="rect">
-            <a:avLst/>
-          </a:prstGeom>
-          <a:solidFill>
-            <a:srgbClr val="EEF3F8"/>
-          </a:solidFill>
-          <a:ln>
-            <a:noFill/>
-          </a:ln>
-          <a:effectLst/>
-        </p:spPr>
-        <p:style>
-          <a:lnRef idx="1">
-            <a:schemeClr val="accent1"/>
-          </a:lnRef>
-          <a:fillRef idx="3">
-            <a:schemeClr val="accent1"/>
-          </a:fillRef>
-          <a:effectRef idx="2">
-            <a:schemeClr val="accent1"/>
-          </a:effectRef>
-          <a:fontRef idx="minor">
-            <a:schemeClr val="lt1"/>
-          </a:fontRef>
-        </p:style>
-        <p:txBody>
-          <a:bodyPr rtlCol="0" anchor="ctr"/>
-          <a:lstStyle/>
-          <a:p>
-            <a:pPr algn="ctr"/>
-          </a:p>
-        </p:txBody>
-      </p:sp>
-      <p:sp>
-        <p:nvSpPr>
-          <p:cNvPr id="6" name="TextBox 5"/>
-          <p:cNvSpPr txBox="1"/>
-          <p:nvPr/>
-        </p:nvSpPr>
-        <p:spPr>
-          <a:xfrm>
-            <a:off x="594360" y="1920240"/>
-            <a:ext cx="3611880" cy="4114800"/>
-          </a:xfrm>
-          <a:prstGeom prst="rect">
-            <a:avLst/>
-          </a:prstGeom>
-          <a:noFill/>
-        </p:spPr>
-        <p:txBody>
-          <a:bodyPr wrap="square" lIns="45720" rIns="45720" anchor="t">
-            <a:spAutoFit/>
-          </a:bodyPr>
-          <a:lstStyle/>
-          <a:p>
-            <a:pPr algn="l"/>
-            <a:r>
-              <a:rPr b="1" sz="1800">
-                <a:solidFill>
-                  <a:srgbClr val="234976"/>
-                </a:solidFill>
-              </a:rPr>
-              <a:t>三個要回答的問題</a:t>
-            </a:r>
-          </a:p>
-          <a:p>
-            <a:pPr algn="l"/>
-            <a:r>
-              <a:rPr sz="1400">
-                <a:solidFill>
-                  <a:srgbClr val="1F1F1F"/>
-                </a:solidFill>
-              </a:rPr>
-              <a:t>1. 5–9 月 RV 到底高不高？IV − RV 是否真的被壓縮？</a:t>
-            </a:r>
-          </a:p>
-          <a:p>
-            <a:pPr algn="l"/>
-            <a:r>
-              <a:rPr sz="600">
-                <a:solidFill>
-                  <a:srgbClr val="1F1F1F"/>
-                </a:solidFill>
-              </a:rPr>
-              <a:t/>
-            </a:r>
-          </a:p>
-          <a:p>
-            <a:pPr algn="l"/>
-            <a:r>
-              <a:rPr sz="1400">
-                <a:solidFill>
-                  <a:srgbClr val="1F1F1F"/>
-                </a:solidFill>
-              </a:rPr>
-              <a:t>2. 9 月底到 10 月，IV 上升是在追 RV，還是明顯脫離 RV？</a:t>
-            </a:r>
-          </a:p>
-          <a:p>
-            <a:pPr algn="l"/>
-            <a:r>
-              <a:rPr sz="600">
-                <a:solidFill>
-                  <a:srgbClr val="1F1F1F"/>
-                </a:solidFill>
-              </a:rPr>
-              <a:t/>
-            </a:r>
-          </a:p>
-          <a:p>
-            <a:pPr algn="l"/>
-            <a:r>
-              <a:rPr sz="1400">
-                <a:solidFill>
-                  <a:srgbClr val="1F1F1F"/>
-                </a:solidFill>
-              </a:rPr>
-              <a:t>3. Payer Skew 是否同步變陡？</a:t>
-            </a:r>
-          </a:p>
-        </p:txBody>
-      </p:sp>
-      <p:graphicFrame>
-        <p:nvGraphicFramePr>
-          <p:cNvPr id="7" name="Table 6"/>
-          <p:cNvGraphicFramePr>
-            <a:graphicFrameLocks noGrp="1"/>
-          </p:cNvGraphicFramePr>
-          <p:nvPr/>
-        </p:nvGraphicFramePr>
-        <p:xfrm>
-          <a:off x="4617720" y="1783080"/>
-          <a:ext cx="7132320" cy="2880360"/>
-        </p:xfrm>
-        <a:graphic>
-          <a:graphicData uri="http://schemas.openxmlformats.org/drawingml/2006/table">
-            <a:tbl>
-              <a:tblPr firstRow="1" bandRow="1">
-                <a:tableStyleId>{5940675A-B579-460E-94D1-54222C63F5DA}</a:tableStyleId>
-              </a:tblPr>
-              <a:tblGrid>
-                <a:gridCol w="1463040"/>
-                <a:gridCol w="2103120"/>
-                <a:gridCol w="1371600"/>
-                <a:gridCol w="2194560"/>
-              </a:tblGrid>
-              <a:tr h="960120">
-                <a:tc>
-                  <a:txBody>
-                    <a:bodyPr wrap="square"/>
-                    <a:lstStyle/>
-                    <a:p>
-                      <a:r>
-                        <a:rPr b="1" sz="1300">
-                          <a:solidFill>
-                            <a:srgbClr val="FFFFFF"/>
-                          </a:solidFill>
-                        </a:rPr>
-                        <a:t>情境</a:t>
-                      </a:r>
-                    </a:p>
-                  </a:txBody>
-                  <a:tcPr marL="73152" marR="73152" marT="27432" marB="27432" anchor="ctr">
-                    <a:solidFill>
-                      <a:srgbClr val="234976"/>
-                    </a:solidFill>
-                  </a:tcPr>
-                </a:tc>
-                <a:tc>
-                  <a:txBody>
-                    <a:bodyPr wrap="square"/>
-                    <a:lstStyle/>
-                    <a:p>
-                      <a:r>
-                        <a:rPr b="1" sz="1300">
-                          <a:solidFill>
-                            <a:srgbClr val="FFFFFF"/>
-                          </a:solidFill>
-                        </a:rPr>
-                        <a:t>數據特徵</a:t>
-                      </a:r>
-                    </a:p>
-                  </a:txBody>
-                  <a:tcPr marL="73152" marR="73152" marT="27432" marB="27432" anchor="ctr">
-                    <a:solidFill>
-                      <a:srgbClr val="234976"/>
-                    </a:solidFill>
-                  </a:tcPr>
-                </a:tc>
-                <a:tc>
-                  <a:txBody>
-                    <a:bodyPr wrap="square"/>
-                    <a:lstStyle/>
-                    <a:p>
-                      <a:r>
-                        <a:rPr b="1" sz="1300">
-                          <a:solidFill>
-                            <a:srgbClr val="FFFFFF"/>
-                          </a:solidFill>
-                        </a:rPr>
-                        <a:t>判斷</a:t>
-                      </a:r>
-                    </a:p>
-                  </a:txBody>
-                  <a:tcPr marL="73152" marR="73152" marT="27432" marB="27432" anchor="ctr">
-                    <a:solidFill>
-                      <a:srgbClr val="234976"/>
-                    </a:solidFill>
-                  </a:tcPr>
-                </a:tc>
-                <a:tc>
-                  <a:txBody>
-                    <a:bodyPr wrap="square"/>
-                    <a:lstStyle/>
-                    <a:p>
-                      <a:r>
-                        <a:rPr b="1" sz="1300">
-                          <a:solidFill>
-                            <a:srgbClr val="FFFFFF"/>
-                          </a:solidFill>
-                        </a:rPr>
-                        <a:t>交易意涵</a:t>
-                      </a:r>
-                    </a:p>
-                  </a:txBody>
-                  <a:tcPr marL="73152" marR="73152" marT="27432" marB="27432" anchor="ctr">
-                    <a:solidFill>
-                      <a:srgbClr val="234976"/>
-                    </a:solidFill>
-                  </a:tcPr>
-                </a:tc>
-              </a:tr>
-              <a:tr h="960120">
-                <a:tc>
-                  <a:txBody>
-                    <a:bodyPr wrap="square"/>
-                    <a:lstStyle/>
-                    <a:p>
-                      <a:r>
-                        <a:rPr b="1" sz="1300">
-                          <a:solidFill>
-                            <a:srgbClr val="1F1F1F"/>
-                          </a:solidFill>
-                        </a:rPr>
-                        <a:t>A：進入 TP 失序期</a:t>
-                      </a:r>
-                    </a:p>
-                  </a:txBody>
-                  <a:tcPr marL="73152" marR="73152" marT="27432" marB="27432" anchor="ctr">
-                    <a:solidFill>
-                      <a:srgbClr val="FFFFFF"/>
-                    </a:solidFill>
-                  </a:tcPr>
-                </a:tc>
-                <a:tc>
-                  <a:txBody>
-                    <a:bodyPr wrap="square"/>
-                    <a:lstStyle/>
-                    <a:p>
-                      <a:r>
-                        <a:rPr sz="1300">
-                          <a:solidFill>
-                            <a:srgbClr val="1F1F1F"/>
-                          </a:solidFill>
-                        </a:rPr>
-                        <a:t>IV − RV 明顯擴大、Payer Skew 變陡、TP 加速</a:t>
-                      </a:r>
-                    </a:p>
-                  </a:txBody>
-                  <a:tcPr marL="73152" marR="73152" marT="27432" marB="27432" anchor="ctr">
-                    <a:solidFill>
-                      <a:srgbClr val="FFFFFF"/>
-                    </a:solidFill>
-                  </a:tcPr>
-                </a:tc>
-                <a:tc>
-                  <a:txBody>
-                    <a:bodyPr wrap="square"/>
-                    <a:lstStyle/>
-                    <a:p>
-                      <a:r>
-                        <a:rPr sz="1300">
-                          <a:solidFill>
-                            <a:srgbClr val="1F1F1F"/>
-                          </a:solidFill>
-                        </a:rPr>
-                        <a:t>Regime Change 已發生</a:t>
-                      </a:r>
-                    </a:p>
-                  </a:txBody>
-                  <a:tcPr marL="73152" marR="73152" marT="27432" marB="27432" anchor="ctr">
-                    <a:solidFill>
-                      <a:srgbClr val="FFFFFF"/>
-                    </a:solidFill>
-                  </a:tcPr>
-                </a:tc>
-                <a:tc>
-                  <a:txBody>
-                    <a:bodyPr wrap="square"/>
-                    <a:lstStyle/>
-                    <a:p>
-                      <a:r>
-                        <a:rPr sz="1300">
-                          <a:solidFill>
-                            <a:srgbClr val="1F1F1F"/>
-                          </a:solidFill>
-                        </a:rPr>
-                        <a:t>IV 易因恐慌避險偏貴；失序緩解後再評估系統性賣 Vol</a:t>
-                      </a:r>
-                    </a:p>
-                  </a:txBody>
-                  <a:tcPr marL="73152" marR="73152" marT="27432" marB="27432" anchor="ctr">
-                    <a:solidFill>
-                      <a:srgbClr val="FFFFFF"/>
-                    </a:solidFill>
-                  </a:tcPr>
-                </a:tc>
-              </a:tr>
-              <a:tr h="960120">
-                <a:tc>
-                  <a:txBody>
-                    <a:bodyPr wrap="square"/>
-                    <a:lstStyle/>
-                    <a:p>
-                      <a:r>
-                        <a:rPr b="1" sz="1300">
-                          <a:solidFill>
-                            <a:srgbClr val="1F1F1F"/>
-                          </a:solidFill>
-                        </a:rPr>
-                        <a:t>B：只是補漲</a:t>
-                      </a:r>
-                    </a:p>
-                  </a:txBody>
-                  <a:tcPr marL="73152" marR="73152" marT="27432" marB="27432" anchor="ctr">
-                    <a:solidFill>
-                      <a:srgbClr val="EEF3F8"/>
-                    </a:solidFill>
-                  </a:tcPr>
-                </a:tc>
-                <a:tc>
-                  <a:txBody>
-                    <a:bodyPr wrap="square"/>
-                    <a:lstStyle/>
-                    <a:p>
-                      <a:r>
-                        <a:rPr sz="1300">
-                          <a:solidFill>
-                            <a:srgbClr val="1F1F1F"/>
-                          </a:solidFill>
-                        </a:rPr>
-                        <a:t>IV 追上 RV、Skew 平穩</a:t>
-                      </a:r>
-                    </a:p>
-                  </a:txBody>
-                  <a:tcPr marL="73152" marR="73152" marT="27432" marB="27432" anchor="ctr">
-                    <a:solidFill>
-                      <a:srgbClr val="EEF3F8"/>
-                    </a:solidFill>
-                  </a:tcPr>
-                </a:tc>
-                <a:tc>
-                  <a:txBody>
-                    <a:bodyPr wrap="square"/>
-                    <a:lstStyle/>
-                    <a:p>
-                      <a:r>
-                        <a:rPr sz="1300">
-                          <a:solidFill>
-                            <a:srgbClr val="1F1F1F"/>
-                          </a:solidFill>
-                        </a:rPr>
-                        <a:t>尚未失序</a:t>
-                      </a:r>
-                    </a:p>
-                  </a:txBody>
-                  <a:tcPr marL="73152" marR="73152" marT="27432" marB="27432" anchor="ctr">
-                    <a:solidFill>
-                      <a:srgbClr val="EEF3F8"/>
-                    </a:solidFill>
-                  </a:tcPr>
-                </a:tc>
-                <a:tc>
-                  <a:txBody>
-                    <a:bodyPr wrap="square"/>
-                    <a:lstStyle/>
-                    <a:p>
-                      <a:r>
-                        <a:rPr sz="1300">
-                          <a:solidFill>
-                            <a:srgbClr val="1F1F1F"/>
-                          </a:solidFill>
-                        </a:rPr>
-                        <a:t>賣 Vol 的機會還沒到；追蹤 TP 上升速度</a:t>
-                      </a:r>
-                    </a:p>
-                  </a:txBody>
-                  <a:tcPr marL="73152" marR="73152" marT="27432" marB="27432" anchor="ctr">
-                    <a:solidFill>
-                      <a:srgbClr val="EEF3F8"/>
-                    </a:solidFill>
-                  </a:tcPr>
-                </a:tc>
-              </a:tr>
-            </a:tbl>
-          </a:graphicData>
-        </a:graphic>
-      </p:graphicFrame>
-      <p:sp>
-        <p:nvSpPr>
-          <p:cNvPr id="8" name="TextBox 7"/>
-          <p:cNvSpPr txBox="1"/>
-          <p:nvPr/>
-        </p:nvSpPr>
-        <p:spPr>
-          <a:xfrm>
-            <a:off x="4617720" y="4892040"/>
-            <a:ext cx="7132320" cy="1188720"/>
-          </a:xfrm>
-          <a:prstGeom prst="rect">
-            <a:avLst/>
-          </a:prstGeom>
-          <a:noFill/>
-        </p:spPr>
-        <p:txBody>
-          <a:bodyPr wrap="square" lIns="45720" rIns="45720" anchor="t">
-            <a:spAutoFit/>
-          </a:bodyPr>
-          <a:lstStyle/>
-          <a:p>
-            <a:pPr algn="l"/>
-            <a:r>
-              <a:rPr b="1" sz="1400">
-                <a:solidFill>
-                  <a:srgbClr val="E83F0A"/>
-                </a:solidFill>
-              </a:rPr>
-              <a:t>兩種情境都要留意：</a:t>
-            </a:r>
-            <a:r>
-              <a:rPr sz="1400">
-                <a:solidFill>
-                  <a:srgbClr val="1F1F1F"/>
-                </a:solidFill>
-              </a:rPr>
-              <a:t>TP 主導期的高 VRP 可能是對肥尾風險的合理補償，而不是「偏貴」；在自我強化的環境系統性賣 Vol，風險不對稱。</a:t>
-            </a:r>
-          </a:p>
-        </p:txBody>
-      </p:sp>
     </p:spTree>
   </p:cSld>
   <p:clrMapOvr>

</xml_diff>

<commit_message>
Reframe deck as an extension of the commentary
Drop the appendix slide that assessed the original commentary and
reword titles and notes that framed findings as rebuttals, so the deck
presents the analysis as building on the original framework. Also note
that the inflation component is small (market BEI about +9 bp).

Co-Authored-By: Claude Opus 5.5 <noreply@anthropic.com>
Claude-Session: https://claude.ai/code/session_01TCy2oBSRDZdisvwwxxfgzX
</commit_message>
<xml_diff>
--- a/slides/2026-10-03_us-treasury-vol-regime-change.pptx
+++ b/slides/2026-10-03_us-treasury-vol-regime-change.pptx
@@ -20,7 +20,6 @@
     <p:sldId id="886" r:id="rId20"/>
     <p:sldId id="887" r:id="rId21"/>
     <p:sldId id="888" r:id="rId22"/>
-    <p:sldId id="889" r:id="rId23"/>
     <p:sldId id="877" r:id="rId10"/>
   </p:sldIdLst>
   <p:sldSz cx="12192000" cy="6858000"/>
@@ -1588,7 +1587,7 @@
           <a:lstStyle/>
           <a:p>
             <a:r>
-              <a:t>核心訊息：市場說這輪拋售不是 TP，但 Kim-Wright 顯示 TP 今年以來約 +45 bp。TP 有序緩升不會推高 IV，失序才會。</a:t>
+              <a:t>核心訊息：延伸原文的預期 vs TP 框架。TP 從 7 月起持續上升（Kim-Wright 今年以來約 +45 bp），但有序緩升不會推高 IV，失序才會。</a:t>
             </a:r>
           </a:p>
         </p:txBody>
@@ -1728,7 +1727,7 @@
           <a:lstStyle/>
           <a:p>
             <a:r>
-              <a:t>DKW 把名目殖利率拆成四塊。實質部分（預期實質短率＋實質 TP）約 +42 bp，其中實質 TP 約 16 bp。原文用實質利率貢獻 120 bp 推論不是 TP，在 DKW 下站不住。</a:t>
+              <a:t>DKW 把名目殖利率拆成四塊。實質部分（預期實質短率＋實質 TP）約 +42 bp，其中實質 TP 約 16 bp。進一步拆開實質利率，能看出期限溢酬的份量。</a:t>
             </a:r>
           </a:p>
         </p:txBody>
@@ -46114,7 +46113,7 @@
                   <a:srgbClr val="1F1F1F"/>
                 </a:solidFill>
               </a:rPr>
-              <a:t>TP 主導期的高 VRP 可能是對肥尾風險的合理補償，而不是「偏貴」；在自我強化的環境系統性賣 Vol，風險不對稱。</a:t>
+              <a:t>失序期的高 VRP 同時反映肥尾風險；賣 Vol 宜等失序緩解，並用價差限制最大損失。</a:t>
             </a:r>
           </a:p>
         </p:txBody>
@@ -46898,7 +46897,7 @@
           <a:lstStyle/>
           <a:p>
             <a:r>
-              <a:t>原文以四個機制解釋：利率變動由政策預期主導時，選擇權買方不願多付保險費</a:t>
+              <a:t>利率變動由政策預期主導時，選擇權買方不願多付保險費</a:t>
             </a:r>
           </a:p>
         </p:txBody>
@@ -46924,7 +46923,7 @@
           <a:lstStyle/>
           <a:p>
             <a:r>
-              <a:t>附錄 A：原文論點——預期主導時 VRP 萎縮的四個機制</a:t>
+              <a:t>附錄：框架基礎——預期主導時 VRP 萎縮的四個機制</a:t>
             </a:r>
           </a:p>
         </p:txBody>
@@ -47294,553 +47293,6 @@
 </file>
 
 <file path=ppt/slides/slide13.xml><?xml version="1.0" encoding="utf-8"?>
-<p:sld xmlns:a="http://schemas.openxmlformats.org/drawingml/2006/main" xmlns:p="http://schemas.openxmlformats.org/presentationml/2006/main" xmlns:r="http://schemas.openxmlformats.org/officeDocument/2006/relationships">
-  <p:cSld>
-    <p:spTree>
-      <p:nvGrpSpPr>
-        <p:cNvPr id="1" name=""/>
-        <p:cNvGrpSpPr/>
-        <p:nvPr/>
-      </p:nvGrpSpPr>
-      <p:grpSpPr/>
-      <p:sp>
-        <p:nvSpPr>
-          <p:cNvPr id="3" name="Text Placeholder 2"/>
-          <p:cNvSpPr>
-            <a:spLocks noGrp="1"/>
-          </p:cNvSpPr>
-          <p:nvPr>
-            <p:ph type="body" idx="15" sz="quarter"/>
-          </p:nvPr>
-        </p:nvSpPr>
-        <p:spPr/>
-        <p:txBody>
-          <a:bodyPr/>
-          <a:lstStyle/>
-          <a:p>
-            <a:r>
-              <a:t>原文適合當作值得驗證的假說；部分論點與 DKW、Kim-Wright 數據不一致</a:t>
-            </a:r>
-          </a:p>
-        </p:txBody>
-      </p:sp>
-      <p:sp>
-        <p:nvSpPr>
-          <p:cNvPr id="4" name="Title 3"/>
-          <p:cNvSpPr>
-            <a:spLocks noGrp="1"/>
-          </p:cNvSpPr>
-          <p:nvPr>
-            <p:ph type="title"/>
-          </p:nvPr>
-        </p:nvSpPr>
-        <p:spPr>
-          <a:xfrm>
-            <a:off x="411480" y="192024"/>
-            <a:ext cx="11329416" cy="548640"/>
-          </a:xfrm>
-        </p:spPr>
-        <p:txBody>
-          <a:bodyPr/>
-          <a:lstStyle/>
-          <a:p>
-            <a:r>
-              <a:t>附錄 B：原文評估——框架合理，推論跳得快</a:t>
-            </a:r>
-          </a:p>
-        </p:txBody>
-      </p:sp>
-      <p:graphicFrame>
-        <p:nvGraphicFramePr>
-          <p:cNvPr id="5" name="Table 4"/>
-          <p:cNvGraphicFramePr>
-            <a:graphicFrameLocks noGrp="1"/>
-          </p:cNvGraphicFramePr>
-          <p:nvPr/>
-        </p:nvGraphicFramePr>
-        <p:xfrm>
-          <a:off x="411480" y="1783080"/>
-          <a:ext cx="11338560" cy="3968496"/>
-        </p:xfrm>
-        <a:graphic>
-          <a:graphicData uri="http://schemas.openxmlformats.org/drawingml/2006/table">
-            <a:tbl>
-              <a:tblPr firstRow="1" bandRow="1">
-                <a:tableStyleId>{5940675A-B579-460E-94D1-54222C63F5DA}</a:tableStyleId>
-              </a:tblPr>
-              <a:tblGrid>
-                <a:gridCol w="3566160"/>
-                <a:gridCol w="1463040"/>
-                <a:gridCol w="6309360"/>
-              </a:tblGrid>
-              <a:tr h="566928">
-                <a:tc>
-                  <a:txBody>
-                    <a:bodyPr wrap="square"/>
-                    <a:lstStyle/>
-                    <a:p>
-                      <a:r>
-                        <a:rPr b="1" sz="1300">
-                          <a:solidFill>
-                            <a:srgbClr val="FFFFFF"/>
-                          </a:solidFill>
-                        </a:rPr>
-                        <a:t>原文論點</a:t>
-                      </a:r>
-                    </a:p>
-                  </a:txBody>
-                  <a:tcPr marL="73152" marR="73152" marT="27432" marB="27432" anchor="ctr">
-                    <a:solidFill>
-                      <a:srgbClr val="234976"/>
-                    </a:solidFill>
-                  </a:tcPr>
-                </a:tc>
-                <a:tc>
-                  <a:txBody>
-                    <a:bodyPr wrap="square"/>
-                    <a:lstStyle/>
-                    <a:p>
-                      <a:r>
-                        <a:rPr b="1" sz="1300">
-                          <a:solidFill>
-                            <a:srgbClr val="FFFFFF"/>
-                          </a:solidFill>
-                        </a:rPr>
-                        <a:t>評估</a:t>
-                      </a:r>
-                    </a:p>
-                  </a:txBody>
-                  <a:tcPr marL="73152" marR="73152" marT="27432" marB="27432" anchor="ctr">
-                    <a:solidFill>
-                      <a:srgbClr val="234976"/>
-                    </a:solidFill>
-                  </a:tcPr>
-                </a:tc>
-                <a:tc>
-                  <a:txBody>
-                    <a:bodyPr wrap="square"/>
-                    <a:lstStyle/>
-                    <a:p>
-                      <a:r>
-                        <a:rPr b="1" sz="1300">
-                          <a:solidFill>
-                            <a:srgbClr val="FFFFFF"/>
-                          </a:solidFill>
-                        </a:rPr>
-                        <a:t>依據</a:t>
-                      </a:r>
-                    </a:p>
-                  </a:txBody>
-                  <a:tcPr marL="73152" marR="73152" marT="27432" marB="27432" anchor="ctr">
-                    <a:solidFill>
-                      <a:srgbClr val="234976"/>
-                    </a:solidFill>
-                  </a:tcPr>
-                </a:tc>
-              </a:tr>
-              <a:tr h="566928">
-                <a:tc>
-                  <a:txBody>
-                    <a:bodyPr wrap="square"/>
-                    <a:lstStyle/>
-                    <a:p>
-                      <a:r>
-                        <a:rPr b="1" sz="1300">
-                          <a:solidFill>
-                            <a:srgbClr val="1F1F1F"/>
-                          </a:solidFill>
-                        </a:rPr>
-                        <a:t>預期衝擊與 TP 衝擊的 VRP 不同</a:t>
-                      </a:r>
-                    </a:p>
-                  </a:txBody>
-                  <a:tcPr marL="73152" marR="73152" marT="27432" marB="27432" anchor="ctr">
-                    <a:solidFill>
-                      <a:srgbClr val="FFFFFF"/>
-                    </a:solidFill>
-                  </a:tcPr>
-                </a:tc>
-                <a:tc>
-                  <a:txBody>
-                    <a:bodyPr wrap="square"/>
-                    <a:lstStyle/>
-                    <a:p>
-                      <a:r>
-                        <a:rPr sz="1300">
-                          <a:solidFill>
-                            <a:srgbClr val="1F1F1F"/>
-                          </a:solidFill>
-                        </a:rPr>
-                        <a:t>合理</a:t>
-                      </a:r>
-                    </a:p>
-                  </a:txBody>
-                  <a:tcPr marL="73152" marR="73152" marT="27432" marB="27432" anchor="ctr">
-                    <a:solidFill>
-                      <a:srgbClr val="FFFFFF"/>
-                    </a:solidFill>
-                  </a:tcPr>
-                </a:tc>
-                <a:tc>
-                  <a:txBody>
-                    <a:bodyPr wrap="square"/>
-                    <a:lstStyle/>
-                    <a:p>
-                      <a:r>
-                        <a:rPr sz="1300">
-                          <a:solidFill>
-                            <a:srgbClr val="1F1F1F"/>
-                          </a:solidFill>
-                        </a:rPr>
-                        <a:t>線性工具 vs 凸性需求的區分，在實務與學術上都站得住</a:t>
-                      </a:r>
-                    </a:p>
-                  </a:txBody>
-                  <a:tcPr marL="73152" marR="73152" marT="27432" marB="27432" anchor="ctr">
-                    <a:solidFill>
-                      <a:srgbClr val="FFFFFF"/>
-                    </a:solidFill>
-                  </a:tcPr>
-                </a:tc>
-              </a:tr>
-              <a:tr h="566928">
-                <a:tc>
-                  <a:txBody>
-                    <a:bodyPr wrap="square"/>
-                    <a:lstStyle/>
-                    <a:p>
-                      <a:r>
-                        <a:rPr b="1" sz="1300">
-                          <a:solidFill>
-                            <a:srgbClr val="1F1F1F"/>
-                          </a:solidFill>
-                        </a:rPr>
-                        <a:t>本輪拋售不是 TP，而是實質利率</a:t>
-                      </a:r>
-                    </a:p>
-                  </a:txBody>
-                  <a:tcPr marL="73152" marR="73152" marT="27432" marB="27432" anchor="ctr">
-                    <a:solidFill>
-                      <a:srgbClr val="EEF3F8"/>
-                    </a:solidFill>
-                  </a:tcPr>
-                </a:tc>
-                <a:tc>
-                  <a:txBody>
-                    <a:bodyPr wrap="square"/>
-                    <a:lstStyle/>
-                    <a:p>
-                      <a:r>
-                        <a:rPr sz="1300">
-                          <a:solidFill>
-                            <a:srgbClr val="1F1F1F"/>
-                          </a:solidFill>
-                        </a:rPr>
-                        <a:t>不成立</a:t>
-                      </a:r>
-                    </a:p>
-                  </a:txBody>
-                  <a:tcPr marL="73152" marR="73152" marT="27432" marB="27432" anchor="ctr">
-                    <a:solidFill>
-                      <a:srgbClr val="EEF3F8"/>
-                    </a:solidFill>
-                  </a:tcPr>
-                </a:tc>
-                <a:tc>
-                  <a:txBody>
-                    <a:bodyPr wrap="square"/>
-                    <a:lstStyle/>
-                    <a:p>
-                      <a:r>
-                        <a:rPr sz="1300">
-                          <a:solidFill>
-                            <a:srgbClr val="1F1F1F"/>
-                          </a:solidFill>
-                        </a:rPr>
-                        <a:t>DKW：實質部分 +42 bp 中實質 TP 約 +16 bp（近四成）；Kim-Wright TP 至 9/25 約 +45 bp</a:t>
-                      </a:r>
-                    </a:p>
-                  </a:txBody>
-                  <a:tcPr marL="73152" marR="73152" marT="27432" marB="27432" anchor="ctr">
-                    <a:solidFill>
-                      <a:srgbClr val="EEF3F8"/>
-                    </a:solidFill>
-                  </a:tcPr>
-                </a:tc>
-              </a:tr>
-              <a:tr h="566928">
-                <a:tc>
-                  <a:txBody>
-                    <a:bodyPr wrap="square"/>
-                    <a:lstStyle/>
-                    <a:p>
-                      <a:r>
-                        <a:rPr b="1" sz="1300">
-                          <a:solidFill>
-                            <a:srgbClr val="1F1F1F"/>
-                          </a:solidFill>
-                        </a:rPr>
-                        <a:t>TP 最近才反彈</a:t>
-                      </a:r>
-                    </a:p>
-                  </a:txBody>
-                  <a:tcPr marL="73152" marR="73152" marT="27432" marB="27432" anchor="ctr">
-                    <a:solidFill>
-                      <a:srgbClr val="FFFFFF"/>
-                    </a:solidFill>
-                  </a:tcPr>
-                </a:tc>
-                <a:tc>
-                  <a:txBody>
-                    <a:bodyPr wrap="square"/>
-                    <a:lstStyle/>
-                    <a:p>
-                      <a:r>
-                        <a:rPr sz="1300">
-                          <a:solidFill>
-                            <a:srgbClr val="1F1F1F"/>
-                          </a:solidFill>
-                        </a:rPr>
-                        <a:t>不精確</a:t>
-                      </a:r>
-                    </a:p>
-                  </a:txBody>
-                  <a:tcPr marL="73152" marR="73152" marT="27432" marB="27432" anchor="ctr">
-                    <a:solidFill>
-                      <a:srgbClr val="FFFFFF"/>
-                    </a:solidFill>
-                  </a:tcPr>
-                </a:tc>
-                <a:tc>
-                  <a:txBody>
-                    <a:bodyPr wrap="square"/>
-                    <a:lstStyle/>
-                    <a:p>
-                      <a:r>
-                        <a:rPr sz="1300">
-                          <a:solidFill>
-                            <a:srgbClr val="1F1F1F"/>
-                          </a:solidFill>
-                        </a:rPr>
-                        <a:t>DKW、Kim-Wright、CR 都顯示 TP 從 7 月起持續上升</a:t>
-                      </a:r>
-                    </a:p>
-                  </a:txBody>
-                  <a:tcPr marL="73152" marR="73152" marT="27432" marB="27432" anchor="ctr">
-                    <a:solidFill>
-                      <a:srgbClr val="FFFFFF"/>
-                    </a:solidFill>
-                  </a:tcPr>
-                </a:tc>
-              </a:tr>
-              <a:tr h="566928">
-                <a:tc>
-                  <a:txBody>
-                    <a:bodyPr wrap="square"/>
-                    <a:lstStyle/>
-                    <a:p>
-                      <a:r>
-                        <a:rPr b="1" sz="1300">
-                          <a:solidFill>
-                            <a:srgbClr val="1F1F1F"/>
-                          </a:solidFill>
-                        </a:rPr>
-                        <a:t>IV 有宏觀錨定上限</a:t>
-                      </a:r>
-                    </a:p>
-                  </a:txBody>
-                  <a:tcPr marL="73152" marR="73152" marT="27432" marB="27432" anchor="ctr">
-                    <a:solidFill>
-                      <a:srgbClr val="EEF3F8"/>
-                    </a:solidFill>
-                  </a:tcPr>
-                </a:tc>
-                <a:tc>
-                  <a:txBody>
-                    <a:bodyPr wrap="square"/>
-                    <a:lstStyle/>
-                    <a:p>
-                      <a:r>
-                        <a:rPr sz="1300">
-                          <a:solidFill>
-                            <a:srgbClr val="1F1F1F"/>
-                          </a:solidFill>
-                        </a:rPr>
-                        <a:t>存疑</a:t>
-                      </a:r>
-                    </a:p>
-                  </a:txBody>
-                  <a:tcPr marL="73152" marR="73152" marT="27432" marB="27432" anchor="ctr">
-                    <a:solidFill>
-                      <a:srgbClr val="EEF3F8"/>
-                    </a:solidFill>
-                  </a:tcPr>
-                </a:tc>
-                <a:tc>
-                  <a:txBody>
-                    <a:bodyPr wrap="square"/>
-                    <a:lstStyle/>
-                    <a:p>
-                      <a:r>
-                        <a:rPr sz="1300">
-                          <a:solidFill>
-                            <a:srgbClr val="1F1F1F"/>
-                          </a:solidFill>
-                        </a:rPr>
-                        <a:t>IV 是市場價格；r* 約束利率水準，不約束 3 個月內的波動</a:t>
-                      </a:r>
-                    </a:p>
-                  </a:txBody>
-                  <a:tcPr marL="73152" marR="73152" marT="27432" marB="27432" anchor="ctr">
-                    <a:solidFill>
-                      <a:srgbClr val="EEF3F8"/>
-                    </a:solidFill>
-                  </a:tcPr>
-                </a:tc>
-              </a:tr>
-              <a:tr h="566928">
-                <a:tc>
-                  <a:txBody>
-                    <a:bodyPr wrap="square"/>
-                    <a:lstStyle/>
-                    <a:p>
-                      <a:r>
-                        <a:rPr b="1" sz="1300">
-                          <a:solidFill>
-                            <a:srgbClr val="1F1F1F"/>
-                          </a:solidFill>
-                        </a:rPr>
-                        <a:t>TP 主導期是賣 Vol 的較佳窗口</a:t>
-                      </a:r>
-                    </a:p>
-                  </a:txBody>
-                  <a:tcPr marL="73152" marR="73152" marT="27432" marB="27432" anchor="ctr">
-                    <a:solidFill>
-                      <a:srgbClr val="FFFFFF"/>
-                    </a:solidFill>
-                  </a:tcPr>
-                </a:tc>
-                <a:tc>
-                  <a:txBody>
-                    <a:bodyPr wrap="square"/>
-                    <a:lstStyle/>
-                    <a:p>
-                      <a:r>
-                        <a:rPr sz="1300">
-                          <a:solidFill>
-                            <a:srgbClr val="1F1F1F"/>
-                          </a:solidFill>
-                        </a:rPr>
-                        <a:t>風險不對稱</a:t>
-                      </a:r>
-                    </a:p>
-                  </a:txBody>
-                  <a:tcPr marL="73152" marR="73152" marT="27432" marB="27432" anchor="ctr">
-                    <a:solidFill>
-                      <a:srgbClr val="FFFFFF"/>
-                    </a:solidFill>
-                  </a:tcPr>
-                </a:tc>
-                <a:tc>
-                  <a:txBody>
-                    <a:bodyPr wrap="square"/>
-                    <a:lstStyle/>
-                    <a:p>
-                      <a:r>
-                        <a:rPr sz="1300">
-                          <a:solidFill>
-                            <a:srgbClr val="1F1F1F"/>
-                          </a:solidFill>
-                        </a:rPr>
-                        <a:t>肥尾環境下的高 VRP 可能是合理補償</a:t>
-                      </a:r>
-                    </a:p>
-                  </a:txBody>
-                  <a:tcPr marL="73152" marR="73152" marT="27432" marB="27432" anchor="ctr">
-                    <a:solidFill>
-                      <a:srgbClr val="FFFFFF"/>
-                    </a:solidFill>
-                  </a:tcPr>
-                </a:tc>
-              </a:tr>
-              <a:tr h="566928">
-                <a:tc>
-                  <a:txBody>
-                    <a:bodyPr wrap="square"/>
-                    <a:lstStyle/>
-                    <a:p>
-                      <a:r>
-                        <a:rPr b="1" sz="1300">
-                          <a:solidFill>
-                            <a:srgbClr val="1F1F1F"/>
-                          </a:solidFill>
-                        </a:rPr>
-                        <a:t>eSLR 放寬後去槓桿風險下降</a:t>
-                      </a:r>
-                    </a:p>
-                  </a:txBody>
-                  <a:tcPr marL="73152" marR="73152" marT="27432" marB="27432" anchor="ctr">
-                    <a:solidFill>
-                      <a:srgbClr val="EEF3F8"/>
-                    </a:solidFill>
-                  </a:tcPr>
-                </a:tc>
-                <a:tc>
-                  <a:txBody>
-                    <a:bodyPr wrap="square"/>
-                    <a:lstStyle/>
-                    <a:p>
-                      <a:r>
-                        <a:rPr sz="1300">
-                          <a:solidFill>
-                            <a:srgbClr val="1F1F1F"/>
-                          </a:solidFill>
-                        </a:rPr>
-                        <a:t>方向合理</a:t>
-                      </a:r>
-                    </a:p>
-                  </a:txBody>
-                  <a:tcPr marL="73152" marR="73152" marT="27432" marB="27432" anchor="ctr">
-                    <a:solidFill>
-                      <a:srgbClr val="EEF3F8"/>
-                    </a:solidFill>
-                  </a:tcPr>
-                </a:tc>
-                <a:tc>
-                  <a:txBody>
-                    <a:bodyPr wrap="square"/>
-                    <a:lstStyle/>
-                    <a:p>
-                      <a:r>
-                        <a:rPr sz="1300">
-                          <a:solidFill>
-                            <a:srgbClr val="1F1F1F"/>
-                          </a:solidFill>
-                        </a:rPr>
-                        <a:t>缺部位數據；2025/4 主因是否為 Basis Trade 當時就有爭議</a:t>
-                      </a:r>
-                    </a:p>
-                  </a:txBody>
-                  <a:tcPr marL="73152" marR="73152" marT="27432" marB="27432" anchor="ctr">
-                    <a:solidFill>
-                      <a:srgbClr val="EEF3F8"/>
-                    </a:solidFill>
-                  </a:tcPr>
-                </a:tc>
-              </a:tr>
-            </a:tbl>
-          </a:graphicData>
-        </a:graphic>
-      </p:graphicFrame>
-    </p:spTree>
-  </p:cSld>
-  <p:clrMapOvr>
-    <a:masterClrMapping/>
-  </p:clrMapOvr>
-</p:sld>
-</file>
-
-<file path=ppt/slides/slide14.xml><?xml version="1.0" encoding="utf-8"?>
 <p:sld xmlns:a="http://schemas.openxmlformats.org/drawingml/2006/main" xmlns:r="http://schemas.openxmlformats.org/officeDocument/2006/relationships" xmlns:p="http://schemas.openxmlformats.org/presentationml/2006/main">
   <p:cSld>
     <p:spTree>
@@ -47906,11 +47358,11 @@
             </a:pPr>
             <a:r>
               <a:rPr b="1" sz="1500"/>
-              <a:t>TP 的角色被低估</a:t>
+              <a:t>TP 是第二大驅動</a:t>
             </a:r>
             <a:r>
               <a:rPr sz="1500"/>
-              <a:t>：依 DKW，10Y 今年到 8 月的上升約三成五來自 TP，「實質利率」上升裡近四成是實質 TP；只是過程有序，沒有觸發恐慌性凸性避險，IV 因此停在低檔</a:t>
+              <a:t>：依 DKW，10Y 今年到 8 月的上升約三成五來自 TP，實質利率上升裡近四成是實質 TP；過程有序，沒有觸發恐慌性凸性避險，IV 因此停在低檔</a:t>
             </a:r>
           </a:p>
           <a:p>
@@ -48975,7 +48427,7 @@
                   <a:srgbClr val="234976"/>
                 </a:solidFill>
               </a:rPr>
-              <a:t>但不一定矛盾</a:t>
+              <a:t>怎麼理解</a:t>
             </a:r>
           </a:p>
           <a:p>
@@ -49051,7 +48503,7 @@
           <a:lstStyle/>
           <a:p>
             <a:r>
-              <a:t>拆解：預期是主力，但 TP 的貢獻被低估</a:t>
+              <a:t>拆解：預期是主力，TP 是第二大來源</a:t>
             </a:r>
           </a:p>
         </p:txBody>
@@ -49327,7 +48779,7 @@
                   <a:srgbClr val="234976"/>
                 </a:solidFill>
               </a:rPr>
-              <a:t>TP 從 7 月起持續上升，不是 9 月底才反彈。</a:t>
+              <a:t>TP 從 7 月起持續上升，9 月再加速。</a:t>
             </a:r>
           </a:p>
         </p:txBody>
@@ -49386,7 +48838,7 @@
             </a:r>
             <a:r>
               <a:rPr sz="1400"/>
-              <a:t>：政策路徑與 r* 的預期，原文說的主力</a:t>
+              <a:t>：政策路徑與 r* 的預期，是主要驅動</a:t>
             </a:r>
           </a:p>
           <a:p>
@@ -49400,7 +48852,7 @@
             </a:r>
             <a:r>
               <a:rPr sz="1400"/>
-              <a:t>：約佔實質部分的 39%，原文的拆法看不到這一塊</a:t>
+              <a:t>：約佔實質部分的 39%，TIPS 殖利率中屬於期限溢酬的部分</a:t>
             </a:r>
           </a:p>
           <a:p>
@@ -49430,7 +48882,7 @@
             </a:pPr>
             <a:r>
               <a:rPr sz="1400"/>
-              <a:t>預期通膨今年到 8 月 +12 bp；DKW 尚未涵蓋 9 月升息後的變化。</a:t>
+              <a:t>通膨部分小：預期通膨 +12 bp、市場 BEI 約 +9 bp，9 月升息後回落。</a:t>
             </a:r>
           </a:p>
         </p:txBody>
@@ -50120,7 +49572,7 @@
                   <a:srgbClr val="234976"/>
                 </a:solidFill>
               </a:rPr>
-              <a:t>我們的修正</a:t>
+              <a:t>延伸：失序才是關鍵</a:t>
             </a:r>
           </a:p>
           <a:p>
@@ -50153,7 +49605,7 @@
                   <a:srgbClr val="E83F0A"/>
                 </a:solidFill>
               </a:rPr>
-              <a:t>必須排除的替代解釋</a:t>
+              <a:t>待驗證的另一種可能</a:t>
             </a:r>
           </a:p>
           <a:p>

</xml_diff>

<commit_message>
Add Kim-Wright and DKW model definitions to notes and deck
Notes: a "TP 模型" subsection in section 11 covering what term premium
models do, each model's source, inputs, decomposition and data, a
side-by-side comparison, and caveats (shared authorship, ACM as an
independent check, revisions); glossary rows and pointers from 14.6
and 14.7. The DKW identities (nominal, TIPS and BEI) were checked
against the published data.

Deck: a method slide before the Kim-Wright results comparing the two
models and listing the decomposition formulas.

Co-Authored-By: Claude Opus 5.5 <noreply@anthropic.com>
Claude-Session: https://claude.ai/code/session_01TCy2oBSRDZdisvwwxxfgzX
</commit_message>
<xml_diff>
--- a/slides/2026-10-03_us-treasury-vol-regime-change.pptx
+++ b/slides/2026-10-03_us-treasury-vol-regime-change.pptx
@@ -23,6 +23,7 @@
     <p:sldId id="889" r:id="rId23"/>
     <p:sldId id="890" r:id="rId24"/>
     <p:sldId id="891" r:id="rId25"/>
+    <p:sldId id="892" r:id="rId26"/>
     <p:sldId id="877" r:id="rId10"/>
   </p:sldIdLst>
   <p:sldSz cx="12192000" cy="6858000"/>
@@ -2988,7 +2989,7 @@
           <a:lstStyle/>
           <a:p>
             <a:r>
-              <a:t>CR 與 Kim-Wright 對 TP 份量差很多；兩者都顯示 7 月起 TP 持續上升。</a:t>
+              <a:t>TP 模型把長天期殖利率拆成「市場預期的未來短率平均」與「期限溢酬」。預期看不到，只能靠模型估計，所以不同模型的 TP 常差 10–20 bp。Kim-Wright 是三因子無套利仿射模型，只用名目公債與短率調查；DKW 用同樣的架構同時為名目公債與 TIPS 定價，加入通膨資料、通膨調查與 TIPS 流動性因子，因此能把實質利率與通膨拆開。DKW 的四個成分加總等於模型配適的名目殖利率，在 Fed 公布的資料中精確成立。</a:t>
             </a:r>
           </a:p>
         </p:txBody>
@@ -3058,7 +3059,7 @@
           <a:lstStyle/>
           <a:p>
             <a:r>
-              <a:t>DKW 把名目殖利率拆成四塊。實質部分（預期實質短率＋實質 TP）約 +42 bp，其中實質 TP 約 16 bp。進一步拆開實質利率，能看出期限溢酬的份量。</a:t>
+              <a:t>CR 與 Kim-Wright 對 TP 份量差很多；兩者都顯示 7 月起 TP 持續上升。</a:t>
             </a:r>
           </a:p>
         </p:txBody>
@@ -3128,7 +3129,7 @@
           <a:lstStyle/>
           <a:p>
             <a:r>
-              <a:t>第一階段：短端領漲，符合升息預期重定價；Vol 與信用平靜。第二階段：短端不動、長端大跌，曲線轉陡，MOVE、TP、HY 利差同時跳升，就是原文說的 regime change，而且有明確日期。</a:t>
+              <a:t>DKW 把名目殖利率拆成四塊。實質部分（預期實質短率＋實質 TP）約 +42 bp，其中實質 TP 約 16 bp。進一步拆開實質利率，能看出期限溢酬的份量。</a:t>
             </a:r>
           </a:p>
         </p:txBody>
@@ -3154,6 +3155,76 @@
 </file>
 
 <file path=ppt/notesSlides/notesSlide5.xml><?xml version="1.0" encoding="utf-8"?>
+<p:notes xmlns:a="http://schemas.openxmlformats.org/drawingml/2006/main" xmlns:p="http://schemas.openxmlformats.org/presentationml/2006/main" xmlns:r="http://schemas.openxmlformats.org/officeDocument/2006/relationships">
+  <p:cSld>
+    <p:spTree>
+      <p:nvGrpSpPr>
+        <p:cNvPr id="1" name=""/>
+        <p:cNvGrpSpPr/>
+        <p:nvPr/>
+      </p:nvGrpSpPr>
+      <p:grpSpPr>
+        <a:xfrm>
+          <a:off x="0" y="0"/>
+          <a:ext cx="0" cy="0"/>
+          <a:chOff x="0" y="0"/>
+          <a:chExt cx="0" cy="0"/>
+        </a:xfrm>
+      </p:grpSpPr>
+      <p:sp>
+        <p:nvSpPr>
+          <p:cNvPr id="2" name="Slide Image Placeholder 1"/>
+          <p:cNvSpPr>
+            <a:spLocks noGrp="1"/>
+          </p:cNvSpPr>
+          <p:nvPr>
+            <p:ph type="sldImg" idx="2"/>
+          </p:nvPr>
+        </p:nvSpPr>
+        <p:spPr/>
+      </p:sp>
+      <p:sp>
+        <p:nvSpPr>
+          <p:cNvPr id="3" name="Notes Placeholder 2"/>
+          <p:cNvSpPr>
+            <a:spLocks noGrp="1"/>
+          </p:cNvSpPr>
+          <p:nvPr>
+            <p:ph type="body" idx="3" sz="quarter"/>
+          </p:nvPr>
+        </p:nvSpPr>
+        <p:spPr/>
+        <p:txBody>
+          <a:bodyPr/>
+          <a:lstStyle/>
+          <a:p>
+            <a:r>
+              <a:t>第一階段：短端領漲，符合升息預期重定價；Vol 與信用平靜。第二階段：短端不動、長端大跌，曲線轉陡，MOVE、TP、HY 利差同時跳升，就是原文說的 regime change，而且有明確日期。</a:t>
+            </a:r>
+          </a:p>
+        </p:txBody>
+      </p:sp>
+      <p:sp>
+        <p:nvSpPr>
+          <p:cNvPr id="4" name="Slide Number Placeholder 3"/>
+          <p:cNvSpPr>
+            <a:spLocks noGrp="1"/>
+          </p:cNvSpPr>
+          <p:nvPr>
+            <p:ph type="sldNum" idx="5" sz="quarter"/>
+          </p:nvPr>
+        </p:nvSpPr>
+        <p:spPr/>
+      </p:sp>
+    </p:spTree>
+  </p:cSld>
+  <p:clrMapOvr>
+    <a:masterClrMapping/>
+  </p:clrMapOvr>
+</p:notes>
+</file>
+
+<file path=ppt/notesSlides/notesSlide6.xml><?xml version="1.0" encoding="utf-8"?>
 <p:notes xmlns:a="http://schemas.openxmlformats.org/drawingml/2006/main" xmlns:p="http://schemas.openxmlformats.org/presentationml/2006/main" xmlns:r="http://schemas.openxmlformats.org/officeDocument/2006/relationships">
   <p:cSld>
     <p:spTree>
@@ -47083,6 +47154,675 @@
       <p:grpSpPr/>
       <p:sp>
         <p:nvSpPr>
+          <p:cNvPr id="3" name="Text Placeholder 2"/>
+          <p:cNvSpPr>
+            <a:spLocks noGrp="1"/>
+          </p:cNvSpPr>
+          <p:nvPr>
+            <p:ph type="body" idx="15" sz="quarter"/>
+          </p:nvPr>
+        </p:nvSpPr>
+        <p:spPr/>
+        <p:txBody>
+          <a:bodyPr/>
+          <a:lstStyle/>
+          <a:p>
+            <a:r>
+              <a:t>選擇權買方主要願意為 TP 衝擊付風險補償；利率由政策預期主導時，VRP 反而萎縮</a:t>
+            </a:r>
+          </a:p>
+        </p:txBody>
+      </p:sp>
+      <p:sp>
+        <p:nvSpPr>
+          <p:cNvPr id="4" name="Title 3"/>
+          <p:cNvSpPr>
+            <a:spLocks noGrp="1"/>
+          </p:cNvSpPr>
+          <p:nvPr>
+            <p:ph type="title"/>
+          </p:nvPr>
+        </p:nvSpPr>
+        <p:spPr>
+          <a:xfrm>
+            <a:off x="411480" y="192024"/>
+            <a:ext cx="11329416" cy="548640"/>
+          </a:xfrm>
+        </p:spPr>
+        <p:txBody>
+          <a:bodyPr/>
+          <a:lstStyle/>
+          <a:p>
+            <a:r>
+              <a:t>框架：VRP 擴張的條件是 TP 失序，不只是 TP 上升</a:t>
+            </a:r>
+          </a:p>
+        </p:txBody>
+      </p:sp>
+      <p:graphicFrame>
+        <p:nvGraphicFramePr>
+          <p:cNvPr id="5" name="Table 4"/>
+          <p:cNvGraphicFramePr>
+            <a:graphicFrameLocks noGrp="1"/>
+          </p:cNvGraphicFramePr>
+          <p:nvPr/>
+        </p:nvGraphicFramePr>
+        <p:xfrm>
+          <a:off x="411480" y="1783080"/>
+          <a:ext cx="6949440" cy="3840480"/>
+        </p:xfrm>
+        <a:graphic>
+          <a:graphicData uri="http://schemas.openxmlformats.org/drawingml/2006/table">
+            <a:tbl>
+              <a:tblPr firstRow="1" bandRow="1">
+                <a:tableStyleId>{5940675A-B579-460E-94D1-54222C63F5DA}</a:tableStyleId>
+              </a:tblPr>
+              <a:tblGrid>
+                <a:gridCol w="1554480"/>
+                <a:gridCol w="2697480"/>
+                <a:gridCol w="2697480"/>
+              </a:tblGrid>
+              <a:tr h="548640">
+                <a:tc>
+                  <a:txBody>
+                    <a:bodyPr wrap="square"/>
+                    <a:lstStyle/>
+                    <a:p>
+                      <a:r>
+                        <a:rPr b="1" sz="1300">
+                          <a:solidFill>
+                            <a:srgbClr val="FFFFFF"/>
+                          </a:solidFill>
+                        </a:rPr>
+                        <a:t>面向</a:t>
+                      </a:r>
+                    </a:p>
+                  </a:txBody>
+                  <a:tcPr marL="73152" marR="73152" marT="27432" marB="27432" anchor="ctr">
+                    <a:solidFill>
+                      <a:srgbClr val="234976"/>
+                    </a:solidFill>
+                  </a:tcPr>
+                </a:tc>
+                <a:tc>
+                  <a:txBody>
+                    <a:bodyPr wrap="square"/>
+                    <a:lstStyle/>
+                    <a:p>
+                      <a:r>
+                        <a:rPr b="1" sz="1300">
+                          <a:solidFill>
+                            <a:srgbClr val="FFFFFF"/>
+                          </a:solidFill>
+                        </a:rPr>
+                        <a:t>預期主導</a:t>
+                      </a:r>
+                    </a:p>
+                  </a:txBody>
+                  <a:tcPr marL="73152" marR="73152" marT="27432" marB="27432" anchor="ctr">
+                    <a:solidFill>
+                      <a:srgbClr val="234976"/>
+                    </a:solidFill>
+                  </a:tcPr>
+                </a:tc>
+                <a:tc>
+                  <a:txBody>
+                    <a:bodyPr wrap="square"/>
+                    <a:lstStyle/>
+                    <a:p>
+                      <a:r>
+                        <a:rPr b="1" sz="1300">
+                          <a:solidFill>
+                            <a:srgbClr val="FFFFFF"/>
+                          </a:solidFill>
+                        </a:rPr>
+                        <a:t>TP 主導（失序）</a:t>
+                      </a:r>
+                    </a:p>
+                  </a:txBody>
+                  <a:tcPr marL="73152" marR="73152" marT="27432" marB="27432" anchor="ctr">
+                    <a:solidFill>
+                      <a:srgbClr val="234976"/>
+                    </a:solidFill>
+                  </a:tcPr>
+                </a:tc>
+              </a:tr>
+              <a:tr h="548640">
+                <a:tc>
+                  <a:txBody>
+                    <a:bodyPr wrap="square"/>
+                    <a:lstStyle/>
+                    <a:p>
+                      <a:r>
+                        <a:rPr b="1" sz="1300">
+                          <a:solidFill>
+                            <a:srgbClr val="1F1F1F"/>
+                          </a:solidFill>
+                        </a:rPr>
+                        <a:t>驅動</a:t>
+                      </a:r>
+                    </a:p>
+                  </a:txBody>
+                  <a:tcPr marL="73152" marR="73152" marT="27432" marB="27432" anchor="ctr">
+                    <a:solidFill>
+                      <a:srgbClr val="FFFFFF"/>
+                    </a:solidFill>
+                  </a:tcPr>
+                </a:tc>
+                <a:tc>
+                  <a:txBody>
+                    <a:bodyPr wrap="square"/>
+                    <a:lstStyle/>
+                    <a:p>
+                      <a:r>
+                        <a:rPr sz="1300">
+                          <a:solidFill>
+                            <a:srgbClr val="1F1F1F"/>
+                          </a:solidFill>
+                        </a:rPr>
+                        <a:t>總經數據＋央行 Reaction Function</a:t>
+                      </a:r>
+                    </a:p>
+                  </a:txBody>
+                  <a:tcPr marL="73152" marR="73152" marT="27432" marB="27432" anchor="ctr">
+                    <a:solidFill>
+                      <a:srgbClr val="FFFFFF"/>
+                    </a:solidFill>
+                  </a:tcPr>
+                </a:tc>
+                <a:tc>
+                  <a:txBody>
+                    <a:bodyPr wrap="square"/>
+                    <a:lstStyle/>
+                    <a:p>
+                      <a:r>
+                        <a:rPr sz="1300">
+                          <a:solidFill>
+                            <a:srgbClr val="1F1F1F"/>
+                          </a:solidFill>
+                        </a:rPr>
+                        <a:t>財政、供給、流動性、持有者結構</a:t>
+                      </a:r>
+                    </a:p>
+                  </a:txBody>
+                  <a:tcPr marL="73152" marR="73152" marT="27432" marB="27432" anchor="ctr">
+                    <a:solidFill>
+                      <a:srgbClr val="FFFFFF"/>
+                    </a:solidFill>
+                  </a:tcPr>
+                </a:tc>
+              </a:tr>
+              <a:tr h="548640">
+                <a:tc>
+                  <a:txBody>
+                    <a:bodyPr wrap="square"/>
+                    <a:lstStyle/>
+                    <a:p>
+                      <a:r>
+                        <a:rPr b="1" sz="1300">
+                          <a:solidFill>
+                            <a:srgbClr val="1F1F1F"/>
+                          </a:solidFill>
+                        </a:rPr>
+                        <a:t>避險工具</a:t>
+                      </a:r>
+                    </a:p>
+                  </a:txBody>
+                  <a:tcPr marL="73152" marR="73152" marT="27432" marB="27432" anchor="ctr">
+                    <a:solidFill>
+                      <a:srgbClr val="EEF3F8"/>
+                    </a:solidFill>
+                  </a:tcPr>
+                </a:tc>
+                <a:tc>
+                  <a:txBody>
+                    <a:bodyPr wrap="square"/>
+                    <a:lstStyle/>
+                    <a:p>
+                      <a:r>
+                        <a:rPr sz="1300">
+                          <a:solidFill>
+                            <a:srgbClr val="1F1F1F"/>
+                          </a:solidFill>
+                        </a:rPr>
+                        <a:t>線性：SOFR / FF Futures、OIS、T-Bills</a:t>
+                      </a:r>
+                    </a:p>
+                  </a:txBody>
+                  <a:tcPr marL="73152" marR="73152" marT="27432" marB="27432" anchor="ctr">
+                    <a:solidFill>
+                      <a:srgbClr val="EEF3F8"/>
+                    </a:solidFill>
+                  </a:tcPr>
+                </a:tc>
+                <a:tc>
+                  <a:txBody>
+                    <a:bodyPr wrap="square"/>
+                    <a:lstStyle/>
+                    <a:p>
+                      <a:r>
+                        <a:rPr sz="1300">
+                          <a:solidFill>
+                            <a:srgbClr val="1F1F1F"/>
+                          </a:solidFill>
+                        </a:rPr>
+                        <a:t>非線性：Deep OTM Payer Swaptions</a:t>
+                      </a:r>
+                    </a:p>
+                  </a:txBody>
+                  <a:tcPr marL="73152" marR="73152" marT="27432" marB="27432" anchor="ctr">
+                    <a:solidFill>
+                      <a:srgbClr val="EEF3F8"/>
+                    </a:solidFill>
+                  </a:tcPr>
+                </a:tc>
+              </a:tr>
+              <a:tr h="548640">
+                <a:tc>
+                  <a:txBody>
+                    <a:bodyPr wrap="square"/>
+                    <a:lstStyle/>
+                    <a:p>
+                      <a:r>
+                        <a:rPr b="1" sz="1300">
+                          <a:solidFill>
+                            <a:srgbClr val="1F1F1F"/>
+                          </a:solidFill>
+                        </a:rPr>
+                        <a:t>買方價格敏感度</a:t>
+                      </a:r>
+                    </a:p>
+                  </a:txBody>
+                  <a:tcPr marL="73152" marR="73152" marT="27432" marB="27432" anchor="ctr">
+                    <a:solidFill>
+                      <a:srgbClr val="FFFFFF"/>
+                    </a:solidFill>
+                  </a:tcPr>
+                </a:tc>
+                <a:tc>
+                  <a:txBody>
+                    <a:bodyPr wrap="square"/>
+                    <a:lstStyle/>
+                    <a:p>
+                      <a:r>
+                        <a:rPr sz="1300">
+                          <a:solidFill>
+                            <a:srgbClr val="1F1F1F"/>
+                          </a:solidFill>
+                        </a:rPr>
+                        <a:t>高</a:t>
+                      </a:r>
+                    </a:p>
+                  </a:txBody>
+                  <a:tcPr marL="73152" marR="73152" marT="27432" marB="27432" anchor="ctr">
+                    <a:solidFill>
+                      <a:srgbClr val="FFFFFF"/>
+                    </a:solidFill>
+                  </a:tcPr>
+                </a:tc>
+                <a:tc>
+                  <a:txBody>
+                    <a:bodyPr wrap="square"/>
+                    <a:lstStyle/>
+                    <a:p>
+                      <a:r>
+                        <a:rPr sz="1300">
+                          <a:solidFill>
+                            <a:srgbClr val="1F1F1F"/>
+                          </a:solidFill>
+                        </a:rPr>
+                        <a:t>極低</a:t>
+                      </a:r>
+                    </a:p>
+                  </a:txBody>
+                  <a:tcPr marL="73152" marR="73152" marT="27432" marB="27432" anchor="ctr">
+                    <a:solidFill>
+                      <a:srgbClr val="FFFFFF"/>
+                    </a:solidFill>
+                  </a:tcPr>
+                </a:tc>
+              </a:tr>
+              <a:tr h="548640">
+                <a:tc>
+                  <a:txBody>
+                    <a:bodyPr wrap="square"/>
+                    <a:lstStyle/>
+                    <a:p>
+                      <a:r>
+                        <a:rPr b="1" sz="1300">
+                          <a:solidFill>
+                            <a:srgbClr val="1F1F1F"/>
+                          </a:solidFill>
+                        </a:rPr>
+                        <a:t>分佈</a:t>
+                      </a:r>
+                    </a:p>
+                  </a:txBody>
+                  <a:tcPr marL="73152" marR="73152" marT="27432" marB="27432" anchor="ctr">
+                    <a:solidFill>
+                      <a:srgbClr val="EEF3F8"/>
+                    </a:solidFill>
+                  </a:tcPr>
+                </a:tc>
+                <a:tc>
+                  <a:txBody>
+                    <a:bodyPr wrap="square"/>
+                    <a:lstStyle/>
+                    <a:p>
+                      <a:r>
+                        <a:rPr sz="1300">
+                          <a:solidFill>
+                            <a:srgbClr val="1F1F1F"/>
+                          </a:solidFill>
+                        </a:rPr>
+                        <a:t>均值回歸、有邊界</a:t>
+                      </a:r>
+                    </a:p>
+                  </a:txBody>
+                  <a:tcPr marL="73152" marR="73152" marT="27432" marB="27432" anchor="ctr">
+                    <a:solidFill>
+                      <a:srgbClr val="EEF3F8"/>
+                    </a:solidFill>
+                  </a:tcPr>
+                </a:tc>
+                <a:tc>
+                  <a:txBody>
+                    <a:bodyPr wrap="square"/>
+                    <a:lstStyle/>
+                    <a:p>
+                      <a:r>
+                        <a:rPr sz="1300">
+                          <a:solidFill>
+                            <a:srgbClr val="1F1F1F"/>
+                          </a:solidFill>
+                        </a:rPr>
+                        <a:t>自我強化、肥尾</a:t>
+                      </a:r>
+                    </a:p>
+                  </a:txBody>
+                  <a:tcPr marL="73152" marR="73152" marT="27432" marB="27432" anchor="ctr">
+                    <a:solidFill>
+                      <a:srgbClr val="EEF3F8"/>
+                    </a:solidFill>
+                  </a:tcPr>
+                </a:tc>
+              </a:tr>
+              <a:tr h="548640">
+                <a:tc>
+                  <a:txBody>
+                    <a:bodyPr wrap="square"/>
+                    <a:lstStyle/>
+                    <a:p>
+                      <a:r>
+                        <a:rPr b="1" sz="1300">
+                          <a:solidFill>
+                            <a:srgbClr val="1F1F1F"/>
+                          </a:solidFill>
+                        </a:rPr>
+                        <a:t>主要參與者</a:t>
+                      </a:r>
+                    </a:p>
+                  </a:txBody>
+                  <a:tcPr marL="73152" marR="73152" marT="27432" marB="27432" anchor="ctr">
+                    <a:solidFill>
+                      <a:srgbClr val="FFFFFF"/>
+                    </a:solidFill>
+                  </a:tcPr>
+                </a:tc>
+                <a:tc>
+                  <a:txBody>
+                    <a:bodyPr wrap="square"/>
+                    <a:lstStyle/>
+                    <a:p>
+                      <a:r>
+                        <a:rPr sz="1300">
+                          <a:solidFill>
+                            <a:srgbClr val="1F1F1F"/>
+                          </a:solidFill>
+                        </a:rPr>
+                        <a:t>宏觀 HF、RV 基金、量化</a:t>
+                      </a:r>
+                    </a:p>
+                  </a:txBody>
+                  <a:tcPr marL="73152" marR="73152" marT="27432" marB="27432" anchor="ctr">
+                    <a:solidFill>
+                      <a:srgbClr val="FFFFFF"/>
+                    </a:solidFill>
+                  </a:tcPr>
+                </a:tc>
+                <a:tc>
+                  <a:txBody>
+                    <a:bodyPr wrap="square"/>
+                    <a:lstStyle/>
+                    <a:p>
+                      <a:r>
+                        <a:rPr sz="1300">
+                          <a:solidFill>
+                            <a:srgbClr val="1F1F1F"/>
+                          </a:solidFill>
+                        </a:rPr>
+                        <a:t>Pension、Lifers、Sovereign</a:t>
+                      </a:r>
+                    </a:p>
+                  </a:txBody>
+                  <a:tcPr marL="73152" marR="73152" marT="27432" marB="27432" anchor="ctr">
+                    <a:solidFill>
+                      <a:srgbClr val="FFFFFF"/>
+                    </a:solidFill>
+                  </a:tcPr>
+                </a:tc>
+              </a:tr>
+              <a:tr h="548640">
+                <a:tc>
+                  <a:txBody>
+                    <a:bodyPr wrap="square"/>
+                    <a:lstStyle/>
+                    <a:p>
+                      <a:r>
+                        <a:rPr b="1" sz="1300">
+                          <a:solidFill>
+                            <a:srgbClr val="1F1F1F"/>
+                          </a:solidFill>
+                        </a:rPr>
+                        <a:t>VRP</a:t>
+                      </a:r>
+                    </a:p>
+                  </a:txBody>
+                  <a:tcPr marL="73152" marR="73152" marT="27432" marB="27432" anchor="ctr">
+                    <a:solidFill>
+                      <a:srgbClr val="EEF3F8"/>
+                    </a:solidFill>
+                  </a:tcPr>
+                </a:tc>
+                <a:tc>
+                  <a:txBody>
+                    <a:bodyPr wrap="square"/>
+                    <a:lstStyle/>
+                    <a:p>
+                      <a:r>
+                        <a:rPr sz="1300">
+                          <a:solidFill>
+                            <a:srgbClr val="E83F0A"/>
+                          </a:solidFill>
+                        </a:rPr>
+                        <a:t>萎縮</a:t>
+                      </a:r>
+                    </a:p>
+                  </a:txBody>
+                  <a:tcPr marL="73152" marR="73152" marT="27432" marB="27432" anchor="ctr">
+                    <a:solidFill>
+                      <a:srgbClr val="EEF3F8"/>
+                    </a:solidFill>
+                  </a:tcPr>
+                </a:tc>
+                <a:tc>
+                  <a:txBody>
+                    <a:bodyPr wrap="square"/>
+                    <a:lstStyle/>
+                    <a:p>
+                      <a:r>
+                        <a:rPr sz="1300">
+                          <a:solidFill>
+                            <a:srgbClr val="E83F0A"/>
+                          </a:solidFill>
+                        </a:rPr>
+                        <a:t>擴張</a:t>
+                      </a:r>
+                    </a:p>
+                  </a:txBody>
+                  <a:tcPr marL="73152" marR="73152" marT="27432" marB="27432" anchor="ctr">
+                    <a:solidFill>
+                      <a:srgbClr val="EEF3F8"/>
+                    </a:solidFill>
+                  </a:tcPr>
+                </a:tc>
+              </a:tr>
+            </a:tbl>
+          </a:graphicData>
+        </a:graphic>
+      </p:graphicFrame>
+      <p:sp>
+        <p:nvSpPr>
+          <p:cNvPr id="6" name="Rectangle 5"/>
+          <p:cNvSpPr/>
+          <p:nvPr/>
+        </p:nvSpPr>
+        <p:spPr>
+          <a:xfrm>
+            <a:off x="7635240" y="1783080"/>
+            <a:ext cx="4114800" cy="3566160"/>
+          </a:xfrm>
+          <a:prstGeom prst="rect">
+            <a:avLst/>
+          </a:prstGeom>
+          <a:solidFill>
+            <a:srgbClr val="EEF3F8"/>
+          </a:solidFill>
+          <a:ln>
+            <a:noFill/>
+          </a:ln>
+          <a:effectLst/>
+        </p:spPr>
+        <p:style>
+          <a:lnRef idx="1">
+            <a:schemeClr val="accent1"/>
+          </a:lnRef>
+          <a:fillRef idx="3">
+            <a:schemeClr val="accent1"/>
+          </a:fillRef>
+          <a:effectRef idx="2">
+            <a:schemeClr val="accent1"/>
+          </a:effectRef>
+          <a:fontRef idx="minor">
+            <a:schemeClr val="lt1"/>
+          </a:fontRef>
+        </p:style>
+        <p:txBody>
+          <a:bodyPr rtlCol="0" anchor="ctr"/>
+          <a:lstStyle/>
+          <a:p>
+            <a:pPr algn="ctr"/>
+          </a:p>
+        </p:txBody>
+      </p:sp>
+      <p:sp>
+        <p:nvSpPr>
+          <p:cNvPr id="7" name="TextBox 6"/>
+          <p:cNvSpPr txBox="1"/>
+          <p:nvPr/>
+        </p:nvSpPr>
+        <p:spPr>
+          <a:xfrm>
+            <a:off x="7818120" y="1920240"/>
+            <a:ext cx="3794760" cy="3657600"/>
+          </a:xfrm>
+          <a:prstGeom prst="rect">
+            <a:avLst/>
+          </a:prstGeom>
+          <a:noFill/>
+        </p:spPr>
+        <p:txBody>
+          <a:bodyPr wrap="square" lIns="45720" rIns="45720" anchor="t">
+            <a:spAutoFit/>
+          </a:bodyPr>
+          <a:lstStyle/>
+          <a:p>
+            <a:pPr algn="l"/>
+            <a:r>
+              <a:rPr b="1" sz="1800">
+                <a:solidFill>
+                  <a:srgbClr val="234976"/>
+                </a:solidFill>
+              </a:rPr>
+              <a:t>延伸：失序才是關鍵</a:t>
+            </a:r>
+          </a:p>
+          <a:p>
+            <a:pPr algn="l"/>
+            <a:r>
+              <a:rPr sz="1400">
+                <a:solidFill>
+                  <a:srgbClr val="1F1F1F"/>
+                </a:solidFill>
+              </a:rPr>
+              <a:t>7–8 月 TP 有序上升，IV 沒有跟上；真正推高 VRP 的是失序特徵：做市商受限、Repo Haircut 加大、保證金追繳引發拋售循環。</a:t>
+            </a:r>
+          </a:p>
+          <a:p>
+            <a:pPr algn="l"/>
+            <a:r>
+              <a:rPr sz="800">
+                <a:solidFill>
+                  <a:srgbClr val="1F1F1F"/>
+                </a:solidFill>
+              </a:rPr>
+              <a:t/>
+            </a:r>
+          </a:p>
+          <a:p>
+            <a:pPr algn="l"/>
+            <a:r>
+              <a:rPr b="1" sz="1800">
+                <a:solidFill>
+                  <a:srgbClr val="E83F0A"/>
+                </a:solidFill>
+              </a:rPr>
+              <a:t>數據顯示：初期失序</a:t>
+            </a:r>
+          </a:p>
+          <a:p>
+            <a:pPr algn="l"/>
+            <a:r>
+              <a:rPr sz="1400">
+                <a:solidFill>
+                  <a:srgbClr val="1F1F1F"/>
+                </a:solidFill>
+              </a:rPr>
+              <a:t>9/23 起 TP 加速、HY 利差 +52 bp，IV − RV 才從 +4 擴大到 +15；MOVE 跳升約六成來自實際波動上升。</a:t>
+            </a:r>
+          </a:p>
+        </p:txBody>
+      </p:sp>
+    </p:spTree>
+  </p:cSld>
+  <p:clrMapOvr>
+    <a:masterClrMapping/>
+  </p:clrMapOvr>
+</p:sld>
+</file>
+
+<file path=ppt/slides/slide11.xml><?xml version="1.0" encoding="utf-8"?>
+<p:sld xmlns:a="http://schemas.openxmlformats.org/drawingml/2006/main" xmlns:p="http://schemas.openxmlformats.org/presentationml/2006/main" xmlns:r="http://schemas.openxmlformats.org/officeDocument/2006/relationships">
+  <p:cSld>
+    <p:spTree>
+      <p:nvGrpSpPr>
+        <p:cNvPr id="1" name=""/>
+        <p:cNvGrpSpPr/>
+        <p:nvPr/>
+      </p:nvGrpSpPr>
+      <p:grpSpPr/>
+      <p:sp>
+        <p:nvSpPr>
           <p:cNvPr id="2" name="Content Placeholder 1"/>
           <p:cNvSpPr>
             <a:spLocks noGrp="1"/>
@@ -47224,7 +47964,7 @@
 </p:sld>
 </file>
 
-<file path=ppt/slides/slide11.xml><?xml version="1.0" encoding="utf-8"?>
+<file path=ppt/slides/slide12.xml><?xml version="1.0" encoding="utf-8"?>
 <p:sld xmlns:a="http://schemas.openxmlformats.org/drawingml/2006/main" xmlns:p="http://schemas.openxmlformats.org/presentationml/2006/main" xmlns:r="http://schemas.openxmlformats.org/officeDocument/2006/relationships">
   <p:cSld>
     <p:spTree>
@@ -48358,7 +49098,7 @@
 </p:sld>
 </file>
 
-<file path=ppt/slides/slide12.xml><?xml version="1.0" encoding="utf-8"?>
+<file path=ppt/slides/slide13.xml><?xml version="1.0" encoding="utf-8"?>
 <p:sld xmlns:a="http://schemas.openxmlformats.org/drawingml/2006/main" xmlns:p="http://schemas.openxmlformats.org/presentationml/2006/main" xmlns:r="http://schemas.openxmlformats.org/officeDocument/2006/relationships">
   <p:cSld>
     <p:spTree>
@@ -48541,7 +49281,7 @@
 </p:sld>
 </file>
 
-<file path=ppt/slides/slide13.xml><?xml version="1.0" encoding="utf-8"?>
+<file path=ppt/slides/slide14.xml><?xml version="1.0" encoding="utf-8"?>
 <p:sld xmlns:a="http://schemas.openxmlformats.org/drawingml/2006/main" xmlns:p="http://schemas.openxmlformats.org/presentationml/2006/main" xmlns:r="http://schemas.openxmlformats.org/officeDocument/2006/relationships">
   <p:cSld>
     <p:spTree>
@@ -49036,7 +49776,7 @@
 </p:sld>
 </file>
 
-<file path=ppt/slides/slide14.xml><?xml version="1.0" encoding="utf-8"?>
+<file path=ppt/slides/slide15.xml><?xml version="1.0" encoding="utf-8"?>
 <p:sld xmlns:a="http://schemas.openxmlformats.org/drawingml/2006/main" xmlns:p="http://schemas.openxmlformats.org/presentationml/2006/main" xmlns:r="http://schemas.openxmlformats.org/officeDocument/2006/relationships">
   <p:cSld>
     <p:spTree>
@@ -49950,7 +50690,7 @@
 </p:sld>
 </file>
 
-<file path=ppt/slides/slide15.xml><?xml version="1.0" encoding="utf-8"?>
+<file path=ppt/slides/slide16.xml><?xml version="1.0" encoding="utf-8"?>
 <p:sld xmlns:a="http://schemas.openxmlformats.org/drawingml/2006/main" xmlns:p="http://schemas.openxmlformats.org/presentationml/2006/main" xmlns:r="http://schemas.openxmlformats.org/officeDocument/2006/relationships">
   <p:cSld>
     <p:spTree>
@@ -50371,7 +51111,7 @@
 </p:sld>
 </file>
 
-<file path=ppt/slides/slide16.xml><?xml version="1.0" encoding="utf-8"?>
+<file path=ppt/slides/slide17.xml><?xml version="1.0" encoding="utf-8"?>
 <p:sld xmlns:a="http://schemas.openxmlformats.org/drawingml/2006/main" xmlns:r="http://schemas.openxmlformats.org/officeDocument/2006/relationships" xmlns:p="http://schemas.openxmlformats.org/presentationml/2006/main">
   <p:cSld>
     <p:spTree>
@@ -51860,6 +52600,774 @@
           <a:lstStyle/>
           <a:p>
             <a:r>
+              <a:t>兩個 Fed 研究模型：KW 拆出名目 TP；DKW 加入 TIPS，再拆出實質利率與通膨</a:t>
+            </a:r>
+          </a:p>
+        </p:txBody>
+      </p:sp>
+      <p:sp>
+        <p:nvSpPr>
+          <p:cNvPr id="4" name="Title 3"/>
+          <p:cNvSpPr>
+            <a:spLocks noGrp="1"/>
+          </p:cNvSpPr>
+          <p:nvPr>
+            <p:ph type="title"/>
+          </p:nvPr>
+        </p:nvSpPr>
+        <p:spPr>
+          <a:xfrm>
+            <a:off x="411480" y="192024"/>
+            <a:ext cx="11329416" cy="548640"/>
+          </a:xfrm>
+        </p:spPr>
+        <p:txBody>
+          <a:bodyPr/>
+          <a:lstStyle/>
+          <a:p>
+            <a:r>
+              <a:t>方法：Kim-Wright 與 DKW 怎麼拆 10Y 殖利率</a:t>
+            </a:r>
+          </a:p>
+        </p:txBody>
+      </p:sp>
+      <p:graphicFrame>
+        <p:nvGraphicFramePr>
+          <p:cNvPr id="5" name="Table 4"/>
+          <p:cNvGraphicFramePr>
+            <a:graphicFrameLocks noGrp="1"/>
+          </p:cNvGraphicFramePr>
+          <p:nvPr/>
+        </p:nvGraphicFramePr>
+        <p:xfrm>
+          <a:off x="411480" y="1783080"/>
+          <a:ext cx="6949440" cy="3840480"/>
+        </p:xfrm>
+        <a:graphic>
+          <a:graphicData uri="http://schemas.openxmlformats.org/drawingml/2006/table">
+            <a:tbl>
+              <a:tblPr firstRow="1" bandRow="1">
+                <a:tableStyleId>{5940675A-B579-460E-94D1-54222C63F5DA}</a:tableStyleId>
+              </a:tblPr>
+              <a:tblGrid>
+                <a:gridCol w="1600200"/>
+                <a:gridCol w="2331720"/>
+                <a:gridCol w="3017520"/>
+              </a:tblGrid>
+              <a:tr h="548640">
+                <a:tc>
+                  <a:txBody>
+                    <a:bodyPr wrap="square"/>
+                    <a:lstStyle/>
+                    <a:p>
+                      <a:r>
+                        <a:rPr b="1" sz="1200">
+                          <a:solidFill>
+                            <a:srgbClr val="FFFFFF"/>
+                          </a:solidFill>
+                        </a:rPr>
+                        <a:t>項目</a:t>
+                      </a:r>
+                    </a:p>
+                  </a:txBody>
+                  <a:tcPr marL="73152" marR="73152" marT="27432" marB="27432" anchor="ctr">
+                    <a:solidFill>
+                      <a:srgbClr val="234976"/>
+                    </a:solidFill>
+                  </a:tcPr>
+                </a:tc>
+                <a:tc>
+                  <a:txBody>
+                    <a:bodyPr wrap="square"/>
+                    <a:lstStyle/>
+                    <a:p>
+                      <a:r>
+                        <a:rPr b="1" sz="1200">
+                          <a:solidFill>
+                            <a:srgbClr val="FFFFFF"/>
+                          </a:solidFill>
+                        </a:rPr>
+                        <a:t>Kim-Wright（KW）</a:t>
+                      </a:r>
+                    </a:p>
+                  </a:txBody>
+                  <a:tcPr marL="73152" marR="73152" marT="27432" marB="27432" anchor="ctr">
+                    <a:solidFill>
+                      <a:srgbClr val="234976"/>
+                    </a:solidFill>
+                  </a:tcPr>
+                </a:tc>
+                <a:tc>
+                  <a:txBody>
+                    <a:bodyPr wrap="square"/>
+                    <a:lstStyle/>
+                    <a:p>
+                      <a:r>
+                        <a:rPr b="1" sz="1200">
+                          <a:solidFill>
+                            <a:srgbClr val="FFFFFF"/>
+                          </a:solidFill>
+                        </a:rPr>
+                        <a:t>DKW</a:t>
+                      </a:r>
+                    </a:p>
+                  </a:txBody>
+                  <a:tcPr marL="73152" marR="73152" marT="27432" marB="27432" anchor="ctr">
+                    <a:solidFill>
+                      <a:srgbClr val="234976"/>
+                    </a:solidFill>
+                  </a:tcPr>
+                </a:tc>
+              </a:tr>
+              <a:tr h="548640">
+                <a:tc>
+                  <a:txBody>
+                    <a:bodyPr wrap="square"/>
+                    <a:lstStyle/>
+                    <a:p>
+                      <a:r>
+                        <a:rPr b="1" sz="1200">
+                          <a:solidFill>
+                            <a:srgbClr val="1F1F1F"/>
+                          </a:solidFill>
+                        </a:rPr>
+                        <a:t>出處</a:t>
+                      </a:r>
+                    </a:p>
+                  </a:txBody>
+                  <a:tcPr marL="73152" marR="73152" marT="27432" marB="27432" anchor="ctr">
+                    <a:solidFill>
+                      <a:srgbClr val="FFFFFF"/>
+                    </a:solidFill>
+                  </a:tcPr>
+                </a:tc>
+                <a:tc>
+                  <a:txBody>
+                    <a:bodyPr wrap="square"/>
+                    <a:lstStyle/>
+                    <a:p>
+                      <a:r>
+                        <a:rPr sz="1200">
+                          <a:solidFill>
+                            <a:srgbClr val="1F1F1F"/>
+                          </a:solidFill>
+                        </a:rPr>
+                        <a:t>Kim &amp; Wright（2005）</a:t>
+                      </a:r>
+                    </a:p>
+                  </a:txBody>
+                  <a:tcPr marL="73152" marR="73152" marT="27432" marB="27432" anchor="ctr">
+                    <a:solidFill>
+                      <a:srgbClr val="FFFFFF"/>
+                    </a:solidFill>
+                  </a:tcPr>
+                </a:tc>
+                <a:tc>
+                  <a:txBody>
+                    <a:bodyPr wrap="square"/>
+                    <a:lstStyle/>
+                    <a:p>
+                      <a:r>
+                        <a:rPr sz="1200">
+                          <a:solidFill>
+                            <a:srgbClr val="1F1F1F"/>
+                          </a:solidFill>
+                        </a:rPr>
+                        <a:t>D'Amico, Kim &amp; Wei（2018）；2019 年更新</a:t>
+                      </a:r>
+                    </a:p>
+                  </a:txBody>
+                  <a:tcPr marL="73152" marR="73152" marT="27432" marB="27432" anchor="ctr">
+                    <a:solidFill>
+                      <a:srgbClr val="FFFFFF"/>
+                    </a:solidFill>
+                  </a:tcPr>
+                </a:tc>
+              </a:tr>
+              <a:tr h="548640">
+                <a:tc>
+                  <a:txBody>
+                    <a:bodyPr wrap="square"/>
+                    <a:lstStyle/>
+                    <a:p>
+                      <a:r>
+                        <a:rPr b="1" sz="1200">
+                          <a:solidFill>
+                            <a:srgbClr val="1F1F1F"/>
+                          </a:solidFill>
+                        </a:rPr>
+                        <a:t>用到的資料</a:t>
+                      </a:r>
+                    </a:p>
+                  </a:txBody>
+                  <a:tcPr marL="73152" marR="73152" marT="27432" marB="27432" anchor="ctr">
+                    <a:solidFill>
+                      <a:srgbClr val="EEF3F8"/>
+                    </a:solidFill>
+                  </a:tcPr>
+                </a:tc>
+                <a:tc>
+                  <a:txBody>
+                    <a:bodyPr wrap="square"/>
+                    <a:lstStyle/>
+                    <a:p>
+                      <a:r>
+                        <a:rPr sz="1200">
+                          <a:solidFill>
+                            <a:srgbClr val="1F1F1F"/>
+                          </a:solidFill>
+                        </a:rPr>
+                        <a:t>名目公債殖利率、短率調查預測</a:t>
+                      </a:r>
+                    </a:p>
+                  </a:txBody>
+                  <a:tcPr marL="73152" marR="73152" marT="27432" marB="27432" anchor="ctr">
+                    <a:solidFill>
+                      <a:srgbClr val="EEF3F8"/>
+                    </a:solidFill>
+                  </a:tcPr>
+                </a:tc>
+                <a:tc>
+                  <a:txBody>
+                    <a:bodyPr wrap="square"/>
+                    <a:lstStyle/>
+                    <a:p>
+                      <a:r>
+                        <a:rPr sz="1200">
+                          <a:solidFill>
+                            <a:srgbClr val="1F1F1F"/>
+                          </a:solidFill>
+                        </a:rPr>
+                        <a:t>名目公債＋TIPS 殖利率、通膨資料、短率與通膨調查預測</a:t>
+                      </a:r>
+                    </a:p>
+                  </a:txBody>
+                  <a:tcPr marL="73152" marR="73152" marT="27432" marB="27432" anchor="ctr">
+                    <a:solidFill>
+                      <a:srgbClr val="EEF3F8"/>
+                    </a:solidFill>
+                  </a:tcPr>
+                </a:tc>
+              </a:tr>
+              <a:tr h="548640">
+                <a:tc>
+                  <a:txBody>
+                    <a:bodyPr wrap="square"/>
+                    <a:lstStyle/>
+                    <a:p>
+                      <a:r>
+                        <a:rPr b="1" sz="1200">
+                          <a:solidFill>
+                            <a:srgbClr val="1F1F1F"/>
+                          </a:solidFill>
+                        </a:rPr>
+                        <a:t>拆得出的成分</a:t>
+                      </a:r>
+                    </a:p>
+                  </a:txBody>
+                  <a:tcPr marL="73152" marR="73152" marT="27432" marB="27432" anchor="ctr">
+                    <a:solidFill>
+                      <a:srgbClr val="FFFFFF"/>
+                    </a:solidFill>
+                  </a:tcPr>
+                </a:tc>
+                <a:tc>
+                  <a:txBody>
+                    <a:bodyPr wrap="square"/>
+                    <a:lstStyle/>
+                    <a:p>
+                      <a:r>
+                        <a:rPr sz="1200">
+                          <a:solidFill>
+                            <a:srgbClr val="1F1F1F"/>
+                          </a:solidFill>
+                        </a:rPr>
+                        <a:t>預期平均短率、名目 TP</a:t>
+                      </a:r>
+                    </a:p>
+                  </a:txBody>
+                  <a:tcPr marL="73152" marR="73152" marT="27432" marB="27432" anchor="ctr">
+                    <a:solidFill>
+                      <a:srgbClr val="FFFFFF"/>
+                    </a:solidFill>
+                  </a:tcPr>
+                </a:tc>
+                <a:tc>
+                  <a:txBody>
+                    <a:bodyPr wrap="square"/>
+                    <a:lstStyle/>
+                    <a:p>
+                      <a:r>
+                        <a:rPr sz="1200">
+                          <a:solidFill>
+                            <a:srgbClr val="1F1F1F"/>
+                          </a:solidFill>
+                        </a:rPr>
+                        <a:t>預期實質短率、實質 TP、預期通膨、通膨風險溢酬、TIPS 流動性溢酬</a:t>
+                      </a:r>
+                    </a:p>
+                  </a:txBody>
+                  <a:tcPr marL="73152" marR="73152" marT="27432" marB="27432" anchor="ctr">
+                    <a:solidFill>
+                      <a:srgbClr val="FFFFFF"/>
+                    </a:solidFill>
+                  </a:tcPr>
+                </a:tc>
+              </a:tr>
+              <a:tr h="548640">
+                <a:tc>
+                  <a:txBody>
+                    <a:bodyPr wrap="square"/>
+                    <a:lstStyle/>
+                    <a:p>
+                      <a:r>
+                        <a:rPr b="1" sz="1200">
+                          <a:solidFill>
+                            <a:srgbClr val="1F1F1F"/>
+                          </a:solidFill>
+                        </a:rPr>
+                        <a:t>更新頻率</a:t>
+                      </a:r>
+                    </a:p>
+                  </a:txBody>
+                  <a:tcPr marL="73152" marR="73152" marT="27432" marB="27432" anchor="ctr">
+                    <a:solidFill>
+                      <a:srgbClr val="EEF3F8"/>
+                    </a:solidFill>
+                  </a:tcPr>
+                </a:tc>
+                <a:tc>
+                  <a:txBody>
+                    <a:bodyPr wrap="square"/>
+                    <a:lstStyle/>
+                    <a:p>
+                      <a:r>
+                        <a:rPr sz="1200">
+                          <a:solidFill>
+                            <a:srgbClr val="1F1F1F"/>
+                          </a:solidFill>
+                        </a:rPr>
+                        <a:t>日資料（FRED THREEFYTP10）</a:t>
+                      </a:r>
+                    </a:p>
+                  </a:txBody>
+                  <a:tcPr marL="73152" marR="73152" marT="27432" marB="27432" anchor="ctr">
+                    <a:solidFill>
+                      <a:srgbClr val="EEF3F8"/>
+                    </a:solidFill>
+                  </a:tcPr>
+                </a:tc>
+                <a:tc>
+                  <a:txBody>
+                    <a:bodyPr wrap="square"/>
+                    <a:lstStyle/>
+                    <a:p>
+                      <a:r>
+                        <a:rPr sz="1200">
+                          <a:solidFill>
+                            <a:srgbClr val="1F1F1F"/>
+                          </a:solidFill>
+                        </a:rPr>
+                        <a:t>每月（Fed staff）</a:t>
+                      </a:r>
+                    </a:p>
+                  </a:txBody>
+                  <a:tcPr marL="73152" marR="73152" marT="27432" marB="27432" anchor="ctr">
+                    <a:solidFill>
+                      <a:srgbClr val="EEF3F8"/>
+                    </a:solidFill>
+                  </a:tcPr>
+                </a:tc>
+              </a:tr>
+              <a:tr h="548640">
+                <a:tc>
+                  <a:txBody>
+                    <a:bodyPr wrap="square"/>
+                    <a:lstStyle/>
+                    <a:p>
+                      <a:r>
+                        <a:rPr b="1" sz="1200">
+                          <a:solidFill>
+                            <a:srgbClr val="1F1F1F"/>
+                          </a:solidFill>
+                        </a:rPr>
+                        <a:t>本報告用途</a:t>
+                      </a:r>
+                    </a:p>
+                  </a:txBody>
+                  <a:tcPr marL="73152" marR="73152" marT="27432" marB="27432" anchor="ctr">
+                    <a:solidFill>
+                      <a:srgbClr val="FFFFFF"/>
+                    </a:solidFill>
+                  </a:tcPr>
+                </a:tc>
+                <a:tc>
+                  <a:txBody>
+                    <a:bodyPr wrap="square"/>
+                    <a:lstStyle/>
+                    <a:p>
+                      <a:r>
+                        <a:rPr sz="1200">
+                          <a:solidFill>
+                            <a:srgbClr val="1F1F1F"/>
+                          </a:solidFill>
+                        </a:rPr>
+                        <a:t>9 月以後的最新變化、交叉驗證</a:t>
+                      </a:r>
+                    </a:p>
+                  </a:txBody>
+                  <a:tcPr marL="73152" marR="73152" marT="27432" marB="27432" anchor="ctr">
+                    <a:solidFill>
+                      <a:srgbClr val="FFFFFF"/>
+                    </a:solidFill>
+                  </a:tcPr>
+                </a:tc>
+                <a:tc>
+                  <a:txBody>
+                    <a:bodyPr wrap="square"/>
+                    <a:lstStyle/>
+                    <a:p>
+                      <a:r>
+                        <a:rPr sz="1200">
+                          <a:solidFill>
+                            <a:srgbClr val="1F1F1F"/>
+                          </a:solidFill>
+                        </a:rPr>
+                        <a:t>主軸：拆開實質利率與通膨</a:t>
+                      </a:r>
+                    </a:p>
+                  </a:txBody>
+                  <a:tcPr marL="73152" marR="73152" marT="27432" marB="27432" anchor="ctr">
+                    <a:solidFill>
+                      <a:srgbClr val="FFFFFF"/>
+                    </a:solidFill>
+                  </a:tcPr>
+                </a:tc>
+              </a:tr>
+              <a:tr h="548640">
+                <a:tc>
+                  <a:txBody>
+                    <a:bodyPr wrap="square"/>
+                    <a:lstStyle/>
+                    <a:p>
+                      <a:r>
+                        <a:rPr b="1" sz="1200">
+                          <a:solidFill>
+                            <a:srgbClr val="1F1F1F"/>
+                          </a:solidFill>
+                        </a:rPr>
+                        <a:t>名目 TP 今年以來（至 8/31）</a:t>
+                      </a:r>
+                    </a:p>
+                  </a:txBody>
+                  <a:tcPr marL="73152" marR="73152" marT="27432" marB="27432" anchor="ctr">
+                    <a:solidFill>
+                      <a:srgbClr val="EEF3F8"/>
+                    </a:solidFill>
+                  </a:tcPr>
+                </a:tc>
+                <a:tc>
+                  <a:txBody>
+                    <a:bodyPr wrap="square"/>
+                    <a:lstStyle/>
+                    <a:p>
+                      <a:r>
+                        <a:rPr sz="1200">
+                          <a:solidFill>
+                            <a:srgbClr val="E83F0A"/>
+                          </a:solidFill>
+                        </a:rPr>
+                        <a:t>+31 bp</a:t>
+                      </a:r>
+                    </a:p>
+                  </a:txBody>
+                  <a:tcPr marL="73152" marR="73152" marT="27432" marB="27432" anchor="ctr">
+                    <a:solidFill>
+                      <a:srgbClr val="EEF3F8"/>
+                    </a:solidFill>
+                  </a:tcPr>
+                </a:tc>
+                <a:tc>
+                  <a:txBody>
+                    <a:bodyPr wrap="square"/>
+                    <a:lstStyle/>
+                    <a:p>
+                      <a:r>
+                        <a:rPr sz="1200">
+                          <a:solidFill>
+                            <a:srgbClr val="E83F0A"/>
+                          </a:solidFill>
+                        </a:rPr>
+                        <a:t>+20 bp</a:t>
+                      </a:r>
+                    </a:p>
+                  </a:txBody>
+                  <a:tcPr marL="73152" marR="73152" marT="27432" marB="27432" anchor="ctr">
+                    <a:solidFill>
+                      <a:srgbClr val="EEF3F8"/>
+                    </a:solidFill>
+                  </a:tcPr>
+                </a:tc>
+              </a:tr>
+            </a:tbl>
+          </a:graphicData>
+        </a:graphic>
+      </p:graphicFrame>
+      <p:sp>
+        <p:nvSpPr>
+          <p:cNvPr id="6" name="Rectangle 5"/>
+          <p:cNvSpPr/>
+          <p:nvPr/>
+        </p:nvSpPr>
+        <p:spPr>
+          <a:xfrm>
+            <a:off x="7635240" y="1783080"/>
+            <a:ext cx="4114800" cy="3886200"/>
+          </a:xfrm>
+          <a:prstGeom prst="rect">
+            <a:avLst/>
+          </a:prstGeom>
+          <a:solidFill>
+            <a:srgbClr val="EEF3F8"/>
+          </a:solidFill>
+          <a:ln>
+            <a:noFill/>
+          </a:ln>
+          <a:effectLst/>
+        </p:spPr>
+        <p:style>
+          <a:lnRef idx="1">
+            <a:schemeClr val="accent1"/>
+          </a:lnRef>
+          <a:fillRef idx="3">
+            <a:schemeClr val="accent1"/>
+          </a:fillRef>
+          <a:effectRef idx="2">
+            <a:schemeClr val="accent1"/>
+          </a:effectRef>
+          <a:fontRef idx="minor">
+            <a:schemeClr val="lt1"/>
+          </a:fontRef>
+        </p:style>
+        <p:txBody>
+          <a:bodyPr rtlCol="0" anchor="ctr"/>
+          <a:lstStyle/>
+          <a:p>
+            <a:pPr algn="ctr"/>
+          </a:p>
+        </p:txBody>
+      </p:sp>
+      <p:sp>
+        <p:nvSpPr>
+          <p:cNvPr id="7" name="TextBox 6"/>
+          <p:cNvSpPr txBox="1"/>
+          <p:nvPr/>
+        </p:nvSpPr>
+        <p:spPr>
+          <a:xfrm>
+            <a:off x="7818120" y="1874519"/>
+            <a:ext cx="3794760" cy="3749039"/>
+          </a:xfrm>
+          <a:prstGeom prst="rect">
+            <a:avLst/>
+          </a:prstGeom>
+          <a:noFill/>
+        </p:spPr>
+        <p:txBody>
+          <a:bodyPr wrap="square" lIns="45720" rIns="45720" anchor="t">
+            <a:spAutoFit/>
+          </a:bodyPr>
+          <a:lstStyle/>
+          <a:p>
+            <a:pPr algn="l"/>
+            <a:r>
+              <a:rPr b="1" sz="1800">
+                <a:solidFill>
+                  <a:srgbClr val="234976"/>
+                </a:solidFill>
+              </a:rPr>
+              <a:t>拆解公式</a:t>
+            </a:r>
+          </a:p>
+          <a:p>
+            <a:pPr algn="l"/>
+            <a:r>
+              <a:rPr b="1" sz="1400">
+                <a:solidFill>
+                  <a:srgbClr val="0065B2"/>
+                </a:solidFill>
+              </a:rPr>
+              <a:t>Kim-Wright</a:t>
+            </a:r>
+          </a:p>
+          <a:p>
+            <a:pPr algn="l"/>
+            <a:r>
+              <a:rPr sz="1400">
+                <a:solidFill>
+                  <a:srgbClr val="1F1F1F"/>
+                </a:solidFill>
+              </a:rPr>
+              <a:t>10Y 殖利率 ＝ 預期平均短率 ＋ 名目 TP</a:t>
+            </a:r>
+          </a:p>
+          <a:p>
+            <a:pPr algn="l"/>
+            <a:r>
+              <a:rPr sz="800">
+                <a:solidFill>
+                  <a:srgbClr val="1F1F1F"/>
+                </a:solidFill>
+              </a:rPr>
+              <a:t/>
+            </a:r>
+          </a:p>
+          <a:p>
+            <a:pPr algn="l"/>
+            <a:r>
+              <a:rPr b="1" sz="1400">
+                <a:solidFill>
+                  <a:srgbClr val="0065B2"/>
+                </a:solidFill>
+              </a:rPr>
+              <a:t>DKW</a:t>
+            </a:r>
+          </a:p>
+          <a:p>
+            <a:pPr algn="l"/>
+            <a:r>
+              <a:rPr sz="1400">
+                <a:solidFill>
+                  <a:srgbClr val="1F1F1F"/>
+                </a:solidFill>
+              </a:rPr>
+              <a:t>10Y 殖利率 ＝ 預期實質短率 ＋ 實質 TP</a:t>
+            </a:r>
+          </a:p>
+          <a:p>
+            <a:pPr algn="l"/>
+            <a:r>
+              <a:rPr sz="1400">
+                <a:solidFill>
+                  <a:srgbClr val="1F1F1F"/>
+                </a:solidFill>
+              </a:rPr>
+              <a:t>　　　　　＋ 預期通膨 ＋ 通膨風險溢酬</a:t>
+            </a:r>
+          </a:p>
+          <a:p>
+            <a:pPr algn="l"/>
+            <a:r>
+              <a:rPr sz="1400">
+                <a:solidFill>
+                  <a:srgbClr val="1F1F1F"/>
+                </a:solidFill>
+              </a:rPr>
+              <a:t>TIPS 殖利率 ＝ 預期實質短率 ＋ 實質 TP</a:t>
+            </a:r>
+          </a:p>
+          <a:p>
+            <a:pPr algn="l"/>
+            <a:r>
+              <a:rPr sz="1400">
+                <a:solidFill>
+                  <a:srgbClr val="1F1F1F"/>
+                </a:solidFill>
+              </a:rPr>
+              <a:t>　　　　　＋ 流動性溢酬</a:t>
+            </a:r>
+          </a:p>
+          <a:p>
+            <a:pPr algn="l"/>
+            <a:r>
+              <a:rPr sz="1400">
+                <a:solidFill>
+                  <a:srgbClr val="1F1F1F"/>
+                </a:solidFill>
+              </a:rPr>
+              <a:t>BEI ＝ 預期通膨 ＋ 通膨風險溢酬</a:t>
+            </a:r>
+          </a:p>
+          <a:p>
+            <a:pPr algn="l"/>
+            <a:r>
+              <a:rPr sz="1400">
+                <a:solidFill>
+                  <a:srgbClr val="1F1F1F"/>
+                </a:solidFill>
+              </a:rPr>
+              <a:t>　　　 − 流動性溢酬</a:t>
+            </a:r>
+          </a:p>
+          <a:p>
+            <a:pPr algn="l"/>
+            <a:r>
+              <a:rPr b="1" sz="1400">
+                <a:solidFill>
+                  <a:srgbClr val="1F1F1F"/>
+                </a:solidFill>
+              </a:rPr>
+              <a:t>名目 TP ＝ 實質 TP ＋ 通膨風險溢酬</a:t>
+            </a:r>
+          </a:p>
+          <a:p>
+            <a:pPr algn="l"/>
+            <a:r>
+              <a:rPr sz="800">
+                <a:solidFill>
+                  <a:srgbClr val="1F1F1F"/>
+                </a:solidFill>
+              </a:rPr>
+              <a:t/>
+            </a:r>
+          </a:p>
+          <a:p>
+            <a:pPr algn="l"/>
+            <a:r>
+              <a:rPr sz="1200">
+                <a:solidFill>
+                  <a:srgbClr val="595959"/>
+                </a:solidFill>
+              </a:rPr>
+              <a:t>兩者都出自 Fed 的 Don Kim，並非完全獨立；紐約 Fed 的 ACM 方法不同，可做交叉驗證。</a:t>
+            </a:r>
+          </a:p>
+        </p:txBody>
+      </p:sp>
+    </p:spTree>
+  </p:cSld>
+  <p:clrMapOvr>
+    <a:masterClrMapping/>
+  </p:clrMapOvr>
+</p:sld>
+</file>
+
+<file path=ppt/slides/slide6.xml><?xml version="1.0" encoding="utf-8"?>
+<p:sld xmlns:a="http://schemas.openxmlformats.org/drawingml/2006/main" xmlns:p="http://schemas.openxmlformats.org/presentationml/2006/main" xmlns:r="http://schemas.openxmlformats.org/officeDocument/2006/relationships">
+  <p:cSld>
+    <p:spTree>
+      <p:nvGrpSpPr>
+        <p:cNvPr id="1" name=""/>
+        <p:cNvGrpSpPr/>
+        <p:nvPr/>
+      </p:nvGrpSpPr>
+      <p:grpSpPr/>
+      <p:sp>
+        <p:nvSpPr>
+          <p:cNvPr id="3" name="Text Placeholder 2"/>
+          <p:cNvSpPr>
+            <a:spLocks noGrp="1"/>
+          </p:cNvSpPr>
+          <p:nvPr>
+            <p:ph type="body" idx="15" sz="quarter"/>
+          </p:nvPr>
+        </p:nvSpPr>
+        <p:spPr/>
+        <p:txBody>
+          <a:bodyPr/>
+          <a:lstStyle/>
+          <a:p>
+            <a:r>
               <a:t>Kim-Wright 10Y TP 今年以來上升約 45 bp，多半發生在 7 月之後</a:t>
             </a:r>
           </a:p>
@@ -52175,7 +53683,7 @@
 </p:sld>
 </file>
 
-<file path=ppt/slides/slide6.xml><?xml version="1.0" encoding="utf-8"?>
+<file path=ppt/slides/slide7.xml><?xml version="1.0" encoding="utf-8"?>
 <p:sld xmlns:a="http://schemas.openxmlformats.org/drawingml/2006/main" xmlns:p="http://schemas.openxmlformats.org/presentationml/2006/main" xmlns:r="http://schemas.openxmlformats.org/officeDocument/2006/relationships">
   <p:cSld>
     <p:spTree>
@@ -52343,7 +53851,7 @@
 </p:sld>
 </file>
 
-<file path=ppt/slides/slide7.xml><?xml version="1.0" encoding="utf-8"?>
+<file path=ppt/slides/slide8.xml><?xml version="1.0" encoding="utf-8"?>
 <p:sld xmlns:a="http://schemas.openxmlformats.org/drawingml/2006/main" xmlns:p="http://schemas.openxmlformats.org/presentationml/2006/main" xmlns:r="http://schemas.openxmlformats.org/officeDocument/2006/relationships">
   <p:cSld>
     <p:spTree>
@@ -53007,7 +54515,7 @@
 </p:sld>
 </file>
 
-<file path=ppt/slides/slide8.xml><?xml version="1.0" encoding="utf-8"?>
+<file path=ppt/slides/slide9.xml><?xml version="1.0" encoding="utf-8"?>
 <p:sld xmlns:a="http://schemas.openxmlformats.org/drawingml/2006/main" xmlns:p="http://schemas.openxmlformats.org/presentationml/2006/main" xmlns:r="http://schemas.openxmlformats.org/officeDocument/2006/relationships">
   <p:cSld>
     <p:spTree>
@@ -53709,675 +55217,6 @@
           </a:graphicData>
         </a:graphic>
       </p:graphicFrame>
-    </p:spTree>
-  </p:cSld>
-  <p:clrMapOvr>
-    <a:masterClrMapping/>
-  </p:clrMapOvr>
-</p:sld>
-</file>
-
-<file path=ppt/slides/slide9.xml><?xml version="1.0" encoding="utf-8"?>
-<p:sld xmlns:a="http://schemas.openxmlformats.org/drawingml/2006/main" xmlns:p="http://schemas.openxmlformats.org/presentationml/2006/main" xmlns:r="http://schemas.openxmlformats.org/officeDocument/2006/relationships">
-  <p:cSld>
-    <p:spTree>
-      <p:nvGrpSpPr>
-        <p:cNvPr id="1" name=""/>
-        <p:cNvGrpSpPr/>
-        <p:nvPr/>
-      </p:nvGrpSpPr>
-      <p:grpSpPr/>
-      <p:sp>
-        <p:nvSpPr>
-          <p:cNvPr id="3" name="Text Placeholder 2"/>
-          <p:cNvSpPr>
-            <a:spLocks noGrp="1"/>
-          </p:cNvSpPr>
-          <p:nvPr>
-            <p:ph type="body" idx="15" sz="quarter"/>
-          </p:nvPr>
-        </p:nvSpPr>
-        <p:spPr/>
-        <p:txBody>
-          <a:bodyPr/>
-          <a:lstStyle/>
-          <a:p>
-            <a:r>
-              <a:t>選擇權買方主要願意為 TP 衝擊付風險補償；利率由政策預期主導時，VRP 反而萎縮</a:t>
-            </a:r>
-          </a:p>
-        </p:txBody>
-      </p:sp>
-      <p:sp>
-        <p:nvSpPr>
-          <p:cNvPr id="4" name="Title 3"/>
-          <p:cNvSpPr>
-            <a:spLocks noGrp="1"/>
-          </p:cNvSpPr>
-          <p:nvPr>
-            <p:ph type="title"/>
-          </p:nvPr>
-        </p:nvSpPr>
-        <p:spPr>
-          <a:xfrm>
-            <a:off x="411480" y="192024"/>
-            <a:ext cx="11329416" cy="548640"/>
-          </a:xfrm>
-        </p:spPr>
-        <p:txBody>
-          <a:bodyPr/>
-          <a:lstStyle/>
-          <a:p>
-            <a:r>
-              <a:t>框架：VRP 擴張的條件是 TP 失序，不只是 TP 上升</a:t>
-            </a:r>
-          </a:p>
-        </p:txBody>
-      </p:sp>
-      <p:graphicFrame>
-        <p:nvGraphicFramePr>
-          <p:cNvPr id="5" name="Table 4"/>
-          <p:cNvGraphicFramePr>
-            <a:graphicFrameLocks noGrp="1"/>
-          </p:cNvGraphicFramePr>
-          <p:nvPr/>
-        </p:nvGraphicFramePr>
-        <p:xfrm>
-          <a:off x="411480" y="1783080"/>
-          <a:ext cx="6949440" cy="3840480"/>
-        </p:xfrm>
-        <a:graphic>
-          <a:graphicData uri="http://schemas.openxmlformats.org/drawingml/2006/table">
-            <a:tbl>
-              <a:tblPr firstRow="1" bandRow="1">
-                <a:tableStyleId>{5940675A-B579-460E-94D1-54222C63F5DA}</a:tableStyleId>
-              </a:tblPr>
-              <a:tblGrid>
-                <a:gridCol w="1554480"/>
-                <a:gridCol w="2697480"/>
-                <a:gridCol w="2697480"/>
-              </a:tblGrid>
-              <a:tr h="548640">
-                <a:tc>
-                  <a:txBody>
-                    <a:bodyPr wrap="square"/>
-                    <a:lstStyle/>
-                    <a:p>
-                      <a:r>
-                        <a:rPr b="1" sz="1300">
-                          <a:solidFill>
-                            <a:srgbClr val="FFFFFF"/>
-                          </a:solidFill>
-                        </a:rPr>
-                        <a:t>面向</a:t>
-                      </a:r>
-                    </a:p>
-                  </a:txBody>
-                  <a:tcPr marL="73152" marR="73152" marT="27432" marB="27432" anchor="ctr">
-                    <a:solidFill>
-                      <a:srgbClr val="234976"/>
-                    </a:solidFill>
-                  </a:tcPr>
-                </a:tc>
-                <a:tc>
-                  <a:txBody>
-                    <a:bodyPr wrap="square"/>
-                    <a:lstStyle/>
-                    <a:p>
-                      <a:r>
-                        <a:rPr b="1" sz="1300">
-                          <a:solidFill>
-                            <a:srgbClr val="FFFFFF"/>
-                          </a:solidFill>
-                        </a:rPr>
-                        <a:t>預期主導</a:t>
-                      </a:r>
-                    </a:p>
-                  </a:txBody>
-                  <a:tcPr marL="73152" marR="73152" marT="27432" marB="27432" anchor="ctr">
-                    <a:solidFill>
-                      <a:srgbClr val="234976"/>
-                    </a:solidFill>
-                  </a:tcPr>
-                </a:tc>
-                <a:tc>
-                  <a:txBody>
-                    <a:bodyPr wrap="square"/>
-                    <a:lstStyle/>
-                    <a:p>
-                      <a:r>
-                        <a:rPr b="1" sz="1300">
-                          <a:solidFill>
-                            <a:srgbClr val="FFFFFF"/>
-                          </a:solidFill>
-                        </a:rPr>
-                        <a:t>TP 主導（失序）</a:t>
-                      </a:r>
-                    </a:p>
-                  </a:txBody>
-                  <a:tcPr marL="73152" marR="73152" marT="27432" marB="27432" anchor="ctr">
-                    <a:solidFill>
-                      <a:srgbClr val="234976"/>
-                    </a:solidFill>
-                  </a:tcPr>
-                </a:tc>
-              </a:tr>
-              <a:tr h="548640">
-                <a:tc>
-                  <a:txBody>
-                    <a:bodyPr wrap="square"/>
-                    <a:lstStyle/>
-                    <a:p>
-                      <a:r>
-                        <a:rPr b="1" sz="1300">
-                          <a:solidFill>
-                            <a:srgbClr val="1F1F1F"/>
-                          </a:solidFill>
-                        </a:rPr>
-                        <a:t>驅動</a:t>
-                      </a:r>
-                    </a:p>
-                  </a:txBody>
-                  <a:tcPr marL="73152" marR="73152" marT="27432" marB="27432" anchor="ctr">
-                    <a:solidFill>
-                      <a:srgbClr val="FFFFFF"/>
-                    </a:solidFill>
-                  </a:tcPr>
-                </a:tc>
-                <a:tc>
-                  <a:txBody>
-                    <a:bodyPr wrap="square"/>
-                    <a:lstStyle/>
-                    <a:p>
-                      <a:r>
-                        <a:rPr sz="1300">
-                          <a:solidFill>
-                            <a:srgbClr val="1F1F1F"/>
-                          </a:solidFill>
-                        </a:rPr>
-                        <a:t>總經數據＋央行 Reaction Function</a:t>
-                      </a:r>
-                    </a:p>
-                  </a:txBody>
-                  <a:tcPr marL="73152" marR="73152" marT="27432" marB="27432" anchor="ctr">
-                    <a:solidFill>
-                      <a:srgbClr val="FFFFFF"/>
-                    </a:solidFill>
-                  </a:tcPr>
-                </a:tc>
-                <a:tc>
-                  <a:txBody>
-                    <a:bodyPr wrap="square"/>
-                    <a:lstStyle/>
-                    <a:p>
-                      <a:r>
-                        <a:rPr sz="1300">
-                          <a:solidFill>
-                            <a:srgbClr val="1F1F1F"/>
-                          </a:solidFill>
-                        </a:rPr>
-                        <a:t>財政、供給、流動性、持有者結構</a:t>
-                      </a:r>
-                    </a:p>
-                  </a:txBody>
-                  <a:tcPr marL="73152" marR="73152" marT="27432" marB="27432" anchor="ctr">
-                    <a:solidFill>
-                      <a:srgbClr val="FFFFFF"/>
-                    </a:solidFill>
-                  </a:tcPr>
-                </a:tc>
-              </a:tr>
-              <a:tr h="548640">
-                <a:tc>
-                  <a:txBody>
-                    <a:bodyPr wrap="square"/>
-                    <a:lstStyle/>
-                    <a:p>
-                      <a:r>
-                        <a:rPr b="1" sz="1300">
-                          <a:solidFill>
-                            <a:srgbClr val="1F1F1F"/>
-                          </a:solidFill>
-                        </a:rPr>
-                        <a:t>避險工具</a:t>
-                      </a:r>
-                    </a:p>
-                  </a:txBody>
-                  <a:tcPr marL="73152" marR="73152" marT="27432" marB="27432" anchor="ctr">
-                    <a:solidFill>
-                      <a:srgbClr val="EEF3F8"/>
-                    </a:solidFill>
-                  </a:tcPr>
-                </a:tc>
-                <a:tc>
-                  <a:txBody>
-                    <a:bodyPr wrap="square"/>
-                    <a:lstStyle/>
-                    <a:p>
-                      <a:r>
-                        <a:rPr sz="1300">
-                          <a:solidFill>
-                            <a:srgbClr val="1F1F1F"/>
-                          </a:solidFill>
-                        </a:rPr>
-                        <a:t>線性：SOFR / FF Futures、OIS、T-Bills</a:t>
-                      </a:r>
-                    </a:p>
-                  </a:txBody>
-                  <a:tcPr marL="73152" marR="73152" marT="27432" marB="27432" anchor="ctr">
-                    <a:solidFill>
-                      <a:srgbClr val="EEF3F8"/>
-                    </a:solidFill>
-                  </a:tcPr>
-                </a:tc>
-                <a:tc>
-                  <a:txBody>
-                    <a:bodyPr wrap="square"/>
-                    <a:lstStyle/>
-                    <a:p>
-                      <a:r>
-                        <a:rPr sz="1300">
-                          <a:solidFill>
-                            <a:srgbClr val="1F1F1F"/>
-                          </a:solidFill>
-                        </a:rPr>
-                        <a:t>非線性：Deep OTM Payer Swaptions</a:t>
-                      </a:r>
-                    </a:p>
-                  </a:txBody>
-                  <a:tcPr marL="73152" marR="73152" marT="27432" marB="27432" anchor="ctr">
-                    <a:solidFill>
-                      <a:srgbClr val="EEF3F8"/>
-                    </a:solidFill>
-                  </a:tcPr>
-                </a:tc>
-              </a:tr>
-              <a:tr h="548640">
-                <a:tc>
-                  <a:txBody>
-                    <a:bodyPr wrap="square"/>
-                    <a:lstStyle/>
-                    <a:p>
-                      <a:r>
-                        <a:rPr b="1" sz="1300">
-                          <a:solidFill>
-                            <a:srgbClr val="1F1F1F"/>
-                          </a:solidFill>
-                        </a:rPr>
-                        <a:t>買方價格敏感度</a:t>
-                      </a:r>
-                    </a:p>
-                  </a:txBody>
-                  <a:tcPr marL="73152" marR="73152" marT="27432" marB="27432" anchor="ctr">
-                    <a:solidFill>
-                      <a:srgbClr val="FFFFFF"/>
-                    </a:solidFill>
-                  </a:tcPr>
-                </a:tc>
-                <a:tc>
-                  <a:txBody>
-                    <a:bodyPr wrap="square"/>
-                    <a:lstStyle/>
-                    <a:p>
-                      <a:r>
-                        <a:rPr sz="1300">
-                          <a:solidFill>
-                            <a:srgbClr val="1F1F1F"/>
-                          </a:solidFill>
-                        </a:rPr>
-                        <a:t>高</a:t>
-                      </a:r>
-                    </a:p>
-                  </a:txBody>
-                  <a:tcPr marL="73152" marR="73152" marT="27432" marB="27432" anchor="ctr">
-                    <a:solidFill>
-                      <a:srgbClr val="FFFFFF"/>
-                    </a:solidFill>
-                  </a:tcPr>
-                </a:tc>
-                <a:tc>
-                  <a:txBody>
-                    <a:bodyPr wrap="square"/>
-                    <a:lstStyle/>
-                    <a:p>
-                      <a:r>
-                        <a:rPr sz="1300">
-                          <a:solidFill>
-                            <a:srgbClr val="1F1F1F"/>
-                          </a:solidFill>
-                        </a:rPr>
-                        <a:t>極低</a:t>
-                      </a:r>
-                    </a:p>
-                  </a:txBody>
-                  <a:tcPr marL="73152" marR="73152" marT="27432" marB="27432" anchor="ctr">
-                    <a:solidFill>
-                      <a:srgbClr val="FFFFFF"/>
-                    </a:solidFill>
-                  </a:tcPr>
-                </a:tc>
-              </a:tr>
-              <a:tr h="548640">
-                <a:tc>
-                  <a:txBody>
-                    <a:bodyPr wrap="square"/>
-                    <a:lstStyle/>
-                    <a:p>
-                      <a:r>
-                        <a:rPr b="1" sz="1300">
-                          <a:solidFill>
-                            <a:srgbClr val="1F1F1F"/>
-                          </a:solidFill>
-                        </a:rPr>
-                        <a:t>分佈</a:t>
-                      </a:r>
-                    </a:p>
-                  </a:txBody>
-                  <a:tcPr marL="73152" marR="73152" marT="27432" marB="27432" anchor="ctr">
-                    <a:solidFill>
-                      <a:srgbClr val="EEF3F8"/>
-                    </a:solidFill>
-                  </a:tcPr>
-                </a:tc>
-                <a:tc>
-                  <a:txBody>
-                    <a:bodyPr wrap="square"/>
-                    <a:lstStyle/>
-                    <a:p>
-                      <a:r>
-                        <a:rPr sz="1300">
-                          <a:solidFill>
-                            <a:srgbClr val="1F1F1F"/>
-                          </a:solidFill>
-                        </a:rPr>
-                        <a:t>均值回歸、有邊界</a:t>
-                      </a:r>
-                    </a:p>
-                  </a:txBody>
-                  <a:tcPr marL="73152" marR="73152" marT="27432" marB="27432" anchor="ctr">
-                    <a:solidFill>
-                      <a:srgbClr val="EEF3F8"/>
-                    </a:solidFill>
-                  </a:tcPr>
-                </a:tc>
-                <a:tc>
-                  <a:txBody>
-                    <a:bodyPr wrap="square"/>
-                    <a:lstStyle/>
-                    <a:p>
-                      <a:r>
-                        <a:rPr sz="1300">
-                          <a:solidFill>
-                            <a:srgbClr val="1F1F1F"/>
-                          </a:solidFill>
-                        </a:rPr>
-                        <a:t>自我強化、肥尾</a:t>
-                      </a:r>
-                    </a:p>
-                  </a:txBody>
-                  <a:tcPr marL="73152" marR="73152" marT="27432" marB="27432" anchor="ctr">
-                    <a:solidFill>
-                      <a:srgbClr val="EEF3F8"/>
-                    </a:solidFill>
-                  </a:tcPr>
-                </a:tc>
-              </a:tr>
-              <a:tr h="548640">
-                <a:tc>
-                  <a:txBody>
-                    <a:bodyPr wrap="square"/>
-                    <a:lstStyle/>
-                    <a:p>
-                      <a:r>
-                        <a:rPr b="1" sz="1300">
-                          <a:solidFill>
-                            <a:srgbClr val="1F1F1F"/>
-                          </a:solidFill>
-                        </a:rPr>
-                        <a:t>主要參與者</a:t>
-                      </a:r>
-                    </a:p>
-                  </a:txBody>
-                  <a:tcPr marL="73152" marR="73152" marT="27432" marB="27432" anchor="ctr">
-                    <a:solidFill>
-                      <a:srgbClr val="FFFFFF"/>
-                    </a:solidFill>
-                  </a:tcPr>
-                </a:tc>
-                <a:tc>
-                  <a:txBody>
-                    <a:bodyPr wrap="square"/>
-                    <a:lstStyle/>
-                    <a:p>
-                      <a:r>
-                        <a:rPr sz="1300">
-                          <a:solidFill>
-                            <a:srgbClr val="1F1F1F"/>
-                          </a:solidFill>
-                        </a:rPr>
-                        <a:t>宏觀 HF、RV 基金、量化</a:t>
-                      </a:r>
-                    </a:p>
-                  </a:txBody>
-                  <a:tcPr marL="73152" marR="73152" marT="27432" marB="27432" anchor="ctr">
-                    <a:solidFill>
-                      <a:srgbClr val="FFFFFF"/>
-                    </a:solidFill>
-                  </a:tcPr>
-                </a:tc>
-                <a:tc>
-                  <a:txBody>
-                    <a:bodyPr wrap="square"/>
-                    <a:lstStyle/>
-                    <a:p>
-                      <a:r>
-                        <a:rPr sz="1300">
-                          <a:solidFill>
-                            <a:srgbClr val="1F1F1F"/>
-                          </a:solidFill>
-                        </a:rPr>
-                        <a:t>Pension、Lifers、Sovereign</a:t>
-                      </a:r>
-                    </a:p>
-                  </a:txBody>
-                  <a:tcPr marL="73152" marR="73152" marT="27432" marB="27432" anchor="ctr">
-                    <a:solidFill>
-                      <a:srgbClr val="FFFFFF"/>
-                    </a:solidFill>
-                  </a:tcPr>
-                </a:tc>
-              </a:tr>
-              <a:tr h="548640">
-                <a:tc>
-                  <a:txBody>
-                    <a:bodyPr wrap="square"/>
-                    <a:lstStyle/>
-                    <a:p>
-                      <a:r>
-                        <a:rPr b="1" sz="1300">
-                          <a:solidFill>
-                            <a:srgbClr val="1F1F1F"/>
-                          </a:solidFill>
-                        </a:rPr>
-                        <a:t>VRP</a:t>
-                      </a:r>
-                    </a:p>
-                  </a:txBody>
-                  <a:tcPr marL="73152" marR="73152" marT="27432" marB="27432" anchor="ctr">
-                    <a:solidFill>
-                      <a:srgbClr val="EEF3F8"/>
-                    </a:solidFill>
-                  </a:tcPr>
-                </a:tc>
-                <a:tc>
-                  <a:txBody>
-                    <a:bodyPr wrap="square"/>
-                    <a:lstStyle/>
-                    <a:p>
-                      <a:r>
-                        <a:rPr sz="1300">
-                          <a:solidFill>
-                            <a:srgbClr val="E83F0A"/>
-                          </a:solidFill>
-                        </a:rPr>
-                        <a:t>萎縮</a:t>
-                      </a:r>
-                    </a:p>
-                  </a:txBody>
-                  <a:tcPr marL="73152" marR="73152" marT="27432" marB="27432" anchor="ctr">
-                    <a:solidFill>
-                      <a:srgbClr val="EEF3F8"/>
-                    </a:solidFill>
-                  </a:tcPr>
-                </a:tc>
-                <a:tc>
-                  <a:txBody>
-                    <a:bodyPr wrap="square"/>
-                    <a:lstStyle/>
-                    <a:p>
-                      <a:r>
-                        <a:rPr sz="1300">
-                          <a:solidFill>
-                            <a:srgbClr val="E83F0A"/>
-                          </a:solidFill>
-                        </a:rPr>
-                        <a:t>擴張</a:t>
-                      </a:r>
-                    </a:p>
-                  </a:txBody>
-                  <a:tcPr marL="73152" marR="73152" marT="27432" marB="27432" anchor="ctr">
-                    <a:solidFill>
-                      <a:srgbClr val="EEF3F8"/>
-                    </a:solidFill>
-                  </a:tcPr>
-                </a:tc>
-              </a:tr>
-            </a:tbl>
-          </a:graphicData>
-        </a:graphic>
-      </p:graphicFrame>
-      <p:sp>
-        <p:nvSpPr>
-          <p:cNvPr id="6" name="Rectangle 5"/>
-          <p:cNvSpPr/>
-          <p:nvPr/>
-        </p:nvSpPr>
-        <p:spPr>
-          <a:xfrm>
-            <a:off x="7635240" y="1783080"/>
-            <a:ext cx="4114800" cy="3566160"/>
-          </a:xfrm>
-          <a:prstGeom prst="rect">
-            <a:avLst/>
-          </a:prstGeom>
-          <a:solidFill>
-            <a:srgbClr val="EEF3F8"/>
-          </a:solidFill>
-          <a:ln>
-            <a:noFill/>
-          </a:ln>
-          <a:effectLst/>
-        </p:spPr>
-        <p:style>
-          <a:lnRef idx="1">
-            <a:schemeClr val="accent1"/>
-          </a:lnRef>
-          <a:fillRef idx="3">
-            <a:schemeClr val="accent1"/>
-          </a:fillRef>
-          <a:effectRef idx="2">
-            <a:schemeClr val="accent1"/>
-          </a:effectRef>
-          <a:fontRef idx="minor">
-            <a:schemeClr val="lt1"/>
-          </a:fontRef>
-        </p:style>
-        <p:txBody>
-          <a:bodyPr rtlCol="0" anchor="ctr"/>
-          <a:lstStyle/>
-          <a:p>
-            <a:pPr algn="ctr"/>
-          </a:p>
-        </p:txBody>
-      </p:sp>
-      <p:sp>
-        <p:nvSpPr>
-          <p:cNvPr id="7" name="TextBox 6"/>
-          <p:cNvSpPr txBox="1"/>
-          <p:nvPr/>
-        </p:nvSpPr>
-        <p:spPr>
-          <a:xfrm>
-            <a:off x="7818120" y="1920240"/>
-            <a:ext cx="3794760" cy="3657600"/>
-          </a:xfrm>
-          <a:prstGeom prst="rect">
-            <a:avLst/>
-          </a:prstGeom>
-          <a:noFill/>
-        </p:spPr>
-        <p:txBody>
-          <a:bodyPr wrap="square" lIns="45720" rIns="45720" anchor="t">
-            <a:spAutoFit/>
-          </a:bodyPr>
-          <a:lstStyle/>
-          <a:p>
-            <a:pPr algn="l"/>
-            <a:r>
-              <a:rPr b="1" sz="1800">
-                <a:solidFill>
-                  <a:srgbClr val="234976"/>
-                </a:solidFill>
-              </a:rPr>
-              <a:t>延伸：失序才是關鍵</a:t>
-            </a:r>
-          </a:p>
-          <a:p>
-            <a:pPr algn="l"/>
-            <a:r>
-              <a:rPr sz="1400">
-                <a:solidFill>
-                  <a:srgbClr val="1F1F1F"/>
-                </a:solidFill>
-              </a:rPr>
-              <a:t>7–8 月 TP 有序上升，IV 沒有跟上；真正推高 VRP 的是失序特徵：做市商受限、Repo Haircut 加大、保證金追繳引發拋售循環。</a:t>
-            </a:r>
-          </a:p>
-          <a:p>
-            <a:pPr algn="l"/>
-            <a:r>
-              <a:rPr sz="800">
-                <a:solidFill>
-                  <a:srgbClr val="1F1F1F"/>
-                </a:solidFill>
-              </a:rPr>
-              <a:t/>
-            </a:r>
-          </a:p>
-          <a:p>
-            <a:pPr algn="l"/>
-            <a:r>
-              <a:rPr b="1" sz="1800">
-                <a:solidFill>
-                  <a:srgbClr val="E83F0A"/>
-                </a:solidFill>
-              </a:rPr>
-              <a:t>數據顯示：初期失序</a:t>
-            </a:r>
-          </a:p>
-          <a:p>
-            <a:pPr algn="l"/>
-            <a:r>
-              <a:rPr sz="1400">
-                <a:solidFill>
-                  <a:srgbClr val="1F1F1F"/>
-                </a:solidFill>
-              </a:rPr>
-              <a:t>9/23 起 TP 加速、HY 利差 +52 bp，IV − RV 才從 +4 擴大到 +15；MOVE 跳升約六成來自實際波動上升。</a:t>
-            </a:r>
-          </a:p>
-        </p:txBody>
-      </p:sp>
     </p:spTree>
   </p:cSld>
   <p:clrMapOvr>

</xml_diff>

<commit_message>
Restructure deck around the motivating question
Move the market background ahead of the summary and turn it into a
motivation slide that poses the three questions the deck answers, with
page pointers. Update the cover subtitle and date, and describe data
sources neutrally instead of naming the vendor.

Co-Authored-By: Claude Opus 5.5 <noreply@anthropic.com>
Claude-Session: https://claude.ai/code/session_01TCy2oBSRDZdisvwwxxfgzX
</commit_message>
<xml_diff>
--- a/slides/2026-10-03_us-treasury-vol-regime-change.pptx
+++ b/slides/2026-10-03_us-treasury-vol-regime-change.pptx
@@ -9,8 +9,8 @@
   </p:notesMasterIdLst>
   <p:sldIdLst>
     <p:sldId id="875" r:id="rId5"/>
+    <p:sldId id="879" r:id="rId8"/>
     <p:sldId id="878" r:id="rId9"/>
-    <p:sldId id="879" r:id="rId8"/>
     <p:sldId id="880" r:id="rId7"/>
     <p:sldId id="881" r:id="rId6"/>
     <p:sldId id="882" r:id="rId16"/>
@@ -2919,7 +2919,7 @@
           <a:lstStyle/>
           <a:p>
             <a:r>
-              <a:t>核心訊息：延伸原文的預期 vs TP 框架並用 Bloomberg 資料驗證。9 月分成兩段：9/22 以前是預期主導的熊市變平，9/23 起是 TP 主導的熊市變陡，MOVE、TP、HY 利差同時跳升。</a:t>
+              <a:t>核心訊息：延伸原文的預期 vs TP 框架並用市場資料驗證。9 月分成兩段：9/22 以前是預期主導的熊市變平，9/23 起是 TP 主導的熊市變陡，MOVE、TP、HY 利差同時跳升。</a:t>
             </a:r>
           </a:p>
         </p:txBody>
@@ -2989,7 +2989,7 @@
           <a:lstStyle/>
           <a:p>
             <a:r>
-              <a:t>TP 模型把長天期殖利率拆成「市場預期的未來短率平均」與「期限溢酬」。預期看不到，只能靠模型估計，所以不同模型的 TP 常差 10–20 bp。Kim-Wright 是三因子無套利仿射模型，只用名目公債與短率調查；DKW 用同樣的架構同時為名目公債與 TIPS 定價，加入通膨資料、通膨調查與 TIPS 流動性因子，因此能把實質利率與通膨拆開。DKW 的四個成分加總等於模型配適的名目殖利率，在 Fed 公布的資料中精確成立。</a:t>
+              <a:t>動機：美伊開戰以來 10Y 從 3.94% 漲到 9/30 的 5.28%，但 5–8 月 MOVE 平均只有 73，約為歷史中位數，因為上漲是緩慢推進（10Y 每天平均只動 3.7 bp）。MOVE 到 9/23 之後才跳升。這份報告要回答三個問題：誰推升了殖利率、為什麼 Vol 這麼晚才反應、現在是補漲還是失序。</a:t>
             </a:r>
           </a:p>
         </p:txBody>
@@ -3059,7 +3059,7 @@
           <a:lstStyle/>
           <a:p>
             <a:r>
-              <a:t>CR 與 Kim-Wright 對 TP 份量差很多；兩者都顯示 7 月起 TP 持續上升。</a:t>
+              <a:t>TP 模型把長天期殖利率拆成「市場預期的未來短率平均」與「期限溢酬」。預期看不到，只能靠模型估計，所以不同模型的 TP 常差 10–20 bp。Kim-Wright 是三因子無套利仿射模型，只用名目公債與短率調查；DKW 用同樣的架構同時為名目公債與 TIPS 定價，加入通膨資料、通膨調查與 TIPS 流動性因子，因此能把實質利率與通膨拆開。DKW 的四個成分加總等於模型配適的名目殖利率，在 Fed 公布的資料中精確成立。</a:t>
             </a:r>
           </a:p>
         </p:txBody>
@@ -3129,7 +3129,7 @@
           <a:lstStyle/>
           <a:p>
             <a:r>
-              <a:t>DKW 把名目殖利率拆成四塊。實質部分（預期實質短率＋實質 TP）約 +42 bp，其中實質 TP 約 16 bp。進一步拆開實質利率，能看出期限溢酬的份量。</a:t>
+              <a:t>CR 與 Kim-Wright 對 TP 份量差很多；兩者都顯示 7 月起 TP 持續上升。</a:t>
             </a:r>
           </a:p>
         </p:txBody>
@@ -3199,7 +3199,7 @@
           <a:lstStyle/>
           <a:p>
             <a:r>
-              <a:t>第一階段：短端領漲，符合升息預期重定價；Vol 與信用平靜。第二階段：短端不動、長端大跌，曲線轉陡，MOVE、TP、HY 利差同時跳升，就是原文說的 regime change，而且有明確日期。</a:t>
+              <a:t>DKW 把名目殖利率拆成四塊。實質部分（預期實質短率＋實質 TP）約 +42 bp，其中實質 TP 約 16 bp。進一步拆開實質利率，能看出期限溢酬的份量。</a:t>
             </a:r>
           </a:p>
         </p:txBody>
@@ -3269,7 +3269,77 @@
           <a:lstStyle/>
           <a:p>
             <a:r>
-              <a:t>MOVE 跳升主要是實際波動上升（補漲），但 IV − RV 也從 +4 擴大到 +15，落在歷史第 86 百分位。開戰衝擊與 2025/4 關稅衝擊時約 +28～+29（第 95 百分位），所以目前算初期失序。</a:t>
+              <a:t>第一階段：短端領漲，符合升息預期重定價；Vol 與信用平靜。第二階段：短端不動、長端大跌，曲線轉陡，MOVE、TP、HY 利差同時跳升，就是原文說的 regime change，而且有明確日期。</a:t>
+            </a:r>
+          </a:p>
+        </p:txBody>
+      </p:sp>
+      <p:sp>
+        <p:nvSpPr>
+          <p:cNvPr id="4" name="Slide Number Placeholder 3"/>
+          <p:cNvSpPr>
+            <a:spLocks noGrp="1"/>
+          </p:cNvSpPr>
+          <p:nvPr>
+            <p:ph type="sldNum" idx="5" sz="quarter"/>
+          </p:nvPr>
+        </p:nvSpPr>
+        <p:spPr/>
+      </p:sp>
+    </p:spTree>
+  </p:cSld>
+  <p:clrMapOvr>
+    <a:masterClrMapping/>
+  </p:clrMapOvr>
+</p:notes>
+</file>
+
+<file path=ppt/notesSlides/notesSlide7.xml><?xml version="1.0" encoding="utf-8"?>
+<p:notes xmlns:a="http://schemas.openxmlformats.org/drawingml/2006/main" xmlns:p="http://schemas.openxmlformats.org/presentationml/2006/main" xmlns:r="http://schemas.openxmlformats.org/officeDocument/2006/relationships">
+  <p:cSld>
+    <p:spTree>
+      <p:nvGrpSpPr>
+        <p:cNvPr id="1" name=""/>
+        <p:cNvGrpSpPr/>
+        <p:nvPr/>
+      </p:nvGrpSpPr>
+      <p:grpSpPr>
+        <a:xfrm>
+          <a:off x="0" y="0"/>
+          <a:ext cx="0" cy="0"/>
+          <a:chOff x="0" y="0"/>
+          <a:chExt cx="0" cy="0"/>
+        </a:xfrm>
+      </p:grpSpPr>
+      <p:sp>
+        <p:nvSpPr>
+          <p:cNvPr id="2" name="Slide Image Placeholder 1"/>
+          <p:cNvSpPr>
+            <a:spLocks noGrp="1"/>
+          </p:cNvSpPr>
+          <p:nvPr>
+            <p:ph type="sldImg" idx="2"/>
+          </p:nvPr>
+        </p:nvSpPr>
+        <p:spPr/>
+      </p:sp>
+      <p:sp>
+        <p:nvSpPr>
+          <p:cNvPr id="3" name="Notes Placeholder 2"/>
+          <p:cNvSpPr>
+            <a:spLocks noGrp="1"/>
+          </p:cNvSpPr>
+          <p:nvPr>
+            <p:ph type="body" idx="3" sz="quarter"/>
+          </p:nvPr>
+        </p:nvSpPr>
+        <p:spPr/>
+        <p:txBody>
+          <a:bodyPr/>
+          <a:lstStyle/>
+          <a:p>
+            <a:r>
+              <a:t>MOVE 跳升主要是實際波動上升（補漲），但 IV − RV 也從 +4 擴大到 +15，落在歷史第 86 百分位。開戰衝擊與 2025/4 關稅衝擊時約 +28～+29（第 95 百分位），所以目前算初期失序。另外，5–8 月 MOVE 低是因為實際波動也低（IV − RV ≈ 0），只有 5 月底到 7 月初 IV 落後實際波動約 7 bp。</a:t>
             </a:r>
           </a:p>
         </p:txBody>
@@ -46965,7 +47035,7 @@
                 <a:cs typeface="Times New Roman"/>
                 <a:sym typeface="Times New Roman"/>
               </a:rPr>
-              <a:t>從預期主導到 TP 失序：MOVE 110 的訊號與 AI 融資風險</a:t>
+              <a:t>9/23 起從預期主導轉向 TP 主導：MOVE 跳升與信用風險</a:t>
             </a:r>
             <a:endParaRPr lang="zh-TW" altLang="en-US" dirty="0">
               <a:latin typeface="微軟正黑體" panose="020B0604030504040204" pitchFamily="34" charset="-120"/>
@@ -47041,7 +47111,7 @@
               <a:rPr lang="en-US" altLang="zh-TW" dirty="0">
                 <a:cs typeface="Times New Roman" panose="02020603050405020304" pitchFamily="18" charset="0"/>
               </a:rPr>
-              <a:t>2026.10.03</a:t>
+              <a:t>2026.10.05</a:t>
             </a:r>
             <a:endParaRPr lang="zh-TW" altLang="en-US" dirty="0">
               <a:cs typeface="Times New Roman" panose="02020603050405020304" pitchFamily="18" charset="0"/>
@@ -50644,7 +50714,7 @@
                   <a:srgbClr val="1F1F1F"/>
                 </a:solidFill>
               </a:rPr>
-              <a:t>• Bloomberg 資料至 10/2；只有收盤價，無盤中值。</a:t>
+              <a:t>• 市場資料至 10/2；只有收盤價，無盤中值。</a:t>
             </a:r>
           </a:p>
           <a:p>
@@ -51153,6 +51223,538 @@
       <p:grpSpPr/>
       <p:sp>
         <p:nvSpPr>
+          <p:cNvPr id="3" name="Text Placeholder 2"/>
+          <p:cNvSpPr>
+            <a:spLocks noGrp="1"/>
+          </p:cNvSpPr>
+          <p:nvPr>
+            <p:ph type="body" idx="15" sz="quarter"/>
+          </p:nvPr>
+        </p:nvSpPr>
+        <p:spPr/>
+        <p:txBody>
+          <a:bodyPr/>
+          <a:lstStyle/>
+          <a:p>
+            <a:r>
+              <a:t>殖利率從 2 月低點上漲 135 bp，MOVE 直到 9/23 之後才從 79 跳到 110</a:t>
+            </a:r>
+          </a:p>
+        </p:txBody>
+      </p:sp>
+      <p:sp>
+        <p:nvSpPr>
+          <p:cNvPr id="4" name="Title 3"/>
+          <p:cNvSpPr>
+            <a:spLocks noGrp="1"/>
+          </p:cNvSpPr>
+          <p:nvPr>
+            <p:ph type="title"/>
+          </p:nvPr>
+        </p:nvSpPr>
+        <p:spPr>
+          <a:xfrm>
+            <a:off x="411480" y="192024"/>
+            <a:ext cx="11329416" cy="548640"/>
+          </a:xfrm>
+        </p:spPr>
+        <p:txBody>
+          <a:bodyPr/>
+          <a:lstStyle/>
+          <a:p>
+            <a:r>
+              <a:t>市況背景：10Y 創新高，Vol 卻到 9 月底才反應</a:t>
+            </a:r>
+          </a:p>
+        </p:txBody>
+      </p:sp>
+      <p:graphicFrame>
+        <p:nvGraphicFramePr>
+          <p:cNvPr id="5" name="Table 4"/>
+          <p:cNvGraphicFramePr>
+            <a:graphicFrameLocks noGrp="1"/>
+          </p:cNvGraphicFramePr>
+          <p:nvPr/>
+        </p:nvGraphicFramePr>
+        <p:xfrm>
+          <a:off x="411480" y="1783080"/>
+          <a:ext cx="6766560" cy="3950208"/>
+        </p:xfrm>
+        <a:graphic>
+          <a:graphicData uri="http://schemas.openxmlformats.org/drawingml/2006/table">
+            <a:tbl>
+              <a:tblPr firstRow="1" bandRow="1">
+                <a:tableStyleId>{5940675A-B579-460E-94D1-54222C63F5DA}</a:tableStyleId>
+              </a:tblPr>
+              <a:tblGrid>
+                <a:gridCol w="1828800"/>
+                <a:gridCol w="4937760"/>
+              </a:tblGrid>
+              <a:tr h="658368">
+                <a:tc>
+                  <a:txBody>
+                    <a:bodyPr wrap="square"/>
+                    <a:lstStyle/>
+                    <a:p>
+                      <a:r>
+                        <a:rPr b="1" sz="1300">
+                          <a:solidFill>
+                            <a:srgbClr val="FFFFFF"/>
+                          </a:solidFill>
+                        </a:rPr>
+                        <a:t>項目</a:t>
+                      </a:r>
+                    </a:p>
+                  </a:txBody>
+                  <a:tcPr marL="73152" marR="73152" marT="27432" marB="27432" anchor="ctr">
+                    <a:solidFill>
+                      <a:srgbClr val="234976"/>
+                    </a:solidFill>
+                  </a:tcPr>
+                </a:tc>
+                <a:tc>
+                  <a:txBody>
+                    <a:bodyPr wrap="square"/>
+                    <a:lstStyle/>
+                    <a:p>
+                      <a:r>
+                        <a:rPr b="1" sz="1300">
+                          <a:solidFill>
+                            <a:srgbClr val="FFFFFF"/>
+                          </a:solidFill>
+                        </a:rPr>
+                        <a:t>現況</a:t>
+                      </a:r>
+                    </a:p>
+                  </a:txBody>
+                  <a:tcPr marL="73152" marR="73152" marT="27432" marB="27432" anchor="ctr">
+                    <a:solidFill>
+                      <a:srgbClr val="234976"/>
+                    </a:solidFill>
+                  </a:tcPr>
+                </a:tc>
+              </a:tr>
+              <a:tr h="658368">
+                <a:tc>
+                  <a:txBody>
+                    <a:bodyPr wrap="square"/>
+                    <a:lstStyle/>
+                    <a:p>
+                      <a:r>
+                        <a:rPr b="1" sz="1300">
+                          <a:solidFill>
+                            <a:srgbClr val="1F1F1F"/>
+                          </a:solidFill>
+                        </a:rPr>
+                        <a:t>10Y 殖利率</a:t>
+                      </a:r>
+                    </a:p>
+                  </a:txBody>
+                  <a:tcPr marL="73152" marR="73152" marT="27432" marB="27432" anchor="ctr">
+                    <a:solidFill>
+                      <a:srgbClr val="FFFFFF"/>
+                    </a:solidFill>
+                  </a:tcPr>
+                </a:tc>
+                <a:tc>
+                  <a:txBody>
+                    <a:bodyPr wrap="square"/>
+                    <a:lstStyle/>
+                    <a:p>
+                      <a:r>
+                        <a:rPr sz="1300">
+                          <a:solidFill>
+                            <a:srgbClr val="1F1F1F"/>
+                          </a:solidFill>
+                        </a:rPr>
+                        <a:t>9/30 收 5.28%（今年最高收盤）；10/1 盤中一度 5.34%</a:t>
+                      </a:r>
+                    </a:p>
+                  </a:txBody>
+                  <a:tcPr marL="73152" marR="73152" marT="27432" marB="27432" anchor="ctr">
+                    <a:solidFill>
+                      <a:srgbClr val="FFFFFF"/>
+                    </a:solidFill>
+                  </a:tcPr>
+                </a:tc>
+              </a:tr>
+              <a:tr h="658368">
+                <a:tc>
+                  <a:txBody>
+                    <a:bodyPr wrap="square"/>
+                    <a:lstStyle/>
+                    <a:p>
+                      <a:r>
+                        <a:rPr b="1" sz="1300">
+                          <a:solidFill>
+                            <a:srgbClr val="1F1F1F"/>
+                          </a:solidFill>
+                        </a:rPr>
+                        <a:t>開戰以來</a:t>
+                      </a:r>
+                    </a:p>
+                  </a:txBody>
+                  <a:tcPr marL="73152" marR="73152" marT="27432" marB="27432" anchor="ctr">
+                    <a:solidFill>
+                      <a:srgbClr val="EEF3F8"/>
+                    </a:solidFill>
+                  </a:tcPr>
+                </a:tc>
+                <a:tc>
+                  <a:txBody>
+                    <a:bodyPr wrap="square"/>
+                    <a:lstStyle/>
+                    <a:p>
+                      <a:r>
+                        <a:rPr sz="1300">
+                          <a:solidFill>
+                            <a:srgbClr val="1F1F1F"/>
+                          </a:solidFill>
+                        </a:rPr>
+                        <a:t>2/27 低點 3.94% → 9/30 +135 bp；9 月單月 +54 bp</a:t>
+                      </a:r>
+                    </a:p>
+                  </a:txBody>
+                  <a:tcPr marL="73152" marR="73152" marT="27432" marB="27432" anchor="ctr">
+                    <a:solidFill>
+                      <a:srgbClr val="EEF3F8"/>
+                    </a:solidFill>
+                  </a:tcPr>
+                </a:tc>
+              </a:tr>
+              <a:tr h="658368">
+                <a:tc>
+                  <a:txBody>
+                    <a:bodyPr wrap="square"/>
+                    <a:lstStyle/>
+                    <a:p>
+                      <a:r>
+                        <a:rPr b="1" sz="1300">
+                          <a:solidFill>
+                            <a:srgbClr val="1F1F1F"/>
+                          </a:solidFill>
+                        </a:rPr>
+                        <a:t>MOVE（5–8 月）</a:t>
+                      </a:r>
+                    </a:p>
+                  </a:txBody>
+                  <a:tcPr marL="73152" marR="73152" marT="27432" marB="27432" anchor="ctr">
+                    <a:solidFill>
+                      <a:srgbClr val="FFFFFF"/>
+                    </a:solidFill>
+                  </a:tcPr>
+                </a:tc>
+                <a:tc>
+                  <a:txBody>
+                    <a:bodyPr wrap="square"/>
+                    <a:lstStyle/>
+                    <a:p>
+                      <a:r>
+                        <a:rPr sz="1300">
+                          <a:solidFill>
+                            <a:srgbClr val="1F1F1F"/>
+                          </a:solidFill>
+                        </a:rPr>
+                        <a:t>平均 73（65–86），約為 2017–2025 年中位數</a:t>
+                      </a:r>
+                    </a:p>
+                  </a:txBody>
+                  <a:tcPr marL="73152" marR="73152" marT="27432" marB="27432" anchor="ctr">
+                    <a:solidFill>
+                      <a:srgbClr val="FFFFFF"/>
+                    </a:solidFill>
+                  </a:tcPr>
+                </a:tc>
+              </a:tr>
+              <a:tr h="658368">
+                <a:tc>
+                  <a:txBody>
+                    <a:bodyPr wrap="square"/>
+                    <a:lstStyle/>
+                    <a:p>
+                      <a:r>
+                        <a:rPr b="1" sz="1300">
+                          <a:solidFill>
+                            <a:srgbClr val="1F1F1F"/>
+                          </a:solidFill>
+                        </a:rPr>
+                        <a:t>MOVE（9 月底）</a:t>
+                      </a:r>
+                    </a:p>
+                  </a:txBody>
+                  <a:tcPr marL="73152" marR="73152" marT="27432" marB="27432" anchor="ctr">
+                    <a:solidFill>
+                      <a:srgbClr val="EEF3F8"/>
+                    </a:solidFill>
+                  </a:tcPr>
+                </a:tc>
+                <a:tc>
+                  <a:txBody>
+                    <a:bodyPr wrap="square"/>
+                    <a:lstStyle/>
+                    <a:p>
+                      <a:r>
+                        <a:rPr sz="1300">
+                          <a:solidFill>
+                            <a:srgbClr val="1F1F1F"/>
+                          </a:solidFill>
+                        </a:rPr>
+                        <a:t>9/22 79 → 9/30 110；3 月高點 115，2025/4 為 140</a:t>
+                      </a:r>
+                    </a:p>
+                  </a:txBody>
+                  <a:tcPr marL="73152" marR="73152" marT="27432" marB="27432" anchor="ctr">
+                    <a:solidFill>
+                      <a:srgbClr val="EEF3F8"/>
+                    </a:solidFill>
+                  </a:tcPr>
+                </a:tc>
+              </a:tr>
+              <a:tr h="658368">
+                <a:tc>
+                  <a:txBody>
+                    <a:bodyPr wrap="square"/>
+                    <a:lstStyle/>
+                    <a:p>
+                      <a:r>
+                        <a:rPr b="1" sz="1300">
+                          <a:solidFill>
+                            <a:srgbClr val="1F1F1F"/>
+                          </a:solidFill>
+                        </a:rPr>
+                        <a:t>政策與事件</a:t>
+                      </a:r>
+                    </a:p>
+                  </a:txBody>
+                  <a:tcPr marL="73152" marR="73152" marT="27432" marB="27432" anchor="ctr">
+                    <a:solidFill>
+                      <a:srgbClr val="FFFFFF"/>
+                    </a:solidFill>
+                  </a:tcPr>
+                </a:tc>
+                <a:tc>
+                  <a:txBody>
+                    <a:bodyPr wrap="square"/>
+                    <a:lstStyle/>
+                    <a:p>
+                      <a:r>
+                        <a:rPr sz="1300">
+                          <a:solidFill>
+                            <a:srgbClr val="1F1F1F"/>
+                          </a:solidFill>
+                        </a:rPr>
+                        <a:t>美伊開戰、Warsh 9 月升息、Bessent 擴大公債回購</a:t>
+                      </a:r>
+                    </a:p>
+                  </a:txBody>
+                  <a:tcPr marL="73152" marR="73152" marT="27432" marB="27432" anchor="ctr">
+                    <a:solidFill>
+                      <a:srgbClr val="FFFFFF"/>
+                    </a:solidFill>
+                  </a:tcPr>
+                </a:tc>
+              </a:tr>
+            </a:tbl>
+          </a:graphicData>
+        </a:graphic>
+      </p:graphicFrame>
+      <p:sp>
+        <p:nvSpPr>
+          <p:cNvPr id="6" name="Rectangle 5"/>
+          <p:cNvSpPr/>
+          <p:nvPr/>
+        </p:nvSpPr>
+        <p:spPr>
+          <a:xfrm>
+            <a:off x="7452360" y="1783080"/>
+            <a:ext cx="4297680" cy="3931920"/>
+          </a:xfrm>
+          <a:prstGeom prst="rect">
+            <a:avLst/>
+          </a:prstGeom>
+          <a:solidFill>
+            <a:srgbClr val="EEF3F8"/>
+          </a:solidFill>
+          <a:ln>
+            <a:noFill/>
+          </a:ln>
+          <a:effectLst/>
+        </p:spPr>
+        <p:style>
+          <a:lnRef idx="1">
+            <a:schemeClr val="accent1"/>
+          </a:lnRef>
+          <a:fillRef idx="3">
+            <a:schemeClr val="accent1"/>
+          </a:fillRef>
+          <a:effectRef idx="2">
+            <a:schemeClr val="accent1"/>
+          </a:effectRef>
+          <a:fontRef idx="minor">
+            <a:schemeClr val="lt1"/>
+          </a:fontRef>
+        </p:style>
+        <p:txBody>
+          <a:bodyPr rtlCol="0" anchor="ctr"/>
+          <a:lstStyle/>
+          <a:p>
+            <a:pPr algn="ctr"/>
+          </a:p>
+        </p:txBody>
+      </p:sp>
+      <p:sp>
+        <p:nvSpPr>
+          <p:cNvPr id="7" name="TextBox 6"/>
+          <p:cNvSpPr txBox="1"/>
+          <p:nvPr/>
+        </p:nvSpPr>
+        <p:spPr>
+          <a:xfrm>
+            <a:off x="7635240" y="1920240"/>
+            <a:ext cx="3977639" cy="3749039"/>
+          </a:xfrm>
+          <a:prstGeom prst="rect">
+            <a:avLst/>
+          </a:prstGeom>
+          <a:noFill/>
+        </p:spPr>
+        <p:txBody>
+          <a:bodyPr wrap="square" lIns="45720" rIns="45720" anchor="t">
+            <a:spAutoFit/>
+          </a:bodyPr>
+          <a:lstStyle/>
+          <a:p>
+            <a:pPr algn="l"/>
+            <a:r>
+              <a:rPr b="1" sz="1800">
+                <a:solidFill>
+                  <a:srgbClr val="234976"/>
+                </a:solidFill>
+              </a:rPr>
+              <a:t>本報告要回答的三個問題</a:t>
+            </a:r>
+          </a:p>
+          <a:p>
+            <a:pPr algn="l"/>
+            <a:r>
+              <a:rPr sz="1600">
+                <a:solidFill>
+                  <a:srgbClr val="1F1F1F"/>
+                </a:solidFill>
+              </a:rPr>
+              <a:t/>
+            </a:r>
+          </a:p>
+          <a:p>
+            <a:pPr algn="l"/>
+            <a:r>
+              <a:rPr b="1" sz="1600">
+                <a:solidFill>
+                  <a:srgbClr val="1F1F1F"/>
+                </a:solidFill>
+              </a:rPr>
+              <a:t>1. 是什麼推升了殖利率：預期還是 TP？</a:t>
+            </a:r>
+          </a:p>
+          <a:p>
+            <a:pPr algn="l"/>
+            <a:r>
+              <a:rPr sz="1300">
+                <a:solidFill>
+                  <a:srgbClr val="595959"/>
+                </a:solidFill>
+              </a:rPr>
+              <a:t>第 4–7 頁</a:t>
+            </a:r>
+          </a:p>
+          <a:p>
+            <a:pPr algn="l"/>
+            <a:r>
+              <a:rPr sz="1600">
+                <a:solidFill>
+                  <a:srgbClr val="1F1F1F"/>
+                </a:solidFill>
+              </a:rPr>
+              <a:t/>
+            </a:r>
+          </a:p>
+          <a:p>
+            <a:pPr algn="l"/>
+            <a:r>
+              <a:rPr b="1" sz="1600">
+                <a:solidFill>
+                  <a:srgbClr val="1F1F1F"/>
+                </a:solidFill>
+              </a:rPr>
+              <a:t>2. 為什麼 Vol 到 9 月底才反應？</a:t>
+            </a:r>
+          </a:p>
+          <a:p>
+            <a:pPr algn="l"/>
+            <a:r>
+              <a:rPr sz="1300">
+                <a:solidFill>
+                  <a:srgbClr val="595959"/>
+                </a:solidFill>
+              </a:rPr>
+              <a:t>第 8–10 頁</a:t>
+            </a:r>
+          </a:p>
+          <a:p>
+            <a:pPr algn="l"/>
+            <a:r>
+              <a:rPr sz="1600">
+                <a:solidFill>
+                  <a:srgbClr val="1F1F1F"/>
+                </a:solidFill>
+              </a:rPr>
+              <a:t/>
+            </a:r>
+          </a:p>
+          <a:p>
+            <a:pPr algn="l"/>
+            <a:r>
+              <a:rPr b="1" sz="1600">
+                <a:solidFill>
+                  <a:srgbClr val="1F1F1F"/>
+                </a:solidFill>
+              </a:rPr>
+              <a:t>3. 現在是補漲還是失序？交易上怎麼看？</a:t>
+            </a:r>
+          </a:p>
+          <a:p>
+            <a:pPr algn="l"/>
+            <a:r>
+              <a:rPr sz="1300">
+                <a:solidFill>
+                  <a:srgbClr val="595959"/>
+                </a:solidFill>
+              </a:rPr>
+              <a:t>第 13–14 頁</a:t>
+            </a:r>
+          </a:p>
+        </p:txBody>
+      </p:sp>
+    </p:spTree>
+  </p:cSld>
+  <p:clrMapOvr>
+    <a:masterClrMapping/>
+  </p:clrMapOvr>
+</p:sld>
+</file>
+
+<file path=ppt/slides/slide3.xml><?xml version="1.0" encoding="utf-8"?>
+<p:sld xmlns:a="http://schemas.openxmlformats.org/drawingml/2006/main" xmlns:p="http://schemas.openxmlformats.org/presentationml/2006/main" xmlns:r="http://schemas.openxmlformats.org/officeDocument/2006/relationships">
+  <p:cSld>
+    <p:spTree>
+      <p:nvGrpSpPr>
+        <p:cNvPr id="1" name=""/>
+        <p:cNvGrpSpPr/>
+        <p:nvPr/>
+      </p:nvGrpSpPr>
+      <p:grpSpPr/>
+      <p:sp>
+        <p:nvSpPr>
           <p:cNvPr id="2" name="Content Placeholder 1"/>
           <p:cNvSpPr>
             <a:spLocks noGrp="1"/>
@@ -51733,686 +52335,6 @@
                 </a:solidFill>
               </a:rPr>
               <a:t>HY OAS（9/22 → 10/1）</a:t>
-            </a:r>
-          </a:p>
-        </p:txBody>
-      </p:sp>
-    </p:spTree>
-  </p:cSld>
-  <p:clrMapOvr>
-    <a:masterClrMapping/>
-  </p:clrMapOvr>
-</p:sld>
-</file>
-
-<file path=ppt/slides/slide3.xml><?xml version="1.0" encoding="utf-8"?>
-<p:sld xmlns:a="http://schemas.openxmlformats.org/drawingml/2006/main" xmlns:p="http://schemas.openxmlformats.org/presentationml/2006/main" xmlns:r="http://schemas.openxmlformats.org/officeDocument/2006/relationships">
-  <p:cSld>
-    <p:spTree>
-      <p:nvGrpSpPr>
-        <p:cNvPr id="1" name=""/>
-        <p:cNvGrpSpPr/>
-        <p:nvPr/>
-      </p:nvGrpSpPr>
-      <p:grpSpPr/>
-      <p:sp>
-        <p:nvSpPr>
-          <p:cNvPr id="3" name="Text Placeholder 2"/>
-          <p:cNvSpPr>
-            <a:spLocks noGrp="1"/>
-          </p:cNvSpPr>
-          <p:nvPr>
-            <p:ph type="body" idx="15" sz="quarter"/>
-          </p:nvPr>
-        </p:nvSpPr>
-        <p:spPr/>
-        <p:txBody>
-          <a:bodyPr/>
-          <a:lstStyle/>
-          <a:p>
-            <a:r>
-              <a:t>10Y 9/30 收 5.28%、開戰以來 +135 bp，MOVE 9/30 升至 110</a:t>
-            </a:r>
-          </a:p>
-        </p:txBody>
-      </p:sp>
-      <p:sp>
-        <p:nvSpPr>
-          <p:cNvPr id="4" name="Title 3"/>
-          <p:cNvSpPr>
-            <a:spLocks noGrp="1"/>
-          </p:cNvSpPr>
-          <p:nvPr>
-            <p:ph type="title"/>
-          </p:nvPr>
-        </p:nvSpPr>
-        <p:spPr>
-          <a:xfrm>
-            <a:off x="411480" y="192024"/>
-            <a:ext cx="11329416" cy="548640"/>
-          </a:xfrm>
-        </p:spPr>
-        <p:txBody>
-          <a:bodyPr/>
-          <a:lstStyle/>
-          <a:p>
-            <a:r>
-              <a:t>市況：原文的關鍵數字與 Bloomberg 資料一致</a:t>
-            </a:r>
-          </a:p>
-        </p:txBody>
-      </p:sp>
-      <p:graphicFrame>
-        <p:nvGraphicFramePr>
-          <p:cNvPr id="5" name="Table 4"/>
-          <p:cNvGraphicFramePr>
-            <a:graphicFrameLocks noGrp="1"/>
-          </p:cNvGraphicFramePr>
-          <p:nvPr/>
-        </p:nvGraphicFramePr>
-        <p:xfrm>
-          <a:off x="411480" y="1783080"/>
-          <a:ext cx="6766560" cy="3840480"/>
-        </p:xfrm>
-        <a:graphic>
-          <a:graphicData uri="http://schemas.openxmlformats.org/drawingml/2006/table">
-            <a:tbl>
-              <a:tblPr firstRow="1" bandRow="1">
-                <a:tableStyleId>{5940675A-B579-460E-94D1-54222C63F5DA}</a:tableStyleId>
-              </a:tblPr>
-              <a:tblGrid>
-                <a:gridCol w="1463040"/>
-                <a:gridCol w="2377440"/>
-                <a:gridCol w="2926080"/>
-              </a:tblGrid>
-              <a:tr h="548640">
-                <a:tc>
-                  <a:txBody>
-                    <a:bodyPr wrap="square"/>
-                    <a:lstStyle/>
-                    <a:p>
-                      <a:r>
-                        <a:rPr b="1" sz="1300">
-                          <a:solidFill>
-                            <a:srgbClr val="FFFFFF"/>
-                          </a:solidFill>
-                        </a:rPr>
-                        <a:t>項目</a:t>
-                      </a:r>
-                    </a:p>
-                  </a:txBody>
-                  <a:tcPr marL="73152" marR="73152" marT="27432" marB="27432" anchor="ctr">
-                    <a:solidFill>
-                      <a:srgbClr val="234976"/>
-                    </a:solidFill>
-                  </a:tcPr>
-                </a:tc>
-                <a:tc>
-                  <a:txBody>
-                    <a:bodyPr wrap="square"/>
-                    <a:lstStyle/>
-                    <a:p>
-                      <a:r>
-                        <a:rPr b="1" sz="1300">
-                          <a:solidFill>
-                            <a:srgbClr val="FFFFFF"/>
-                          </a:solidFill>
-                        </a:rPr>
-                        <a:t>原文</a:t>
-                      </a:r>
-                    </a:p>
-                  </a:txBody>
-                  <a:tcPr marL="73152" marR="73152" marT="27432" marB="27432" anchor="ctr">
-                    <a:solidFill>
-                      <a:srgbClr val="234976"/>
-                    </a:solidFill>
-                  </a:tcPr>
-                </a:tc>
-                <a:tc>
-                  <a:txBody>
-                    <a:bodyPr wrap="square"/>
-                    <a:lstStyle/>
-                    <a:p>
-                      <a:r>
-                        <a:rPr b="1" sz="1300">
-                          <a:solidFill>
-                            <a:srgbClr val="FFFFFF"/>
-                          </a:solidFill>
-                        </a:rPr>
-                        <a:t>Bloomberg 資料</a:t>
-                      </a:r>
-                    </a:p>
-                  </a:txBody>
-                  <a:tcPr marL="73152" marR="73152" marT="27432" marB="27432" anchor="ctr">
-                    <a:solidFill>
-                      <a:srgbClr val="234976"/>
-                    </a:solidFill>
-                  </a:tcPr>
-                </a:tc>
-              </a:tr>
-              <a:tr h="548640">
-                <a:tc>
-                  <a:txBody>
-                    <a:bodyPr wrap="square"/>
-                    <a:lstStyle/>
-                    <a:p>
-                      <a:r>
-                        <a:rPr b="1" sz="1300">
-                          <a:solidFill>
-                            <a:srgbClr val="1F1F1F"/>
-                          </a:solidFill>
-                        </a:rPr>
-                        <a:t>10Y 高點</a:t>
-                      </a:r>
-                    </a:p>
-                  </a:txBody>
-                  <a:tcPr marL="73152" marR="73152" marT="27432" marB="27432" anchor="ctr">
-                    <a:solidFill>
-                      <a:srgbClr val="FFFFFF"/>
-                    </a:solidFill>
-                  </a:tcPr>
-                </a:tc>
-                <a:tc>
-                  <a:txBody>
-                    <a:bodyPr wrap="square"/>
-                    <a:lstStyle/>
-                    <a:p>
-                      <a:r>
-                        <a:rPr sz="1300">
-                          <a:solidFill>
-                            <a:srgbClr val="1F1F1F"/>
-                          </a:solidFill>
-                        </a:rPr>
-                        <a:t>10/1 盤中 5.34%</a:t>
-                      </a:r>
-                    </a:p>
-                  </a:txBody>
-                  <a:tcPr marL="73152" marR="73152" marT="27432" marB="27432" anchor="ctr">
-                    <a:solidFill>
-                      <a:srgbClr val="FFFFFF"/>
-                    </a:solidFill>
-                  </a:tcPr>
-                </a:tc>
-                <a:tc>
-                  <a:txBody>
-                    <a:bodyPr wrap="square"/>
-                    <a:lstStyle/>
-                    <a:p>
-                      <a:r>
-                        <a:rPr sz="1300">
-                          <a:solidFill>
-                            <a:srgbClr val="1F1F1F"/>
-                          </a:solidFill>
-                        </a:rPr>
-                        <a:t>9/30 收盤 5.28%、10/2 5.27%</a:t>
-                      </a:r>
-                    </a:p>
-                  </a:txBody>
-                  <a:tcPr marL="73152" marR="73152" marT="27432" marB="27432" anchor="ctr">
-                    <a:solidFill>
-                      <a:srgbClr val="FFFFFF"/>
-                    </a:solidFill>
-                  </a:tcPr>
-                </a:tc>
-              </a:tr>
-              <a:tr h="548640">
-                <a:tc>
-                  <a:txBody>
-                    <a:bodyPr wrap="square"/>
-                    <a:lstStyle/>
-                    <a:p>
-                      <a:r>
-                        <a:rPr b="1" sz="1300">
-                          <a:solidFill>
-                            <a:srgbClr val="1F1F1F"/>
-                          </a:solidFill>
-                        </a:rPr>
-                        <a:t>開戰以來漲幅</a:t>
-                      </a:r>
-                    </a:p>
-                  </a:txBody>
-                  <a:tcPr marL="73152" marR="73152" marT="27432" marB="27432" anchor="ctr">
-                    <a:solidFill>
-                      <a:srgbClr val="EEF3F8"/>
-                    </a:solidFill>
-                  </a:tcPr>
-                </a:tc>
-                <a:tc>
-                  <a:txBody>
-                    <a:bodyPr wrap="square"/>
-                    <a:lstStyle/>
-                    <a:p>
-                      <a:r>
-                        <a:rPr sz="1300">
-                          <a:solidFill>
-                            <a:srgbClr val="1F1F1F"/>
-                          </a:solidFill>
-                        </a:rPr>
-                        <a:t>超過 130 bp</a:t>
-                      </a:r>
-                    </a:p>
-                  </a:txBody>
-                  <a:tcPr marL="73152" marR="73152" marT="27432" marB="27432" anchor="ctr">
-                    <a:solidFill>
-                      <a:srgbClr val="EEF3F8"/>
-                    </a:solidFill>
-                  </a:tcPr>
-                </a:tc>
-                <a:tc>
-                  <a:txBody>
-                    <a:bodyPr wrap="square"/>
-                    <a:lstStyle/>
-                    <a:p>
-                      <a:r>
-                        <a:rPr sz="1300">
-                          <a:solidFill>
-                            <a:srgbClr val="1F1F1F"/>
-                          </a:solidFill>
-                        </a:rPr>
-                        <a:t>2/27 低點 3.94% → 9/30 +135 bp</a:t>
-                      </a:r>
-                    </a:p>
-                  </a:txBody>
-                  <a:tcPr marL="73152" marR="73152" marT="27432" marB="27432" anchor="ctr">
-                    <a:solidFill>
-                      <a:srgbClr val="EEF3F8"/>
-                    </a:solidFill>
-                  </a:tcPr>
-                </a:tc>
-              </a:tr>
-              <a:tr h="548640">
-                <a:tc>
-                  <a:txBody>
-                    <a:bodyPr wrap="square"/>
-                    <a:lstStyle/>
-                    <a:p>
-                      <a:r>
-                        <a:rPr b="1" sz="1300">
-                          <a:solidFill>
-                            <a:srgbClr val="1F1F1F"/>
-                          </a:solidFill>
-                        </a:rPr>
-                        <a:t>實質利率貢獻</a:t>
-                      </a:r>
-                    </a:p>
-                  </a:txBody>
-                  <a:tcPr marL="73152" marR="73152" marT="27432" marB="27432" anchor="ctr">
-                    <a:solidFill>
-                      <a:srgbClr val="FFFFFF"/>
-                    </a:solidFill>
-                  </a:tcPr>
-                </a:tc>
-                <a:tc>
-                  <a:txBody>
-                    <a:bodyPr wrap="square"/>
-                    <a:lstStyle/>
-                    <a:p>
-                      <a:r>
-                        <a:rPr sz="1300">
-                          <a:solidFill>
-                            <a:srgbClr val="1F1F1F"/>
-                          </a:solidFill>
-                        </a:rPr>
-                        <a:t>約 120 bp</a:t>
-                      </a:r>
-                    </a:p>
-                  </a:txBody>
-                  <a:tcPr marL="73152" marR="73152" marT="27432" marB="27432" anchor="ctr">
-                    <a:solidFill>
-                      <a:srgbClr val="FFFFFF"/>
-                    </a:solidFill>
-                  </a:tcPr>
-                </a:tc>
-                <a:tc>
-                  <a:txBody>
-                    <a:bodyPr wrap="square"/>
-                    <a:lstStyle/>
-                    <a:p>
-                      <a:r>
-                        <a:rPr sz="1300">
-                          <a:solidFill>
-                            <a:srgbClr val="1F1F1F"/>
-                          </a:solidFill>
-                        </a:rPr>
-                        <a:t>同期 TIPS +123 bp、BEI +11 bp</a:t>
-                      </a:r>
-                    </a:p>
-                  </a:txBody>
-                  <a:tcPr marL="73152" marR="73152" marT="27432" marB="27432" anchor="ctr">
-                    <a:solidFill>
-                      <a:srgbClr val="FFFFFF"/>
-                    </a:solidFill>
-                  </a:tcPr>
-                </a:tc>
-              </a:tr>
-              <a:tr h="548640">
-                <a:tc>
-                  <a:txBody>
-                    <a:bodyPr wrap="square"/>
-                    <a:lstStyle/>
-                    <a:p>
-                      <a:r>
-                        <a:rPr b="1" sz="1300">
-                          <a:solidFill>
-                            <a:srgbClr val="1F1F1F"/>
-                          </a:solidFill>
-                        </a:rPr>
-                        <a:t>9 月單月</a:t>
-                      </a:r>
-                    </a:p>
-                  </a:txBody>
-                  <a:tcPr marL="73152" marR="73152" marT="27432" marB="27432" anchor="ctr">
-                    <a:solidFill>
-                      <a:srgbClr val="EEF3F8"/>
-                    </a:solidFill>
-                  </a:tcPr>
-                </a:tc>
-                <a:tc>
-                  <a:txBody>
-                    <a:bodyPr wrap="square"/>
-                    <a:lstStyle/>
-                    <a:p>
-                      <a:r>
-                        <a:rPr sz="1300">
-                          <a:solidFill>
-                            <a:srgbClr val="1F1F1F"/>
-                          </a:solidFill>
-                        </a:rPr>
-                        <a:t>約 +60 bp</a:t>
-                      </a:r>
-                    </a:p>
-                  </a:txBody>
-                  <a:tcPr marL="73152" marR="73152" marT="27432" marB="27432" anchor="ctr">
-                    <a:solidFill>
-                      <a:srgbClr val="EEF3F8"/>
-                    </a:solidFill>
-                  </a:tcPr>
-                </a:tc>
-                <a:tc>
-                  <a:txBody>
-                    <a:bodyPr wrap="square"/>
-                    <a:lstStyle/>
-                    <a:p>
-                      <a:r>
-                        <a:rPr sz="1300">
-                          <a:solidFill>
-                            <a:srgbClr val="1F1F1F"/>
-                          </a:solidFill>
-                        </a:rPr>
-                        <a:t>收盤 +54 bp</a:t>
-                      </a:r>
-                    </a:p>
-                  </a:txBody>
-                  <a:tcPr marL="73152" marR="73152" marT="27432" marB="27432" anchor="ctr">
-                    <a:solidFill>
-                      <a:srgbClr val="EEF3F8"/>
-                    </a:solidFill>
-                  </a:tcPr>
-                </a:tc>
-              </a:tr>
-              <a:tr h="548640">
-                <a:tc>
-                  <a:txBody>
-                    <a:bodyPr wrap="square"/>
-                    <a:lstStyle/>
-                    <a:p>
-                      <a:r>
-                        <a:rPr b="1" sz="1300">
-                          <a:solidFill>
-                            <a:srgbClr val="1F1F1F"/>
-                          </a:solidFill>
-                        </a:rPr>
-                        <a:t>MOVE</a:t>
-                      </a:r>
-                    </a:p>
-                  </a:txBody>
-                  <a:tcPr marL="73152" marR="73152" marT="27432" marB="27432" anchor="ctr">
-                    <a:solidFill>
-                      <a:srgbClr val="FFFFFF"/>
-                    </a:solidFill>
-                  </a:tcPr>
-                </a:tc>
-                <a:tc>
-                  <a:txBody>
-                    <a:bodyPr wrap="square"/>
-                    <a:lstStyle/>
-                    <a:p>
-                      <a:r>
-                        <a:rPr sz="1300">
-                          <a:solidFill>
-                            <a:srgbClr val="1F1F1F"/>
-                          </a:solidFill>
-                        </a:rPr>
-                        <a:t>10/1 升至 110</a:t>
-                      </a:r>
-                    </a:p>
-                  </a:txBody>
-                  <a:tcPr marL="73152" marR="73152" marT="27432" marB="27432" anchor="ctr">
-                    <a:solidFill>
-                      <a:srgbClr val="FFFFFF"/>
-                    </a:solidFill>
-                  </a:tcPr>
-                </a:tc>
-                <a:tc>
-                  <a:txBody>
-                    <a:bodyPr wrap="square"/>
-                    <a:lstStyle/>
-                    <a:p>
-                      <a:r>
-                        <a:rPr sz="1300">
-                          <a:solidFill>
-                            <a:srgbClr val="1F1F1F"/>
-                          </a:solidFill>
-                        </a:rPr>
-                        <a:t>9/30 110.5、10/1 108.1</a:t>
-                      </a:r>
-                    </a:p>
-                  </a:txBody>
-                  <a:tcPr marL="73152" marR="73152" marT="27432" marB="27432" anchor="ctr">
-                    <a:solidFill>
-                      <a:srgbClr val="FFFFFF"/>
-                    </a:solidFill>
-                  </a:tcPr>
-                </a:tc>
-              </a:tr>
-              <a:tr h="548640">
-                <a:tc>
-                  <a:txBody>
-                    <a:bodyPr wrap="square"/>
-                    <a:lstStyle/>
-                    <a:p>
-                      <a:r>
-                        <a:rPr b="1" sz="1300">
-                          <a:solidFill>
-                            <a:srgbClr val="1F1F1F"/>
-                          </a:solidFill>
-                        </a:rPr>
-                        <a:t>MOVE 前高</a:t>
-                      </a:r>
-                    </a:p>
-                  </a:txBody>
-                  <a:tcPr marL="73152" marR="73152" marT="27432" marB="27432" anchor="ctr">
-                    <a:solidFill>
-                      <a:srgbClr val="EEF3F8"/>
-                    </a:solidFill>
-                  </a:tcPr>
-                </a:tc>
-                <a:tc>
-                  <a:txBody>
-                    <a:bodyPr wrap="square"/>
-                    <a:lstStyle/>
-                    <a:p>
-                      <a:r>
-                        <a:rPr sz="1300">
-                          <a:solidFill>
-                            <a:srgbClr val="1F1F1F"/>
-                          </a:solidFill>
-                        </a:rPr>
-                        <a:t>接近 3 月底高點；2025/4 為 140</a:t>
-                      </a:r>
-                    </a:p>
-                  </a:txBody>
-                  <a:tcPr marL="73152" marR="73152" marT="27432" marB="27432" anchor="ctr">
-                    <a:solidFill>
-                      <a:srgbClr val="EEF3F8"/>
-                    </a:solidFill>
-                  </a:tcPr>
-                </a:tc>
-                <a:tc>
-                  <a:txBody>
-                    <a:bodyPr wrap="square"/>
-                    <a:lstStyle/>
-                    <a:p>
-                      <a:r>
-                        <a:rPr sz="1300">
-                          <a:solidFill>
-                            <a:srgbClr val="1F1F1F"/>
-                          </a:solidFill>
-                        </a:rPr>
-                        <a:t>3/26 115.0；2025/4/8 139.9</a:t>
-                      </a:r>
-                    </a:p>
-                  </a:txBody>
-                  <a:tcPr marL="73152" marR="73152" marT="27432" marB="27432" anchor="ctr">
-                    <a:solidFill>
-                      <a:srgbClr val="EEF3F8"/>
-                    </a:solidFill>
-                  </a:tcPr>
-                </a:tc>
-              </a:tr>
-            </a:tbl>
-          </a:graphicData>
-        </a:graphic>
-      </p:graphicFrame>
-      <p:sp>
-        <p:nvSpPr>
-          <p:cNvPr id="6" name="Rectangle 5"/>
-          <p:cNvSpPr/>
-          <p:nvPr/>
-        </p:nvSpPr>
-        <p:spPr>
-          <a:xfrm>
-            <a:off x="7452360" y="1783080"/>
-            <a:ext cx="4297680" cy="3337560"/>
-          </a:xfrm>
-          <a:prstGeom prst="rect">
-            <a:avLst/>
-          </a:prstGeom>
-          <a:solidFill>
-            <a:srgbClr val="EEF3F8"/>
-          </a:solidFill>
-          <a:ln>
-            <a:noFill/>
-          </a:ln>
-          <a:effectLst/>
-        </p:spPr>
-        <p:style>
-          <a:lnRef idx="1">
-            <a:schemeClr val="accent1"/>
-          </a:lnRef>
-          <a:fillRef idx="3">
-            <a:schemeClr val="accent1"/>
-          </a:fillRef>
-          <a:effectRef idx="2">
-            <a:schemeClr val="accent1"/>
-          </a:effectRef>
-          <a:fontRef idx="minor">
-            <a:schemeClr val="lt1"/>
-          </a:fontRef>
-        </p:style>
-        <p:txBody>
-          <a:bodyPr rtlCol="0" anchor="ctr"/>
-          <a:lstStyle/>
-          <a:p>
-            <a:pPr algn="ctr"/>
-          </a:p>
-        </p:txBody>
-      </p:sp>
-      <p:sp>
-        <p:nvSpPr>
-          <p:cNvPr id="7" name="TextBox 6"/>
-          <p:cNvSpPr txBox="1"/>
-          <p:nvPr/>
-        </p:nvSpPr>
-        <p:spPr>
-          <a:xfrm>
-            <a:off x="7635240" y="1920240"/>
-            <a:ext cx="3977639" cy="3657600"/>
-          </a:xfrm>
-          <a:prstGeom prst="rect">
-            <a:avLst/>
-          </a:prstGeom>
-          <a:noFill/>
-        </p:spPr>
-        <p:txBody>
-          <a:bodyPr wrap="square" lIns="45720" rIns="45720" anchor="t">
-            <a:spAutoFit/>
-          </a:bodyPr>
-          <a:lstStyle/>
-          <a:p>
-            <a:pPr algn="l"/>
-            <a:r>
-              <a:rPr b="1" sz="1700">
-                <a:solidFill>
-                  <a:srgbClr val="234976"/>
-                </a:solidFill>
-              </a:rPr>
-              <a:t>延伸：5–8 月的 IV 低，是因為實際波動也低</a:t>
-            </a:r>
-          </a:p>
-          <a:p>
-            <a:pPr algn="l"/>
-            <a:r>
-              <a:rPr sz="1400">
-                <a:solidFill>
-                  <a:srgbClr val="1F1F1F"/>
-                </a:solidFill>
-              </a:rPr>
-              <a:t>MOVE 平均 73（65–86），約為 2017–2025 年中位數；同期 10Y 實際波動 73，IV − RV ≈ 0。</a:t>
-            </a:r>
-          </a:p>
-          <a:p>
-            <a:pPr algn="l"/>
-            <a:r>
-              <a:rPr sz="600">
-                <a:solidFill>
-                  <a:srgbClr val="1F1F1F"/>
-                </a:solidFill>
-              </a:rPr>
-              <a:t/>
-            </a:r>
-          </a:p>
-          <a:p>
-            <a:pPr algn="l"/>
-            <a:r>
-              <a:rPr sz="1400">
-                <a:solidFill>
-                  <a:srgbClr val="1F1F1F"/>
-                </a:solidFill>
-              </a:rPr>
-              <a:t>10Y 每天平均只動 3.7 bp：上漲是緩慢推進，不是劇烈震盪。</a:t>
-            </a:r>
-          </a:p>
-          <a:p>
-            <a:pPr algn="l"/>
-            <a:r>
-              <a:rPr sz="600">
-                <a:solidFill>
-                  <a:srgbClr val="1F1F1F"/>
-                </a:solidFill>
-              </a:rPr>
-              <a:t/>
-            </a:r>
-          </a:p>
-          <a:p>
-            <a:pPr algn="l"/>
-            <a:r>
-              <a:rPr sz="1400">
-                <a:solidFill>
-                  <a:srgbClr val="1F1F1F"/>
-                </a:solidFill>
-              </a:rPr>
-              <a:t>5 月底到 7 月初，IV 平均落後實際波動 7 bp，呼應「RV 上升、IV 被壓住」的機制。</a:t>
             </a:r>
           </a:p>
         </p:txBody>

</xml_diff>

<commit_message>
Clarify slide 5: TIPS + BEI is the real-vs-inflation split
Co-Authored-By: Claude Opus 5.5 <noreply@anthropic.com>
Claude-Session: https://claude.ai/code/session_01TCy2oBSRDZdisvwwxxfgzX
</commit_message>
<xml_diff>
--- a/slides/2026-10-03_us-treasury-vol-regime-change.pptx
+++ b/slides/2026-10-03_us-treasury-vol-regime-change.pptx
@@ -149,7 +149,7 @@
                   <a:srgbClr val="234976"/>
                 </a:solidFill>
               </a:rPr>
-              <a:t>10Y 殖利率變動拆解（bp）</a:t>
+              <a:t>10Y 變動 ＝ TIPS（實質利率）＋ BEI（通膨預期）（bp）</a:t>
             </a:r>
           </a:p>
         </c:rich>
@@ -54334,7 +54334,7 @@
           <a:p>
             <a:r>
               <a:rPr b="1" sz="1400"/>
-              <a:t>下一步：拆開實質利率</a:t>
+              <a:t>這是第一種拆法：實質 vs. 通膨</a:t>
             </a:r>
           </a:p>
           <a:p>
@@ -54343,7 +54343,7 @@
             </a:pPr>
             <a:r>
               <a:rPr sz="1400"/>
-              <a:t>TIPS 殖利率含實質 TP 與流動性溢酬，接下來用 Kim-Wright 與 DKW 模型把 TP 拆出來。</a:t>
+              <a:t>另一種拆法是預期 vs. TP（第 6–8 頁）。兩者是不同維度：TIPS 本身也含實質 TP，所以「實質利率上升」不代表「不是 TP」。</a:t>
             </a:r>
           </a:p>
         </p:txBody>

</xml_diff>

<commit_message>
Add real-vs-inflation x expectations-vs-TP matrix to slide 6
Co-Authored-By: Claude Opus 5.5 <noreply@anthropic.com>
Claude-Session: https://claude.ai/code/session_01TCy2oBSRDZdisvwwxxfgzX
</commit_message>
<xml_diff>
--- a/slides/2026-10-03_us-treasury-vol-regime-change.pptx
+++ b/slides/2026-10-03_us-treasury-vol-regime-change.pptx
@@ -55012,8 +55012,8 @@
         </p:nvSpPr>
         <p:spPr>
           <a:xfrm>
-            <a:off x="7818120" y="1874519"/>
-            <a:ext cx="3794760" cy="3749039"/>
+            <a:off x="7818120" y="1828800"/>
+            <a:ext cx="3794760" cy="411480"/>
           </a:xfrm>
           <a:prstGeom prst="rect">
             <a:avLst/>
@@ -55028,40 +55028,462 @@
           <a:p>
             <a:pPr algn="l"/>
             <a:r>
-              <a:rPr b="1" sz="1800">
+              <a:rPr b="1" sz="1400">
                 <a:solidFill>
                   <a:srgbClr val="234976"/>
                 </a:solidFill>
               </a:rPr>
-              <a:t>拆解公式</a:t>
-            </a:r>
-          </a:p>
+              <a:t>兩種拆法交叉（今年至 8/31，bp）</a:t>
+            </a:r>
+          </a:p>
+        </p:txBody>
+      </p:sp>
+      <p:graphicFrame>
+        <p:nvGraphicFramePr>
+          <p:cNvPr id="8" name="Table 7"/>
+          <p:cNvGraphicFramePr>
+            <a:graphicFrameLocks noGrp="1"/>
+          </p:cNvGraphicFramePr>
+          <p:nvPr/>
+        </p:nvGraphicFramePr>
+        <p:xfrm>
+          <a:off x="7818120" y="2286000"/>
+          <a:ext cx="3749040" cy="1536192"/>
+        </p:xfrm>
+        <a:graphic>
+          <a:graphicData uri="http://schemas.openxmlformats.org/drawingml/2006/table">
+            <a:tbl>
+              <a:tblPr firstRow="1" bandRow="1">
+                <a:tableStyleId>{5940675A-B579-460E-94D1-54222C63F5DA}</a:tableStyleId>
+              </a:tblPr>
+              <a:tblGrid>
+                <a:gridCol w="1417320"/>
+                <a:gridCol w="777240"/>
+                <a:gridCol w="777240"/>
+                <a:gridCol w="777240"/>
+              </a:tblGrid>
+              <a:tr h="384048">
+                <a:tc>
+                  <a:txBody>
+                    <a:bodyPr wrap="square"/>
+                    <a:lstStyle/>
+                    <a:p>
+                      <a:r>
+                        <a:rPr b="1" sz="1200">
+                          <a:solidFill>
+                            <a:srgbClr val="FFFFFF"/>
+                          </a:solidFill>
+                        </a:rPr>
+                        <a:t>DKW</a:t>
+                      </a:r>
+                    </a:p>
+                  </a:txBody>
+                  <a:tcPr marL="73152" marR="73152" marT="27432" marB="27432" anchor="ctr">
+                    <a:solidFill>
+                      <a:srgbClr val="234976"/>
+                    </a:solidFill>
+                  </a:tcPr>
+                </a:tc>
+                <a:tc>
+                  <a:txBody>
+                    <a:bodyPr wrap="square"/>
+                    <a:lstStyle/>
+                    <a:p>
+                      <a:r>
+                        <a:rPr b="1" sz="1200">
+                          <a:solidFill>
+                            <a:srgbClr val="FFFFFF"/>
+                          </a:solidFill>
+                        </a:rPr>
+                        <a:t>預期</a:t>
+                      </a:r>
+                    </a:p>
+                  </a:txBody>
+                  <a:tcPr marL="73152" marR="73152" marT="27432" marB="27432" anchor="ctr">
+                    <a:solidFill>
+                      <a:srgbClr val="234976"/>
+                    </a:solidFill>
+                  </a:tcPr>
+                </a:tc>
+                <a:tc>
+                  <a:txBody>
+                    <a:bodyPr wrap="square"/>
+                    <a:lstStyle/>
+                    <a:p>
+                      <a:r>
+                        <a:rPr b="1" sz="1200">
+                          <a:solidFill>
+                            <a:srgbClr val="FFFFFF"/>
+                          </a:solidFill>
+                        </a:rPr>
+                        <a:t>TP</a:t>
+                      </a:r>
+                    </a:p>
+                  </a:txBody>
+                  <a:tcPr marL="73152" marR="73152" marT="27432" marB="27432" anchor="ctr">
+                    <a:solidFill>
+                      <a:srgbClr val="234976"/>
+                    </a:solidFill>
+                  </a:tcPr>
+                </a:tc>
+                <a:tc>
+                  <a:txBody>
+                    <a:bodyPr wrap="square"/>
+                    <a:lstStyle/>
+                    <a:p>
+                      <a:r>
+                        <a:rPr b="1" sz="1200">
+                          <a:solidFill>
+                            <a:srgbClr val="FFFFFF"/>
+                          </a:solidFill>
+                        </a:rPr>
+                        <a:t>合計</a:t>
+                      </a:r>
+                    </a:p>
+                  </a:txBody>
+                  <a:tcPr marL="73152" marR="73152" marT="27432" marB="27432" anchor="ctr">
+                    <a:solidFill>
+                      <a:srgbClr val="234976"/>
+                    </a:solidFill>
+                  </a:tcPr>
+                </a:tc>
+              </a:tr>
+              <a:tr h="384048">
+                <a:tc>
+                  <a:txBody>
+                    <a:bodyPr wrap="square"/>
+                    <a:lstStyle/>
+                    <a:p>
+                      <a:r>
+                        <a:rPr b="1" sz="1200">
+                          <a:solidFill>
+                            <a:srgbClr val="1F1F1F"/>
+                          </a:solidFill>
+                        </a:rPr>
+                        <a:t>實質 TIPS</a:t>
+                      </a:r>
+                    </a:p>
+                  </a:txBody>
+                  <a:tcPr marL="73152" marR="73152" marT="27432" marB="27432" anchor="ctr">
+                    <a:solidFill>
+                      <a:srgbClr val="FFFFFF"/>
+                    </a:solidFill>
+                  </a:tcPr>
+                </a:tc>
+                <a:tc>
+                  <a:txBody>
+                    <a:bodyPr wrap="square"/>
+                    <a:lstStyle/>
+                    <a:p>
+                      <a:r>
+                        <a:rPr sz="1200">
+                          <a:solidFill>
+                            <a:srgbClr val="E83F0A"/>
+                          </a:solidFill>
+                        </a:rPr>
+                        <a:t>+25</a:t>
+                      </a:r>
+                    </a:p>
+                  </a:txBody>
+                  <a:tcPr marL="73152" marR="73152" marT="27432" marB="27432" anchor="ctr">
+                    <a:solidFill>
+                      <a:srgbClr val="FFFFFF"/>
+                    </a:solidFill>
+                  </a:tcPr>
+                </a:tc>
+                <a:tc>
+                  <a:txBody>
+                    <a:bodyPr wrap="square"/>
+                    <a:lstStyle/>
+                    <a:p>
+                      <a:r>
+                        <a:rPr sz="1200">
+                          <a:solidFill>
+                            <a:srgbClr val="E83F0A"/>
+                          </a:solidFill>
+                        </a:rPr>
+                        <a:t>+16</a:t>
+                      </a:r>
+                    </a:p>
+                  </a:txBody>
+                  <a:tcPr marL="73152" marR="73152" marT="27432" marB="27432" anchor="ctr">
+                    <a:solidFill>
+                      <a:srgbClr val="FFFFFF"/>
+                    </a:solidFill>
+                  </a:tcPr>
+                </a:tc>
+                <a:tc>
+                  <a:txBody>
+                    <a:bodyPr wrap="square"/>
+                    <a:lstStyle/>
+                    <a:p>
+                      <a:r>
+                        <a:rPr sz="1200">
+                          <a:solidFill>
+                            <a:srgbClr val="E83F0A"/>
+                          </a:solidFill>
+                        </a:rPr>
+                        <a:t>+42</a:t>
+                      </a:r>
+                    </a:p>
+                  </a:txBody>
+                  <a:tcPr marL="73152" marR="73152" marT="27432" marB="27432" anchor="ctr">
+                    <a:solidFill>
+                      <a:srgbClr val="FFFFFF"/>
+                    </a:solidFill>
+                  </a:tcPr>
+                </a:tc>
+              </a:tr>
+              <a:tr h="384048">
+                <a:tc>
+                  <a:txBody>
+                    <a:bodyPr wrap="square"/>
+                    <a:lstStyle/>
+                    <a:p>
+                      <a:r>
+                        <a:rPr b="1" sz="1200">
+                          <a:solidFill>
+                            <a:srgbClr val="1F1F1F"/>
+                          </a:solidFill>
+                        </a:rPr>
+                        <a:t>通膨 BEI</a:t>
+                      </a:r>
+                    </a:p>
+                  </a:txBody>
+                  <a:tcPr marL="73152" marR="73152" marT="27432" marB="27432" anchor="ctr">
+                    <a:solidFill>
+                      <a:srgbClr val="EEF3F8"/>
+                    </a:solidFill>
+                  </a:tcPr>
+                </a:tc>
+                <a:tc>
+                  <a:txBody>
+                    <a:bodyPr wrap="square"/>
+                    <a:lstStyle/>
+                    <a:p>
+                      <a:r>
+                        <a:rPr sz="1200">
+                          <a:solidFill>
+                            <a:srgbClr val="1F1F1F"/>
+                          </a:solidFill>
+                        </a:rPr>
+                        <a:t>+12</a:t>
+                      </a:r>
+                    </a:p>
+                  </a:txBody>
+                  <a:tcPr marL="73152" marR="73152" marT="27432" marB="27432" anchor="ctr">
+                    <a:solidFill>
+                      <a:srgbClr val="EEF3F8"/>
+                    </a:solidFill>
+                  </a:tcPr>
+                </a:tc>
+                <a:tc>
+                  <a:txBody>
+                    <a:bodyPr wrap="square"/>
+                    <a:lstStyle/>
+                    <a:p>
+                      <a:r>
+                        <a:rPr sz="1200">
+                          <a:solidFill>
+                            <a:srgbClr val="1F1F1F"/>
+                          </a:solidFill>
+                        </a:rPr>
+                        <a:t>+4</a:t>
+                      </a:r>
+                    </a:p>
+                  </a:txBody>
+                  <a:tcPr marL="73152" marR="73152" marT="27432" marB="27432" anchor="ctr">
+                    <a:solidFill>
+                      <a:srgbClr val="EEF3F8"/>
+                    </a:solidFill>
+                  </a:tcPr>
+                </a:tc>
+                <a:tc>
+                  <a:txBody>
+                    <a:bodyPr wrap="square"/>
+                    <a:lstStyle/>
+                    <a:p>
+                      <a:r>
+                        <a:rPr sz="1200">
+                          <a:solidFill>
+                            <a:srgbClr val="1F1F1F"/>
+                          </a:solidFill>
+                        </a:rPr>
+                        <a:t>+16</a:t>
+                      </a:r>
+                    </a:p>
+                  </a:txBody>
+                  <a:tcPr marL="73152" marR="73152" marT="27432" marB="27432" anchor="ctr">
+                    <a:solidFill>
+                      <a:srgbClr val="EEF3F8"/>
+                    </a:solidFill>
+                  </a:tcPr>
+                </a:tc>
+              </a:tr>
+              <a:tr h="384048">
+                <a:tc>
+                  <a:txBody>
+                    <a:bodyPr wrap="square"/>
+                    <a:lstStyle/>
+                    <a:p>
+                      <a:r>
+                        <a:rPr b="1" sz="1200">
+                          <a:solidFill>
+                            <a:srgbClr val="1F1F1F"/>
+                          </a:solidFill>
+                        </a:rPr>
+                        <a:t>合計</a:t>
+                      </a:r>
+                    </a:p>
+                  </a:txBody>
+                  <a:tcPr marL="73152" marR="73152" marT="27432" marB="27432" anchor="ctr">
+                    <a:solidFill>
+                      <a:srgbClr val="FFFFFF"/>
+                    </a:solidFill>
+                  </a:tcPr>
+                </a:tc>
+                <a:tc>
+                  <a:txBody>
+                    <a:bodyPr wrap="square"/>
+                    <a:lstStyle/>
+                    <a:p>
+                      <a:r>
+                        <a:rPr sz="1200">
+                          <a:solidFill>
+                            <a:srgbClr val="1F1F1F"/>
+                          </a:solidFill>
+                        </a:rPr>
+                        <a:t>+37</a:t>
+                      </a:r>
+                    </a:p>
+                  </a:txBody>
+                  <a:tcPr marL="73152" marR="73152" marT="27432" marB="27432" anchor="ctr">
+                    <a:solidFill>
+                      <a:srgbClr val="FFFFFF"/>
+                    </a:solidFill>
+                  </a:tcPr>
+                </a:tc>
+                <a:tc>
+                  <a:txBody>
+                    <a:bodyPr wrap="square"/>
+                    <a:lstStyle/>
+                    <a:p>
+                      <a:r>
+                        <a:rPr sz="1200">
+                          <a:solidFill>
+                            <a:srgbClr val="1F1F1F"/>
+                          </a:solidFill>
+                        </a:rPr>
+                        <a:t>+20</a:t>
+                      </a:r>
+                    </a:p>
+                  </a:txBody>
+                  <a:tcPr marL="73152" marR="73152" marT="27432" marB="27432" anchor="ctr">
+                    <a:solidFill>
+                      <a:srgbClr val="FFFFFF"/>
+                    </a:solidFill>
+                  </a:tcPr>
+                </a:tc>
+                <a:tc>
+                  <a:txBody>
+                    <a:bodyPr wrap="square"/>
+                    <a:lstStyle/>
+                    <a:p>
+                      <a:r>
+                        <a:rPr sz="1200">
+                          <a:solidFill>
+                            <a:srgbClr val="1F1F1F"/>
+                          </a:solidFill>
+                        </a:rPr>
+                        <a:t>+57</a:t>
+                      </a:r>
+                    </a:p>
+                  </a:txBody>
+                  <a:tcPr marL="73152" marR="73152" marT="27432" marB="27432" anchor="ctr">
+                    <a:solidFill>
+                      <a:srgbClr val="FFFFFF"/>
+                    </a:solidFill>
+                  </a:tcPr>
+                </a:tc>
+              </a:tr>
+            </a:tbl>
+          </a:graphicData>
+        </a:graphic>
+      </p:graphicFrame>
+      <p:sp>
+        <p:nvSpPr>
+          <p:cNvPr id="9" name="TextBox 8"/>
+          <p:cNvSpPr txBox="1"/>
+          <p:nvPr/>
+        </p:nvSpPr>
+        <p:spPr>
+          <a:xfrm>
+            <a:off x="7818120" y="3931920"/>
+            <a:ext cx="3794760" cy="1691640"/>
+          </a:xfrm>
+          <a:prstGeom prst="rect">
+            <a:avLst/>
+          </a:prstGeom>
+          <a:noFill/>
+        </p:spPr>
+        <p:txBody>
+          <a:bodyPr wrap="square" lIns="45720" rIns="45720" anchor="t">
+            <a:spAutoFit/>
+          </a:bodyPr>
+          <a:lstStyle/>
           <a:p>
             <a:pPr algn="l"/>
             <a:r>
-              <a:rPr b="1" sz="1400">
+              <a:rPr b="1" sz="1200">
                 <a:solidFill>
                   <a:srgbClr val="0065B2"/>
                 </a:solidFill>
               </a:rPr>
-              <a:t>Kim-Wright</a:t>
+              <a:t>橫列 ＝ 拆法一：</a:t>
+            </a:r>
+            <a:r>
+              <a:rPr sz="1200">
+                <a:solidFill>
+                  <a:srgbClr val="1F1F1F"/>
+                </a:solidFill>
+              </a:rPr>
+              <a:t>實質 vs. 通膨（TIPS ＋ BEI，第 5 頁）</a:t>
             </a:r>
           </a:p>
           <a:p>
             <a:pPr algn="l"/>
             <a:r>
-              <a:rPr sz="1400">
+              <a:rPr b="1" sz="1200">
+                <a:solidFill>
+                  <a:srgbClr val="0065B2"/>
+                </a:solidFill>
+              </a:rPr>
+              <a:t>直欄 ＝ 拆法二：</a:t>
+            </a:r>
+            <a:r>
+              <a:rPr sz="1200">
                 <a:solidFill>
                   <a:srgbClr val="1F1F1F"/>
                 </a:solidFill>
               </a:rPr>
-              <a:t>10Y 殖利率 ＝ 預期平均短率 ＋ 名目 TP</a:t>
+              <a:t>預期 vs. TP（KW 只拆到這一層）</a:t>
             </a:r>
           </a:p>
           <a:p>
             <a:pPr algn="l"/>
             <a:r>
-              <a:rPr sz="800">
+              <a:rPr b="1" sz="1200">
+                <a:solidFill>
+                  <a:srgbClr val="1F1F1F"/>
+                </a:solidFill>
+              </a:rPr>
+              <a:t>TIPS 本身含實質 TP：實質利率上升裡近四成是 TP。</a:t>
+            </a:r>
+          </a:p>
+          <a:p>
+            <a:pPr algn="l"/>
+            <a:r>
+              <a:rPr sz="600">
                 <a:solidFill>
                   <a:srgbClr val="1F1F1F"/>
                 </a:solidFill>
@@ -55072,111 +55494,12 @@
           <a:p>
             <a:pPr algn="l"/>
             <a:r>
-              <a:rPr b="1" sz="1400">
-                <a:solidFill>
-                  <a:srgbClr val="0065B2"/>
+              <a:rPr sz="1000">
+                <a:solidFill>
+                  <a:srgbClr val="595959"/>
                 </a:solidFill>
               </a:rPr>
-              <a:t>DKW</a:t>
-            </a:r>
-          </a:p>
-          <a:p>
-            <a:pPr algn="l"/>
-            <a:r>
-              <a:rPr sz="1400">
-                <a:solidFill>
-                  <a:srgbClr val="1F1F1F"/>
-                </a:solidFill>
-              </a:rPr>
-              <a:t>10Y 殖利率 ＝ 預期實質短率 ＋ 實質 TP</a:t>
-            </a:r>
-          </a:p>
-          <a:p>
-            <a:pPr algn="l"/>
-            <a:r>
-              <a:rPr sz="1400">
-                <a:solidFill>
-                  <a:srgbClr val="1F1F1F"/>
-                </a:solidFill>
-              </a:rPr>
-              <a:t>　　　　　＋ 預期通膨 ＋ 通膨風險溢酬</a:t>
-            </a:r>
-          </a:p>
-          <a:p>
-            <a:pPr algn="l"/>
-            <a:r>
-              <a:rPr sz="1400">
-                <a:solidFill>
-                  <a:srgbClr val="1F1F1F"/>
-                </a:solidFill>
-              </a:rPr>
-              <a:t>TIPS 殖利率 ＝ 預期實質短率 ＋ 實質 TP</a:t>
-            </a:r>
-          </a:p>
-          <a:p>
-            <a:pPr algn="l"/>
-            <a:r>
-              <a:rPr sz="1400">
-                <a:solidFill>
-                  <a:srgbClr val="1F1F1F"/>
-                </a:solidFill>
-              </a:rPr>
-              <a:t>　　　　　＋ 流動性溢酬</a:t>
-            </a:r>
-          </a:p>
-          <a:p>
-            <a:pPr algn="l"/>
-            <a:r>
-              <a:rPr sz="1400">
-                <a:solidFill>
-                  <a:srgbClr val="1F1F1F"/>
-                </a:solidFill>
-              </a:rPr>
-              <a:t>BEI ＝ 預期通膨 ＋ 通膨風險溢酬</a:t>
-            </a:r>
-          </a:p>
-          <a:p>
-            <a:pPr algn="l"/>
-            <a:r>
-              <a:rPr sz="1400">
-                <a:solidFill>
-                  <a:srgbClr val="1F1F1F"/>
-                </a:solidFill>
-              </a:rPr>
-              <a:t>　　　 − 流動性溢酬</a:t>
-            </a:r>
-          </a:p>
-          <a:p>
-            <a:pPr algn="l"/>
-            <a:r>
-              <a:rPr b="1" sz="1400">
-                <a:solidFill>
-                  <a:srgbClr val="1F1F1F"/>
-                </a:solidFill>
-              </a:rPr>
-              <a:t>名目 TP ＝ 實質 TP ＋ 通膨風險溢酬</a:t>
-            </a:r>
-          </a:p>
-          <a:p>
-            <a:pPr algn="l"/>
-            <a:r>
-              <a:rPr sz="800">
-                <a:solidFill>
-                  <a:srgbClr val="1F1F1F"/>
-                </a:solidFill>
-              </a:rPr>
-              <a:t/>
-            </a:r>
-          </a:p>
-          <a:p>
-            <a:pPr algn="l"/>
-            <a:r>
-              <a:rPr sz="1200">
-                <a:solidFill>
-                  <a:srgbClr val="595959"/>
-                </a:solidFill>
-              </a:rPr>
-              <a:t>兩者都出自 Fed 的 Don Kim，並非完全獨立；紐約 Fed 的 ACM 方法不同，可做交叉驗證。</a:t>
+              <a:t>TIPS、BEI 另含流動性溢酬（+2 bp）；各格四捨五入，加總可能差 1 bp。兩模型都出自 Fed 的 Don Kim，紐約 Fed 的 ACM 方法不同，可做交叉驗證。</a:t>
             </a:r>
           </a:p>
         </p:txBody>

</xml_diff>